<commit_message>
refactor: v66 pptx builder consumes lib/theme as single source; JSZip local-first (E3 closure)
</commit_message>
<xml_diff>
--- a/work/备课/选择性必修下册/氓/_v62_stage/v66/pptx/04_氓_V66逐页功能重构_81状态无插图逐字稿_V5.pptx
+++ b/work/备课/选择性必修下册/氓/_v62_stage/v66/pptx/04_氓_V66逐页功能重构_81状态无插图逐字稿_V5.pptx
@@ -624,15 +624,15 @@
 【可见产物】
 时间封存的个人文学回忆单
 【教师作用】
-准确释词、引用真实回答、追问原词、后置归纳并守住解释边界。
+本页教师零供给：不报任何篇名与主题词，退到后排巡视只确认个人非空白；公共声音出现前不归纳、不举例；封存指令后才转场。
 【真实等待】
-逐字稿内有首答等待、限定反馈和本人修订的明确时间。
+台词明示“安静两分半”（时间盒：说明45秒/个人静默检索165秒/补写与封存60秒/转场30秒）；检索期间教师零插话，封存动作（翻面一瞬）真实发生。
 【反馈与本人修订】
-学生依据原词、同伴追问或教师校准，亲自保留、补充、改写或撤回初稿。
+本页为个人封存页，无反馈修订环节；补记发生在 O02——听见自己没想到的篇目时当场添进个人清单。
 【首次后用】
 O02同桌轮说和公共增量
 【正常反例】
-想不起、无新增、已经准确、不同意或暂时沉默均有诚实完成路径，不要求伪造改变。
+想不起→翻本班读过的篇目目录（台词已授权）；只记得情节→先留真实情节；主题拿不准→写“还说不准”，不借同桌答案补抄。
 【主视觉职责】
 一张真正可以落笔的文学记忆纸
 【插图资格】
@@ -640,7 +640,7 @@
 【第一人称接收】
 我从自己的阅读经历中想起了作品、故事和一个朴素主题；这些不是老师替我列出的。
 【故事回接】
-页面结束前由一句自然复述回到谁做了什么、人物处境怎样变化以及故事推进到哪里。
+本页未入《氓》叙事；回接为：每人手里先有了一点自己的爱情/婚姻故事记忆，O02 将其长成全班文学版图，成为后文对照《氓》的底色（S06 回望时取回）。
 【删除损失】
 多数学生失去独立检索时间，公共发言被快想者占据。
 【相邻反证】
@@ -762,7 +762,7 @@
 【前页输入】
 前三章已经连续响过，朗读不因换页停止。
 【唯一困难】
-学生容易看见“《氓》第四至第六章的完整声音及全诗结尾”，却不能把它准确接回人物和前后故事。
+后三章情绪急转（劳苦、受暴、决绝），困难是让声音把转折带完而不被提前解释；“亦已焉哉”需要完整落下的空间。
 【唯一功能】
 无缝接收第四至六章并让末句落下。
 【文学对象】
@@ -772,33 +772,33 @@
 【学生主动作】
 继续听读；末句后确认停点
 【参与路径】
-个人先形成；需要交流时并行同桌或四人轮说；全班只公开少量有差异材料。
+继续个人静听；末句后默数自己的停点数（为 O07 选句做准备），无交流环节。
 【可见产物】
 教材停点
 【教师作用】
-准确释词、引用真实回答、追问原词、后置归纳并守住解释边界。
+延续同一朗读声不换节奏；末句后完全静默切页，绝不接“这首诗表达了……”式总结。
 【真实等待】
-逐字稿内有首答等待、限定反馈和本人修订的明确时间。
+三分钟连续朗读零插话；末句后停顿至切页句出现，期间教师零语言。
 【反馈与本人修订】
-学生依据原词、同伴追问或教师校准，亲自保留、补充、改写或撤回初稿。
+本页无修订；停点在下一页转化为初听卡文字。
 【首次后用】
 O07取回
 【正常反例】
-想不起、无新增、已经准确、不同意或暂时沉默均有诚实完成路径，不要求伪造改变。
+无停点的学生等末句落下即可，不强制造句；跟不上朗读速度的学生听完全程即算完成。
 【主视觉职责】
 第四至六章原诗
 【插图资格】
 无
 【第一人称接收】
-我刚才面对“《氓》第四至第六章的完整声音及全诗结尾”，留下了教材停点；我能用原词说清自己新增或修正的理解。
+我听完了全诗六章；末句落下后，我能指出一句最留住我的句子，并知道它在第几章。
 【故事回接】
-页面结束前由一句自然复述回到谁做了什么、人物处境怎样变化以及故事推进到哪里。
+声音层面完成婚变→决绝；切页句把全诗第一次完整经历交给学生：“把第一次听见的《氓》，留在纸上”。
 【删除损失】
 删除会把全诗压成婚前故事
 【相邻反证】
-相邻页不同时处理“学生容易看见“《氓》第四至第六章的完整声音及全诗结尾”，却不能把它准确接回人物和前后故事。”；合并会挤掉必要首答、校准或故事回接。
+与 O05 合并则一次首读的物理承接与换气点消失；与 O07 合并则末句落下后的静默书写被挤掉——三页各承担“声音上半/声音下半/起点文字化”。
 【失败信号】
-学生只能复述活动手续，不能复述诗意；首答前已经看见完成关系或答案；产物在后页没有真实消费者
+末句后教师立即总结主题；后半朗读节奏与前半不一致（声音断裂）；学生被要求当场分享停点（应留到O07）
 【声明边界】V5无插图桌面候选；不声称真实课堂或学生掌握已经通过。</a:t>
             </a:r>
             <a:endParaRPr lang="en-US" dirty="0"/>
@@ -914,27 +914,27 @@
 六章已经完整地响过，大家停下的地方也留在这里。现在我们把这首诗慢慢读懂。
 【V6.6逻辑页】O07｜逻辑页7｜4分钟
 【前页输入】
-学生已经完成前页任务，手中保留与“学生在六章完整声音中的个人停顿句、画面、声音或问题”有关的原词或初稿。
+六章声音已完整响过（O05-O06）；每人教材上留有自己的停点标记；初听卡此刻才发放（真实分发时点）。
 【唯一困难】
-学生容易看见“学生在六章完整声音中的个人停顿句、画面、声音或问题”，却不能把它准确接回人物和前后故事。
+三问一旦先出现，学生的“第一句”会被问题塑形；困难是保护“第一次真正听见”的个人起点不被任务覆盖。
 【唯一功能】
 保存每个人第一次真正听见的句子，不让三问覆盖个人起点。
 【文学对象】
 学生在六章完整声音中的个人停顿句、画面、声音或问题
 【信息状态】
-首答前只给原诗、必要字面和一个自然问题；解释、分类、关系与代表答案在学生首稿后出现。
+三问尚未出现；卡片此刻发放（登记首次可见）；教师不示范“好的初听句”，黑板右侧只承载学生真实文字。
 【学生主动作】
 抄下一句；接写我看见、听见或想问
 【参与路径】
-个人先形成；需要交流时并行同桌或四人轮说；全班只公开少量有差异材料。
+个人静写55秒→同桌各说一次（听者不评深浅只补漏）→全班仅由教师在 O08 引用、不展评。
 【可见产物】
 个人初听卡
 【教师作用】
-准确释词、引用真实回答、追问原词、后置归纳并守住解释边界。
+巡视确认非空白但不评价句子深浅；不补造、不给“标准停点”；引用推迟到 O08 且只用真实文字。
 【真实等待】
-逐字稿内有首答等待、限定反馈和本人修订的明确时间。
+静默书写55秒（台词明示）；同桌互说限时一轮；教师巡视零插话。
 【反馈与本人修订】
-学生依据原词、同伴追问或教师校准，亲自保留、补充、改写或撤回初稿。
+听同桌说完后可补换自己的句子（“再决定要不要补”）——修订动作即换句重写，卡上保留原句痕迹。
 【首次后用】
 O08引用
 【正常反例】
@@ -944,15 +944,15 @@
 【插图资格】
 无
 【第一人称接收】
-我刚才面对“学生在六章完整声音中的个人停顿句、画面、声音或问题”，留下了个人初听卡；我能用原词说清自己新增或修正的理解。
+我抄下了一句真正留住我的诗，并接了一句“我看见/听见/想问”的自然话；这是我自己的起点，不是老师期待的那一句。
 【故事回接】
-页面结束前由一句自然复述回到谁做了什么、人物处境怎样变化以及故事推进到哪里。
+初听卡是学生与这首诗关系的起点句；S06 综合页将回望“第一次停在哪里，现在停在哪里”。
 【删除损失】
 删除会失去真实接收起点
 【相邻反证】
-相邻页不同时处理“学生容易看见“学生在六章完整声音中的个人停顿句、画面、声音或问题”，却不能把它准确接回人物和前后故事。”；合并会挤掉必要首答、校准或故事回接。
+O08 的三问必须在本页之后出现——若合并，问题先于个人起点进入，保护失效；本页55秒静默书写也因此被挤掉。
 【失败信号】
-学生只能复述活动手续，不能复述诗意；首答前已经看见完成关系或答案；产物在后页没有真实消费者
+教师展示了示范句；三问提前出现在卡片上；学生抄的是邻座的句子而非自己的停点
 【声明边界】V5无插图桌面候选；不声称真实课堂或学生掌握已经通过。</a:t>
             </a:r>
             <a:endParaRPr lang="en-US" dirty="0"/>
@@ -1069,7 +1069,7 @@
 【前页输入】
 全诗已经完整听过，个人初见也已保存。
 【唯一困难】
-学生容易看见“在完整听读和学生初听文字之后出现的经历、不幸表现与婚姻原因三个问题”，却不能把它准确接回人物和前后故事。
+问题若由教师直接布置即成外部任务；困难是让三问从学生的初听文字中长出来，并立即成为全课导航而不被抢答消耗。
 【唯一功能】
 把三问变成读后生成的全文导航：先讲经历，再看生活，最后追原因。
 【文学对象】
@@ -1079,15 +1079,15 @@
 【学生主动作】
 保存三问；暂不抢答
 【参与路径】
-个人先形成；需要交流时并行同桌或四人轮说；全班只公开少量有差异材料。
+全班接收三问并保存书签；教师引用初听文字时被引用者确认；明示“暂不抢答”，无讨论环节。
 【可见产物】
 三问书签
 【教师作用】
-准确释词、引用真实回答、追问原词、后置归纳并守住解释边界。
+只引用 O07 黑板右侧真实文字、不补造；设问后不给出任何方向性提示或示例答案。
 【真实等待】
-逐字稿内有首答等待、限定反馈和本人修订的明确时间。
+引用—设问—保存书签共2分钟；设问后停顿即切页，不留答问时间（时间盒明示）。
 【反馈与本人修订】
-学生依据原词、同伴追问或教师校准，亲自保留、补充、改写或撤回初稿。
+本页无修订；书签在 S02-S04 被逐问回收时完成首尾呼应。
 【首次后用】
 六章积证并由S02—S04回收
 【正常反例】
@@ -1097,15 +1097,15 @@
 【插图资格】
 无
 【第一人称接收】
-我刚才面对“在完整听读和学生初听文字之后出现的经历、不幸表现与婚姻原因三个问题”，留下了三问书签；我能用原词说清自己新增或修正的理解。
+我知道了接下来要回答的三个问题；黑板上引用的某句初听文字（可能是我写的）成了问题的起点，我的起点被留在了全课里。
 【故事回接】
-页面结束前由一句自然复述回到谁做了什么、人物处境怎样变化以及故事推进到哪里。
+三问即叙事导航：经历（她经历了什么）→生活（婚后的不幸是什么样子）→原因（婚姻为什么走到这一步）；切页句回到“从第一章慢慢读起”。
 【删除损失】
 删除后细读缺少共同方向
 【相邻反证】
-相邻页不同时处理“学生容易看见“在完整听读和学生初听文字之后出现的经历、不幸表现与婚姻原因三个问题”，却不能把它准确接回人物和前后故事。”；合并会挤掉必要首答、校准或故事回接。
+本页2分钟只设问不展开；并入 O07 会挤掉静默书写；三问书签此后贯穿六章积证并由 S02-S04 逐问回收，不可省略。
 【失败信号】
-学生只能复述活动手续，不能复述诗意；首答前已经看见完成关系或答案；产物在后页没有真实消费者
+教师对三问给出示例答案；引用的初听文字不在黑板上（补造）；三问措辞与 S02-S04 回收页不一致
 【声明边界】V5无插图桌面候选；不声称真实课堂或学生掌握已经通过。</a:t>
             </a:r>
             <a:endParaRPr lang="en-US" dirty="0"/>
@@ -1221,45 +1221,45 @@
 先看第一处：诗让我们先看见他做什么，女子随后又告诉我们什么？
 【V6.6逻辑页】C101｜逻辑页9｜5分钟
 【前页输入】
-学生已经完成前页任务，手中保留与“氓之蚩蚩，抱布贸丝。匪来贸丝，来即我谋。送子涉淇，至于顿丘。匪我愆期，子无良媒。将子无怒，秋以为期。”有关的原词或初稿。
+三问书签已保存（O08）；学生知道这是女子回头讲婚姻；尚未逐句读过第一章，行动初稿为空。
 【唯一困难】
-学生容易看见“氓之蚩蚩，抱布贸丝。匪来贸丝，来即我谋。送子涉淇，至于顿丘。匪我愆期，子无良媒。将子无怒，秋以为期。”，却不能把它准确接回人物和前后故事。
+学生易把第一章当“译文对号”逐句翻；困难是同时用两套标记（圈男子动作／划女子动作）看清“谁在动”——第一人称回望里两个人物的行动易被混成一段流水。
 【唯一功能】
 让第一章完整进入，并确认女子怎样用第一人称讲两个人的行动。
 【文学对象】
 氓之蚩蚩，抱布贸丝。匪来贸丝，来即我谋。送子涉淇，至于顿丘。匪我愆期，子无良媒。将子无怒，秋以为期。
 【信息状态】
-首答前只给原诗、必要字面和一个自然问题；解释、分类、关系与代表答案在学生首稿后出现。
+首读态只有原诗与两套标记要求；词义校准、叙事分析与主题词均不出现（延迟到 C102 起）。
 【学生主动作】
 完整读章；圈男子动作、划女子动作
 【参与路径】
-个人先形成；需要交流时并行同桌或四人轮说；全班只公开少量有差异材料。
+教师听读→个人完整朗读并圈划（94秒）→同桌核对行动主体（56秒）→两条现场分享；无代表制。
 【可见产物】
 第一章行动初稿
 【教师作用】
-准确释词、引用真实回答、追问原词、后置归纳并守住解释边界。
+完整听读承载章的声音；巡视确认两类标记共存；收束只引用学生现场两条原话，不预告词义。
 【真实等待】
-逐字稿内有首答等待、限定反馈和本人修订的明确时间。
+时间盒明示：听读69秒→个人朗读圈划94秒→同桌核对56秒→现场分享与修订56秒；圈划期间零插话。
 【反馈与本人修订】
-学生依据原词、同伴追问或教师校准，亲自保留、补充、改写或撤回初稿。
+同桌核对后用另一色笔改标记归属（“这句其实是她做的”）；现场分享后各自回诗修订。
 【首次后用】
 C102—C104
 【正常反例】
-想不起、无新增、已经准确、不同意或暂时沉默均有诚实完成路径，不要求伪造改变。
+归属分不清的句子先画“？”保留不硬归；读不完的学生跟读完成即算。
 【主视觉职责】
 整章原诗与圈划
 【插图资格】
 无
 【第一人称接收】
-我刚才面对“氓之蚩蚩，抱布贸丝。匪来贸丝，来即我谋。送子涉淇，至于顿丘。匪我愆期，子无良媒。将子无怒，秋以为期。”，留下了第一章行动初稿；我能用原词说清自己新增或修正的理解。
+我完整读了第一章并留下两类标记；我能指着一处说“这是他做的／这是她做的”，且知道这是她自己在讲。
 【故事回接】
-页面结束前由一句自然复述回到谁做了什么、人物处境怎样变化以及故事推进到哪里。
+第一章作为故事被完整接收：他来（抱布贸丝／来即我谋）→她送（送子涉淇）→两人约（秋以为期）；切页句指向第一处细读。
 【删除损失】
 删除会使逐句讲解没有整章轮廓
 【相邻反证】
-相邻页不同时处理“学生容易看见“氓之蚩蚩，抱布贸丝。匪来贸丝，来即我谋。送子涉淇，至于顿丘。匪我愆期，子无良媒。将子无怒，秋以为期。”，却不能把它准确接回人物和前后故事。”；合并会挤掉必要首答、校准或故事回接。
+C102-C104 才逐句细读；本页若拆句讲解，“完整进入一章”的整读功能即失，C105 合书重建也失去整读底子。
 【失败信号】
-学生只能复述活动手续，不能复述诗意；首答前已经看见完成关系或答案；产物在后页没有真实消费者
+整读被拆成逐句翻译；标记只圈了一方人物；首读态教师报出词义或主题
 【声明边界】V5无插图桌面候选；不声称真实课堂或学生掌握已经通过。</a:t>
             </a:r>
             <a:endParaRPr lang="en-US" dirty="0"/>
@@ -1373,9 +1373,9 @@
 你们已经各自圈过。现在只比较真实分歧。
 【V6.6逻辑页】C102｜逻辑页10｜5分钟
 【前页输入】
-学生已经完成前页任务，手中保留与“氓之蚩蚩，抱布贸丝。匪来贸丝，来即我谋。”有关的原词或初稿。
+行动初稿已留两类标记（C101）；学生知道第一章完整故事，尚未逐词面对首两句。
 【唯一困难】
-学生容易看见“氓之蚩蚩，抱布贸丝。匪来贸丝，来即我谋。”，却不能把它准确接回人物和前后故事。
+“抱布贸丝”极易读成做生意，“匪”受现代义干扰；困难是靠重复的“贸丝”与“匪—谋”转折自己读出“来意不在丝”，而非接受教师直译。
 【唯一功能】
 从重复的‘贸丝’和‘匪—谋’读出叙事转弯，校准首句易误词，并守住初见证据边界。
 【文学对象】
@@ -1385,31 +1385,31 @@
 【学生主动作】
 自然口译并圈出转折字；把氓、蚩蚩、布、贸、即、谋送回原句
 【参与路径】
-个人先形成；需要交流时并行同桌或四人轮说；全班只公开少量有差异材料。
+个人自然口译58秒→双人分读互核42秒→分享与定点释义79秒→个人修订54秒；全部个人先行。
 【可见产物】
 叙事转弯句和首句词义旁批
 【教师作用】
-准确释词、引用真实回答、追问原词、后置归纳并守住解释边界。
+巡视不提示；分享后定点释义氓／蚩蚩／布／贸／即／谋并送回原句；守住初见证据边界，不为氓贴性格标签。
 【真实等待】
-逐字稿内有首答等待、限定反馈和本人修订的明确时间。
+时间盒明示：读题25秒→个人口译58秒（台词“安静七十秒”内含）→双人42秒→释义79秒→修订54秒→回诗42秒；口译期间屏幕无译文。
 【反馈与本人修订】
-学生依据原词、同伴追问或教师校准，亲自保留、补充、改写或撤回初稿。
+定点释义后回原句亲手改自己的自然话与转折字圈选；边界项（无怒等）在修订段处理。
 【首次后用】
 C105与C503
 【正常反例】
-想不起、无新增、已经准确、不同意或暂时沉默均有诚实完成路径，不要求伪造改变。
+说不完整先写“谁做了什么”（台词已授权）；猜错词义如实保留原猜测供对照。
 【主视觉职责】
 原词转弯
 【插图资格】
 I01待A/B
 【第一人称接收】
-我刚才面对“氓之蚩蚩，抱布贸丝。匪来贸丝，来即我谋。”，留下了叙事转弯句和首句词义旁批；我能用原词说清自己新增或修正的理解。
+我把首两句说成了一句自然话，圈出让意思转过去的字（匪／谋）；揭示后我能说清自己原以为“贸丝”是什么、差在哪。
 【故事回接】
-页面结束前由一句自然复述回到谁做了什么、人物处境怎样变化以及故事推进到哪里。
+他抱布的名义下是“来即我谋”——初见即有来意；切页句“诗不写一句她很投入，只让三个动词把一段路铺开”引出 C103。
 【删除损失】
 首句会被压成‘男子来求婚’的结论，叙事转弯、词义异说和证据边界同时丢失。
 【相邻反证】
-相邻页不同时处理“学生容易看见“氓之蚩蚩，抱布贸丝。匪来贸丝，来即我谋。”，却不能把它准确接回人物和前后故事。”；合并会挤掉必要首答、校准或故事回接。
+C103 只处理“送子涉淇”的空间感；若并入本页，两句词义＋一句空间共三重任务超出单页负荷（A-T22）。
 【失败信号】
 屏幕标出‘表面动作／真实来意’答案；学生看图猜人格；教师在首答前解释匪—谋关系
 【声明边界】V5无插图桌面候选；不声称真实课堂或学生掌握已经通过。</a:t>
@@ -1525,9 +1525,9 @@
 转弯已经被看见，接下来把它说准确。
 【V6.6逻辑页】C102｜逻辑页10｜5分钟
 【前页输入】
-学生已经完成前页任务，手中保留与“氓之蚩蚩，抱布贸丝。匪来贸丝，来即我谋。”有关的原词或初稿。
+行动初稿已留两类标记（C101）；学生知道第一章完整故事，尚未逐词面对首两句。
 【唯一困难】
-学生容易看见“氓之蚩蚩，抱布贸丝。匪来贸丝，来即我谋。”，却不能把它准确接回人物和前后故事。
+“抱布贸丝”极易读成做生意，“匪”受现代义干扰；困难是靠重复的“贸丝”与“匪—谋”转折自己读出“来意不在丝”，而非接受教师直译。
 【唯一功能】
 从重复的‘贸丝’和‘匪—谋’读出叙事转弯，校准首句易误词，并守住初见证据边界。
 【文学对象】
@@ -1537,31 +1537,31 @@
 【学生主动作】
 自然口译并圈出转折字；把氓、蚩蚩、布、贸、即、谋送回原句
 【参与路径】
-个人先形成；需要交流时并行同桌或四人轮说；全班只公开少量有差异材料。
+个人自然口译58秒→双人分读互核42秒→分享与定点释义79秒→个人修订54秒；全部个人先行。
 【可见产物】
 叙事转弯句和首句词义旁批
 【教师作用】
-准确释词、引用真实回答、追问原词、后置归纳并守住解释边界。
+巡视不提示；分享后定点释义氓／蚩蚩／布／贸／即／谋并送回原句；守住初见证据边界，不为氓贴性格标签。
 【真实等待】
-逐字稿内有首答等待、限定反馈和本人修订的明确时间。
+时间盒明示：读题25秒→个人口译58秒（台词“安静七十秒”内含）→双人42秒→释义79秒→修订54秒→回诗42秒；口译期间屏幕无译文。
 【反馈与本人修订】
-学生依据原词、同伴追问或教师校准，亲自保留、补充、改写或撤回初稿。
+定点释义后回原句亲手改自己的自然话与转折字圈选；边界项（无怒等）在修订段处理。
 【首次后用】
 C105与C503
 【正常反例】
-想不起、无新增、已经准确、不同意或暂时沉默均有诚实完成路径，不要求伪造改变。
+说不完整先写“谁做了什么”（台词已授权）；猜错词义如实保留原猜测供对照。
 【主视觉职责】
 原词转弯
 【插图资格】
 I01待A/B
 【第一人称接收】
-我刚才面对“氓之蚩蚩，抱布贸丝。匪来贸丝，来即我谋。”，留下了叙事转弯句和首句词义旁批；我能用原词说清自己新增或修正的理解。
+我把首两句说成了一句自然话，圈出让意思转过去的字（匪／谋）；揭示后我能说清自己原以为“贸丝”是什么、差在哪。
 【故事回接】
-页面结束前由一句自然复述回到谁做了什么、人物处境怎样变化以及故事推进到哪里。
+他抱布的名义下是“来即我谋”——初见即有来意；切页句“诗不写一句她很投入，只让三个动词把一段路铺开”引出 C103。
 【删除损失】
 首句会被压成‘男子来求婚’的结论，叙事转弯、词义异说和证据边界同时丢失。
 【相邻反证】
-相邻页不同时处理“学生容易看见“氓之蚩蚩，抱布贸丝。匪来贸丝，来即我谋。”，却不能把它准确接回人物和前后故事。”；合并会挤掉必要首答、校准或故事回接。
+C103 只处理“送子涉淇”的空间感；若并入本页，两句词义＋一句空间共三重任务超出单页负荷（A-T22）。
 【失败信号】
 屏幕标出‘表面动作／真实来意’答案；学生看图猜人格；教师在首答前解释匪—谋关系
 【声明边界】V5无插图桌面候选；不声称真实课堂或学生掌握已经通过。</a:t>
@@ -1677,9 +1677,9 @@
 叙事转弯已经清楚，第一句还有六个词要真正说准。
 【V6.6逻辑页】C102｜逻辑页10｜5分钟
 【前页输入】
-学生已经完成前页任务，手中保留与“氓之蚩蚩，抱布贸丝。匪来贸丝，来即我谋。”有关的原词或初稿。
+行动初稿已留两类标记（C101）；学生知道第一章完整故事，尚未逐词面对首两句。
 【唯一困难】
-学生容易看见“氓之蚩蚩，抱布贸丝。匪来贸丝，来即我谋。”，却不能把它准确接回人物和前后故事。
+“抱布贸丝”极易读成做生意，“匪”受现代义干扰；困难是靠重复的“贸丝”与“匪—谋”转折自己读出“来意不在丝”，而非接受教师直译。
 【唯一功能】
 从重复的‘贸丝’和‘匪—谋’读出叙事转弯，校准首句易误词，并守住初见证据边界。
 【文学对象】
@@ -1689,31 +1689,31 @@
 【学生主动作】
 自然口译并圈出转折字；把氓、蚩蚩、布、贸、即、谋送回原句
 【参与路径】
-个人先形成；需要交流时并行同桌或四人轮说；全班只公开少量有差异材料。
+个人自然口译58秒→双人分读互核42秒→分享与定点释义79秒→个人修订54秒；全部个人先行。
 【可见产物】
 叙事转弯句和首句词义旁批
 【教师作用】
-准确释词、引用真实回答、追问原词、后置归纳并守住解释边界。
+巡视不提示；分享后定点释义氓／蚩蚩／布／贸／即／谋并送回原句；守住初见证据边界，不为氓贴性格标签。
 【真实等待】
-逐字稿内有首答等待、限定反馈和本人修订的明确时间。
+时间盒明示：读题25秒→个人口译58秒（台词“安静七十秒”内含）→双人42秒→释义79秒→修订54秒→回诗42秒；口译期间屏幕无译文。
 【反馈与本人修订】
-学生依据原词、同伴追问或教师校准，亲自保留、补充、改写或撤回初稿。
+定点释义后回原句亲手改自己的自然话与转折字圈选；边界项（无怒等）在修订段处理。
 【首次后用】
 C105与C503
 【正常反例】
-想不起、无新增、已经准确、不同意或暂时沉默均有诚实完成路径，不要求伪造改变。
+说不完整先写“谁做了什么”（台词已授权）；猜错词义如实保留原猜测供对照。
 【主视觉职责】
 原词转弯
 【插图资格】
 I01待A/B
 【第一人称接收】
-我刚才面对“氓之蚩蚩，抱布贸丝。匪来贸丝，来即我谋。”，留下了叙事转弯句和首句词义旁批；我能用原词说清自己新增或修正的理解。
+我把首两句说成了一句自然话，圈出让意思转过去的字（匪／谋）；揭示后我能说清自己原以为“贸丝”是什么、差在哪。
 【故事回接】
-页面结束前由一句自然复述回到谁做了什么、人物处境怎样变化以及故事推进到哪里。
+他抱布的名义下是“来即我谋”——初见即有来意；切页句“诗不写一句她很投入，只让三个动词把一段路铺开”引出 C103。
 【删除损失】
 首句会被压成‘男子来求婚’的结论，叙事转弯、词义异说和证据边界同时丢失。
 【相邻反证】
-相邻页不同时处理“学生容易看见“氓之蚩蚩，抱布贸丝。匪来贸丝，来即我谋。”，却不能把它准确接回人物和前后故事。”；合并会挤掉必要首答、校准或故事回接。
+C103 只处理“送子涉淇”的空间感；若并入本页，两句词义＋一句空间共三重任务超出单页负荷（A-T22）。
 【失败信号】
 屏幕标出‘表面动作／真实来意’答案；学生看图猜人格；教师在首答前解释匪—谋关系
 【声明边界】V5无插图桌面候选；不声称真实课堂或学生掌握已经通过。</a:t>
@@ -1829,9 +1829,9 @@
 来意和词义都已说准。接着看她把他送了多远。
 【V6.6逻辑页】C102｜逻辑页10｜5分钟
 【前页输入】
-学生已经完成前页任务，手中保留与“氓之蚩蚩，抱布贸丝。匪来贸丝，来即我谋。”有关的原词或初稿。
+行动初稿已留两类标记（C101）；学生知道第一章完整故事，尚未逐词面对首两句。
 【唯一困难】
-学生容易看见“氓之蚩蚩，抱布贸丝。匪来贸丝，来即我谋。”，却不能把它准确接回人物和前后故事。
+“抱布贸丝”极易读成做生意，“匪”受现代义干扰；困难是靠重复的“贸丝”与“匪—谋”转折自己读出“来意不在丝”，而非接受教师直译。
 【唯一功能】
 从重复的‘贸丝’和‘匪—谋’读出叙事转弯，校准首句易误词，并守住初见证据边界。
 【文学对象】
@@ -1841,31 +1841,31 @@
 【学生主动作】
 自然口译并圈出转折字；把氓、蚩蚩、布、贸、即、谋送回原句
 【参与路径】
-个人先形成；需要交流时并行同桌或四人轮说；全班只公开少量有差异材料。
+个人自然口译58秒→双人分读互核42秒→分享与定点释义79秒→个人修订54秒；全部个人先行。
 【可见产物】
 叙事转弯句和首句词义旁批
 【教师作用】
-准确释词、引用真实回答、追问原词、后置归纳并守住解释边界。
+巡视不提示；分享后定点释义氓／蚩蚩／布／贸／即／谋并送回原句；守住初见证据边界，不为氓贴性格标签。
 【真实等待】
-逐字稿内有首答等待、限定反馈和本人修订的明确时间。
+时间盒明示：读题25秒→个人口译58秒（台词“安静七十秒”内含）→双人42秒→释义79秒→修订54秒→回诗42秒；口译期间屏幕无译文。
 【反馈与本人修订】
-学生依据原词、同伴追问或教师校准，亲自保留、补充、改写或撤回初稿。
+定点释义后回原句亲手改自己的自然话与转折字圈选；边界项（无怒等）在修订段处理。
 【首次后用】
 C105与C503
 【正常反例】
-想不起、无新增、已经准确、不同意或暂时沉默均有诚实完成路径，不要求伪造改变。
+说不完整先写“谁做了什么”（台词已授权）；猜错词义如实保留原猜测供对照。
 【主视觉职责】
 原词转弯
 【插图资格】
 I01待A/B
 【第一人称接收】
-我刚才面对“氓之蚩蚩，抱布贸丝。匪来贸丝，来即我谋。”，留下了叙事转弯句和首句词义旁批；我能用原词说清自己新增或修正的理解。
+我把首两句说成了一句自然话，圈出让意思转过去的字（匪／谋）；揭示后我能说清自己原以为“贸丝”是什么、差在哪。
 【故事回接】
-页面结束前由一句自然复述回到谁做了什么、人物处境怎样变化以及故事推进到哪里。
+他抱布的名义下是“来即我谋”——初见即有来意；切页句“诗不写一句她很投入，只让三个动词把一段路铺开”引出 C103。
 【删除损失】
 首句会被压成‘男子来求婚’的结论，叙事转弯、词义异说和证据边界同时丢失。
 【相邻反证】
-相邻页不同时处理“学生容易看见“氓之蚩蚩，抱布贸丝。匪来贸丝，来即我谋。”，却不能把它准确接回人物和前后故事。”；合并会挤掉必要首答、校准或故事回接。
+C103 只处理“送子涉淇”的空间感；若并入本页，两句词义＋一句空间共三重任务超出单页负荷（A-T22）。
 【失败信号】
 屏幕标出‘表面动作／真实来意’答案；学生看图猜人格；教师在首答前解释匪—谋关系
 【声明边界】V5无插图桌面候选；不声称真实课堂或学生掌握已经通过。</a:t>
@@ -1981,45 +1981,45 @@
 路线在每个人手里，下一页说给同桌看。
 【V6.6逻辑页】C103｜逻辑页11｜4分钟
 【前页输入】
-学生已经完成前页任务，手中保留与“送子涉淇，至于顿丘。”有关的原词或初稿。
+已知来意（C102）；细读单在手；尚未处理空间距离。
 【唯一困难】
-学生容易看见“送子涉淇，至于顿丘。”，却不能把它准确接回人物和前后故事。
+“送子涉淇”易被一句“她很爱他”概括掉；困难是把送—涉—至当身体可感的路程走一遍，让“投入”从动词而非形容词里长出来。
 【唯一功能】
 让‘送—涉—至’成为身体可感的空间长度，看见女子主动投入。
 【文学对象】
 送子涉淇，至于顿丘。
 【信息状态】
-首答前只给原诗、必要字面和一个自然问题；解释、分类、关系与代表答案在学生首稿后出现。
+首答态只有原句与三个动词；“她很爱他”式情感结论、地图背景与婚俗知识均不出现。
 【学生主动作】
 用指尖或笔迹连三个动词；说成一句自然话
 【参与路径】
-个人先形成；需要交流时并行同桌或四人轮说；全班只公开少量有差异材料。
+个人连线48秒→同桌互说核对36秒→释义与边界52秒→自然话分享44秒；单人低门槛起步。
 【可见产物】
 送行线
 【教师作用】
-准确释词、引用真实回答、追问原词、后置归纳并守住解释边界。
+说明“低虚构行线”规则后退开；定点只释送／涉／至三动词与淇／顿丘二地名；不作爱情评价引申。
 【真实等待】
-逐字稿内有首答等待、限定反馈和本人修订的明确时间。
+时间盒明示：说明24秒→个人连线48秒→同桌36秒→释义52秒→分享修订44秒→回接36秒；连线期间教师零语言。
 【反馈与本人修订】
-学生依据原词、同伴追问或教师校准，亲自保留、补充、改写或撤回初稿。
+听过同伴路线后补／改自己的笔迹线；自然话在分享后回原句修订一次。
 【首次后用】
 C105
 【正常反例】
-想不起、无新增、已经准确、不同意或暂时沉默均有诚实完成路径，不要求伪造改变。
+连不直的学生只标能确定的起点与终点；“看不出感情”如实保留为观察。
 【主视觉职责】
 三个原词之间的空间
 【插图资格】
 I02待A/B
 【第一人称接收】
-我刚才面对“送子涉淇，至于顿丘。”，留下了送行线；我能用原词说清自己新增或修正的理解。
+我用手指和笔迹把送—涉—至连成一条线，能用自然话说出她送出了多远；“投入”这个词现在有三个动词托着。
 【故事回接】
-页面结束前由一句自然复述回到谁做了什么、人物处境怎样变化以及故事推进到哪里。
+她送到顿丘而婚事未当场定下——切页句把话语交棒 C104。
 【删除损失】
 删除会把远送压成‘她送他’
 【相邻反证】
-相邻页不同时处理“学生容易看见“送子涉淇，至于顿丘。”，却不能把它准确接回人物和前后故事。”；合并会挤掉必要首答、校准或故事回接。
+C104 处理顿丘上的话语（匪我愆期…）；空间（身体）与话语（声音）是两种经验，合并则其一被滑过。
 【失败信号】
-学生只能复述活动手续，不能复述诗意；首答前已经看见完成关系或答案；产物在后页没有真实消费者
+学生写下“她很爱他”而无一动词支撑；行线画成装饰图而非三动词轨迹；教师提前给出“主动投入”结论词
 【声明边界】V5无插图桌面候选；不声称真实课堂或学生掌握已经通过。</a:t>
             </a:r>
             <a:endParaRPr lang="en-US" dirty="0"/>
@@ -2133,45 +2133,45 @@
 现在让三个动词排成一条准确的路。
 【V6.6逻辑页】C103｜逻辑页11｜4分钟
 【前页输入】
-学生已经完成前页任务，手中保留与“送子涉淇，至于顿丘。”有关的原词或初稿。
+已知来意（C102）；细读单在手；尚未处理空间距离。
 【唯一困难】
-学生容易看见“送子涉淇，至于顿丘。”，却不能把它准确接回人物和前后故事。
+“送子涉淇”易被一句“她很爱他”概括掉；困难是把送—涉—至当身体可感的路程走一遍，让“投入”从动词而非形容词里长出来。
 【唯一功能】
 让‘送—涉—至’成为身体可感的空间长度，看见女子主动投入。
 【文学对象】
 送子涉淇，至于顿丘。
 【信息状态】
-首答前只给原诗、必要字面和一个自然问题；解释、分类、关系与代表答案在学生首稿后出现。
+首答态只有原句与三个动词；“她很爱他”式情感结论、地图背景与婚俗知识均不出现。
 【学生主动作】
 用指尖或笔迹连三个动词；说成一句自然话
 【参与路径】
-个人先形成；需要交流时并行同桌或四人轮说；全班只公开少量有差异材料。
+个人连线48秒→同桌互说核对36秒→释义与边界52秒→自然话分享44秒；单人低门槛起步。
 【可见产物】
 送行线
 【教师作用】
-准确释词、引用真实回答、追问原词、后置归纳并守住解释边界。
+说明“低虚构行线”规则后退开；定点只释送／涉／至三动词与淇／顿丘二地名；不作爱情评价引申。
 【真实等待】
-逐字稿内有首答等待、限定反馈和本人修订的明确时间。
+时间盒明示：说明24秒→个人连线48秒→同桌36秒→释义52秒→分享修订44秒→回接36秒；连线期间教师零语言。
 【反馈与本人修订】
-学生依据原词、同伴追问或教师校准，亲自保留、补充、改写或撤回初稿。
+听过同伴路线后补／改自己的笔迹线；自然话在分享后回原句修订一次。
 【首次后用】
 C105
 【正常反例】
-想不起、无新增、已经准确、不同意或暂时沉默均有诚实完成路径，不要求伪造改变。
+连不直的学生只标能确定的起点与终点；“看不出感情”如实保留为观察。
 【主视觉职责】
 三个原词之间的空间
 【插图资格】
 I02待A/B
 【第一人称接收】
-我刚才面对“送子涉淇，至于顿丘。”，留下了送行线；我能用原词说清自己新增或修正的理解。
+我用手指和笔迹把送—涉—至连成一条线，能用自然话说出她送出了多远；“投入”这个词现在有三个动词托着。
 【故事回接】
-页面结束前由一句自然复述回到谁做了什么、人物处境怎样变化以及故事推进到哪里。
+她送到顿丘而婚事未当场定下——切页句把话语交棒 C104。
 【删除损失】
 删除会把远送压成‘她送他’
 【相邻反证】
-相邻页不同时处理“学生容易看见“送子涉淇，至于顿丘。”，却不能把它准确接回人物和前后故事。”；合并会挤掉必要首答、校准或故事回接。
+C104 处理顿丘上的话语（匪我愆期…）；空间（身体）与话语（声音）是两种经验，合并则其一被滑过。
 【失败信号】
-学生只能复述活动手续，不能复述诗意；首答前已经看见完成关系或答案；产物在后页没有真实消费者
+学生写下“她很爱他”而无一动词支撑；行线画成装饰图而非三动词轨迹；教师提前给出“主动投入”结论词
 【声明边界】V5无插图桌面候选；不声称真实课堂或学生掌握已经通过。</a:t>
             </a:r>
             <a:endParaRPr lang="en-US" dirty="0"/>
@@ -2288,7 +2288,7 @@
 【前页输入】
 每人已有一份公共声音出现前封存的文学回忆单。
 【唯一困难】
-学生容易看见“全班学生真正记得的爱情与婚姻文学作品及其朴素主题”，却不能把它准确接回人物和前后故事。
+串行点名会让多数人长时间等待并听见重复；只收小组卡又掩盖个人声音——本页困难是“人人真实开口”与“全班不被同义材料淹没”同时成立。
 【唯一功能】
 分别实现每个人低压开口和全班文学版图的广度，让作品与朴素主题从学生话语中相遇。
 【文学对象】
@@ -2302,15 +2302,15 @@
 【可见产物】
 黑板文学长卷和个人新增栏
 【教师作用】
-准确释词、引用真实回答、追问原词、后置归纳并守住解释边界。
+教师只把学生真正说出的篇名与关键词写上黑板、当场不分类不补篇；每组一条增量后才以“我们先听记”承认无新增组；归纳延迟到 O03。
 【真实等待】
-逐字稿内有首答等待、限定反馈和本人修订的明确时间。
+同桌互说95秒内零插话；四人按可见顺序轮说150秒、说完前不选代表；公共增量190秒逐组一条；个人补记45秒（时间盒明示）。
 【反馈与本人修订】
-学生依据原词、同伴追问或教师校准，亲自保留、补充、改写或撤回初稿。
+听见自己没有想到的篇目或主题→当场补进 O01 单的新增栏；本组无新增→如实“先听记”后补记别组新篇目。
 【首次后用】
 O03教师引用并揭题；S04回投
 【正常反例】
-想不起、无新增、已经准确、不同意或暂时沉默均有诚实完成路径，不要求伪造改变。
+无新增组如实说“我们先听记”，不制造虚假差异；主题说过深或过空→被拉回“一句故事＋它写到什么”。
 【主视觉职责】
 一句自然表达入口；真正主视觉为现场黑板长卷
 【插图资格】
@@ -2318,7 +2318,7 @@
 【第一人称接收】
 我完整说过一篇，也从同学那里补到自己没有想到的作品或主题。
 【故事回接】
-页面结束前由一句自然复述回到谁做了什么、人物处境怎样变化以及故事推进到哪里。
+黑板长卷是全班的爱情婚姻记忆版图；切页句完成回接：“沿着大家真正说出的故事，去听一位更早的女子怎样讲她的相识与后来”——O03 从这面黑板聚焦《氓》。
 【删除损失】
 失去全员声音或公共文学广度。
 【相邻反证】
@@ -2438,45 +2438,45 @@
 路送到了顿丘，婚期为什么仍没有定下？
 【V6.6逻辑页】C103｜逻辑页11｜4分钟
 【前页输入】
-学生已经完成前页任务，手中保留与“送子涉淇，至于顿丘。”有关的原词或初稿。
+已知来意（C102）；细读单在手；尚未处理空间距离。
 【唯一困难】
-学生容易看见“送子涉淇，至于顿丘。”，却不能把它准确接回人物和前后故事。
+“送子涉淇”易被一句“她很爱他”概括掉；困难是把送—涉—至当身体可感的路程走一遍，让“投入”从动词而非形容词里长出来。
 【唯一功能】
 让‘送—涉—至’成为身体可感的空间长度，看见女子主动投入。
 【文学对象】
 送子涉淇，至于顿丘。
 【信息状态】
-首答前只给原诗、必要字面和一个自然问题；解释、分类、关系与代表答案在学生首稿后出现。
+首答态只有原句与三个动词；“她很爱他”式情感结论、地图背景与婚俗知识均不出现。
 【学生主动作】
 用指尖或笔迹连三个动词；说成一句自然话
 【参与路径】
-个人先形成；需要交流时并行同桌或四人轮说；全班只公开少量有差异材料。
+个人连线48秒→同桌互说核对36秒→释义与边界52秒→自然话分享44秒；单人低门槛起步。
 【可见产物】
 送行线
 【教师作用】
-准确释词、引用真实回答、追问原词、后置归纳并守住解释边界。
+说明“低虚构行线”规则后退开；定点只释送／涉／至三动词与淇／顿丘二地名；不作爱情评价引申。
 【真实等待】
-逐字稿内有首答等待、限定反馈和本人修订的明确时间。
+时间盒明示：说明24秒→个人连线48秒→同桌36秒→释义52秒→分享修订44秒→回接36秒；连线期间教师零语言。
 【反馈与本人修订】
-学生依据原词、同伴追问或教师校准，亲自保留、补充、改写或撤回初稿。
+听过同伴路线后补／改自己的笔迹线；自然话在分享后回原句修订一次。
 【首次后用】
 C105
 【正常反例】
-想不起、无新增、已经准确、不同意或暂时沉默均有诚实完成路径，不要求伪造改变。
+连不直的学生只标能确定的起点与终点；“看不出感情”如实保留为观察。
 【主视觉职责】
 三个原词之间的空间
 【插图资格】
 I02待A/B
 【第一人称接收】
-我刚才面对“送子涉淇，至于顿丘。”，留下了送行线；我能用原词说清自己新增或修正的理解。
+我用手指和笔迹把送—涉—至连成一条线，能用自然话说出她送出了多远；“投入”这个词现在有三个动词托着。
 【故事回接】
-页面结束前由一句自然复述回到谁做了什么、人物处境怎样变化以及故事推进到哪里。
+她送到顿丘而婚事未当场定下——切页句把话语交棒 C104。
 【删除损失】
 删除会把远送压成‘她送他’
 【相邻反证】
-相邻页不同时处理“学生容易看见“送子涉淇，至于顿丘。”，却不能把它准确接回人物和前后故事。”；合并会挤掉必要首答、校准或故事回接。
+C104 处理顿丘上的话语（匪我愆期…）；空间（身体）与话语（声音）是两种经验，合并则其一被滑过。
 【失败信号】
-学生只能复述活动手续，不能复述诗意；首答前已经看见完成关系或答案；产物在后页没有真实消费者
+学生写下“她很爱他”而无一动词支撑；行线画成装饰图而非三动词轨迹；教师提前给出“主动投入”结论词
 【声明边界】V5无插图桌面候选；不声称真实课堂或学生掌握已经通过。</a:t>
             </a:r>
             <a:endParaRPr lang="en-US" dirty="0"/>
@@ -2590,9 +2590,9 @@
 话已经各自说过，下一页只听它怎样推进。
 【V6.6逻辑页】C104｜逻辑页12｜5分钟
 【前页输入】
-学生已经完成前页任务，手中保留与“匪我愆期，子无良媒。将子无怒，秋以为期。”有关的原词或初稿。
+空间路线已连好（C103）；学生带着“送到顿丘但婚期未定”的悬置进入。
 【唯一困难】
-学生容易看见“匪我愆期，子无良媒。将子无怒，秋以为期。”，却不能把它准确接回人物和前后故事。
+四小句易被当四个知识点（愆期／良媒／无怒／秋期）分记；困难是读成一轮完整话语——说明原因、安抚情绪、另约时间——听见语气功能。
 【唯一功能】
 把四小句读成说明条件、安抚和另约的一轮完整话语。
 【文学对象】
@@ -2602,33 +2602,33 @@
 【学生主动作】
 完整自然口译；同桌听一处含义是否清楚
 【参与路径】
-个人先形成；需要交流时并行同桌或四人轮说；全班只公开少量有差异材料。
+个人口译64秒→双人读听轮换61秒→分享与释义75秒→修订46秒；听者唯一任务是“听一处含义是否清楚”。
 【可见产物】
 对话与声音标记
 【教师作用】
-准确释词、引用真实回答、追问原词、后置归纳并守住解释边界。
+领起连读后退开；定点释义愆期／良媒并处理“无怒”边界（安抚≠纵容，不作现代恋爱引申）；不评判女子“守规矩”。
 【真实等待】
-逐字稿内有首答等待、限定反馈和本人修订的明确时间。
+时间盒明示：连读交代25秒→个人口译64秒→双人轮换61秒→分享释义75秒→修订46秒→合读29秒；口译期间零提示。
 【反馈与本人修订】
-学生依据原词、同伴追问或教师校准，亲自保留、补充、改写或撤回初稿。
+同桌指出不清楚处后本人改读一次；释义后回原句修订四小句功能标注。
 【首次后用】
 C105与C503
 【正常反例】
-想不起、无新增、已经准确、不同意或暂时沉默均有诚实完成路径，不要求伪造改变。
+某小句功能说不清就标“存疑”；改读不要求感情色彩，清楚即可。
 【主视觉职责】
 完整话语而非四条注释
 【插图资格】
 无
 【第一人称接收】
-我刚才面对“匪我愆期，子无良媒。将子无怒，秋以为期。”，留下了对话与声音标记；我能用原词说清自己新增或修正的理解。
+我把整轮话说成了自然话，并写出四小句各自在做什么（说明／安抚／约定）；同桌听过我的一处含义是否清楚。
 【故事回接】
-页面结束前由一句自然复述回到谁做了什么、人物处境怎样变化以及故事推进到哪里。
+来—送—解释—安抚—约期全部发生；切页句把第一章推向整体重建（C105）。
 【删除损失】
 删除会失去女子怎样主动推进婚事
 【相邻反证】
-相邻页不同时处理“学生容易看见“匪我愆期，子无良媒。将子无怒，秋以为期。”，却不能把它准确接回人物和前后故事。”；合并会挤掉必要首答、校准或故事回接。
+C105 合书重建以本页话语理解为前提；C503 婚后回望将取回“将子无怒”——本页是那组对照的起点，不可省。
 【失败信号】
-学生只能复述活动手续，不能复述诗意；首答前已经看见完成关系或答案；产物在后页没有真实消费者
+四小句被抄成四个注释词条；同桌互听变成互批翻译；教师对“无怒”作恋爱技巧式引申
 【声明边界】V5无插图桌面候选；不声称真实课堂或学生掌握已经通过。</a:t>
             </a:r>
             <a:endParaRPr lang="en-US" dirty="0"/>
@@ -2742,9 +2742,9 @@
 听感已经出现，下一页把字义和整番话说准。
 【V6.6逻辑页】C104｜逻辑页12｜5分钟
 【前页输入】
-学生已经完成前页任务，手中保留与“匪我愆期，子无良媒。将子无怒，秋以为期。”有关的原词或初稿。
+空间路线已连好（C103）；学生带着“送到顿丘但婚期未定”的悬置进入。
 【唯一困难】
-学生容易看见“匪我愆期，子无良媒。将子无怒，秋以为期。”，却不能把它准确接回人物和前后故事。
+四小句易被当四个知识点（愆期／良媒／无怒／秋期）分记；困难是读成一轮完整话语——说明原因、安抚情绪、另约时间——听见语气功能。
 【唯一功能】
 把四小句读成说明条件、安抚和另约的一轮完整话语。
 【文学对象】
@@ -2754,33 +2754,33 @@
 【学生主动作】
 完整自然口译；同桌听一处含义是否清楚
 【参与路径】
-个人先形成；需要交流时并行同桌或四人轮说；全班只公开少量有差异材料。
+个人口译64秒→双人读听轮换61秒→分享与释义75秒→修订46秒；听者唯一任务是“听一处含义是否清楚”。
 【可见产物】
 对话与声音标记
 【教师作用】
-准确释词、引用真实回答、追问原词、后置归纳并守住解释边界。
+领起连读后退开；定点释义愆期／良媒并处理“无怒”边界（安抚≠纵容，不作现代恋爱引申）；不评判女子“守规矩”。
 【真实等待】
-逐字稿内有首答等待、限定反馈和本人修订的明确时间。
+时间盒明示：连读交代25秒→个人口译64秒→双人轮换61秒→分享释义75秒→修订46秒→合读29秒；口译期间零提示。
 【反馈与本人修订】
-学生依据原词、同伴追问或教师校准，亲自保留、补充、改写或撤回初稿。
+同桌指出不清楚处后本人改读一次；释义后回原句修订四小句功能标注。
 【首次后用】
 C105与C503
 【正常反例】
-想不起、无新增、已经准确、不同意或暂时沉默均有诚实完成路径，不要求伪造改变。
+某小句功能说不清就标“存疑”；改读不要求感情色彩，清楚即可。
 【主视觉职责】
 完整话语而非四条注释
 【插图资格】
 无
 【第一人称接收】
-我刚才面对“匪我愆期，子无良媒。将子无怒，秋以为期。”，留下了对话与声音标记；我能用原词说清自己新增或修正的理解。
+我把整轮话说成了自然话，并写出四小句各自在做什么（说明／安抚／约定）；同桌听过我的一处含义是否清楚。
 【故事回接】
-页面结束前由一句自然复述回到谁做了什么、人物处境怎样变化以及故事推进到哪里。
+来—送—解释—安抚—约期全部发生；切页句把第一章推向整体重建（C105）。
 【删除损失】
 删除会失去女子怎样主动推进婚事
 【相邻反证】
-相邻页不同时处理“学生容易看见“匪我愆期，子无良媒。将子无怒，秋以为期。”，却不能把它准确接回人物和前后故事。”；合并会挤掉必要首答、校准或故事回接。
+C105 合书重建以本页话语理解为前提；C503 婚后回望将取回“将子无怒”——本页是那组对照的起点，不可省。
 【失败信号】
-学生只能复述活动手续，不能复述诗意；首答前已经看见完成关系或答案；产物在后页没有真实消费者
+四小句被抄成四个注释词条；同桌互听变成互批翻译；教师对“无怒”作恋爱技巧式引申
 【声明边界】V5无插图桌面候选；不声称真实课堂或学生掌握已经通过。</a:t>
             </a:r>
             <a:endParaRPr lang="en-US" dirty="0"/>
@@ -2894,9 +2894,9 @@
 来、送、约已经清楚，现在把第一章重新讲成一个故事。
 【V6.6逻辑页】C104｜逻辑页12｜5分钟
 【前页输入】
-学生已经完成前页任务，手中保留与“匪我愆期，子无良媒。将子无怒，秋以为期。”有关的原词或初稿。
+空间路线已连好（C103）；学生带着“送到顿丘但婚期未定”的悬置进入。
 【唯一困难】
-学生容易看见“匪我愆期，子无良媒。将子无怒，秋以为期。”，却不能把它准确接回人物和前后故事。
+四小句易被当四个知识点（愆期／良媒／无怒／秋期）分记；困难是读成一轮完整话语——说明原因、安抚情绪、另约时间——听见语气功能。
 【唯一功能】
 把四小句读成说明条件、安抚和另约的一轮完整话语。
 【文学对象】
@@ -2906,33 +2906,33 @@
 【学生主动作】
 完整自然口译；同桌听一处含义是否清楚
 【参与路径】
-个人先形成；需要交流时并行同桌或四人轮说；全班只公开少量有差异材料。
+个人口译64秒→双人读听轮换61秒→分享与释义75秒→修订46秒；听者唯一任务是“听一处含义是否清楚”。
 【可见产物】
 对话与声音标记
 【教师作用】
-准确释词、引用真实回答、追问原词、后置归纳并守住解释边界。
+领起连读后退开；定点释义愆期／良媒并处理“无怒”边界（安抚≠纵容，不作现代恋爱引申）；不评判女子“守规矩”。
 【真实等待】
-逐字稿内有首答等待、限定反馈和本人修订的明确时间。
+时间盒明示：连读交代25秒→个人口译64秒→双人轮换61秒→分享释义75秒→修订46秒→合读29秒；口译期间零提示。
 【反馈与本人修订】
-学生依据原词、同伴追问或教师校准，亲自保留、补充、改写或撤回初稿。
+同桌指出不清楚处后本人改读一次；释义后回原句修订四小句功能标注。
 【首次后用】
 C105与C503
 【正常反例】
-想不起、无新增、已经准确、不同意或暂时沉默均有诚实完成路径，不要求伪造改变。
+某小句功能说不清就标“存疑”；改读不要求感情色彩，清楚即可。
 【主视觉职责】
 完整话语而非四条注释
 【插图资格】
 无
 【第一人称接收】
-我刚才面对“匪我愆期，子无良媒。将子无怒，秋以为期。”，留下了对话与声音标记；我能用原词说清自己新增或修正的理解。
+我把整轮话说成了自然话，并写出四小句各自在做什么（说明／安抚／约定）；同桌听过我的一处含义是否清楚。
 【故事回接】
-页面结束前由一句自然复述回到谁做了什么、人物处境怎样变化以及故事推进到哪里。
+来—送—解释—安抚—约期全部发生；切页句把第一章推向整体重建（C105）。
 【删除损失】
 删除会失去女子怎样主动推进婚事
 【相邻反证】
-相邻页不同时处理“学生容易看见“匪我愆期，子无良媒。将子无怒，秋以为期。”，却不能把它准确接回人物和前后故事。”；合并会挤掉必要首答、校准或故事回接。
+C105 合书重建以本页话语理解为前提；C503 婚后回望将取回“将子无怒”——本页是那组对照的起点，不可省。
 【失败信号】
-学生只能复述活动手续，不能复述诗意；首答前已经看见完成关系或答案；产物在后页没有真实消费者
+四小句被抄成四个注释词条；同桌互听变成互批翻译；教师对“无怒”作恋爱技巧式引申
 【声明边界】V5无插图桌面候选；不声称真实课堂或学生掌握已经通过。</a:t>
             </a:r>
             <a:endParaRPr lang="en-US" dirty="0"/>
@@ -3052,45 +3052,45 @@
 第一格先留在这里。下一章，约定之后的日子从等待复关开始。
 【V6.6逻辑页】C105｜逻辑页13｜5分钟
 【前页输入】
-学生已经完成前页任务，手中保留与“氓之蚩蚩，抱布贸丝。匪来贸丝，来即我谋。送子涉淇，至于顿丘。匪我愆期，子无良媒。将子无怒，秋以为期。”有关的原词或初稿。
+C102-C104 的词义、路线、话语全部完成；03A 初读卡与 03B 细读单此刻翻面压桌角（合书条件成立）。
 【唯一困难】
-学生容易看见“氓之蚩蚩，抱布贸丝。匪来贸丝，来即我谋。送子涉淇，至于顿丘。匪我愆期，子无良媒。将子无怒，秋以为期。”，却不能把它准确接回人物和前后故事。
+局部都读过后学生仍可能只会复述活动（圈了词、画了线）；困难是合书把来—送—约讲成一段故事，断点处返诗补说而非背书。
 【唯一功能】
 示范怎样把局部词句重新讲成人物、动作和结果连贯的一章。
 【文学对象】
 氓之蚩蚩，抱布贸丝。匪来贸丝，来即我谋。送子涉淇，至于顿丘。匪我愆期，子无良媒。将子无怒，秋以为期。
 【信息状态】
-首答前只给原诗、必要字面和一个自然问题；解释、分类、关系与代表答案在学生首稿后出现。
+旁白前教材合上、双单翻面；屏幕只有章题与轨道第一格；教师不先示范完整旁白。
 【学生主动作】
 合书讲来—送—约；真实断点处返诗补说
 【参与路径】
-个人先形成；需要交流时并行同桌或四人轮说；全班只公开少量有差异材料。
+完整重读45秒→两人轮流30秒旁白75秒→听者补缺返诗55秒→写章意50秒→引用保存45秒；两人各讲一遍。
 【可见产物】
 第一章章意
 【教师作用】
-准确释词、引用真实回答、追问原词、后置归纳并守住解释边界。
+领起重读第一句后让学生读完；宣听者边界（只补缺不评价）；收束只引用学生章意原话写入轨道第一格。
 【真实等待】
-逐字稿内有首答等待、限定反馈和本人修订的明确时间。
+时间盒明示六段（45／30／75／55／50／45秒）；旁白期间教师不插话，断点由讲者自己返诗。
 【反馈与本人修订】
-学生依据原词、同伴追问或教师校准，亲自保留、补充、改写或撤回初稿。
+断点补说即修订（翻诗→补→继续）；听者补缺后讲者确认或改正。
 【首次后用】
 C201
 【正常反例】
-想不起、无新增、已经准确、不同意或暂时沉默均有诚实完成路径，不要求伪造改变。
+断点如实返诗补说不硬编；章意写不出整句先写三个词后补成句。
 【主视觉职责】
 第一次完整章意示范
 【插图资格】
 无
 【第一人称接收】
-我刚才面对“氓之蚩蚩，抱布贸丝。匪来贸丝，来即我谋。送子涉淇，至于顿丘。匪我愆期，子无良媒。将子无怒，秋以为期。”，留下了第一章章意；我能用原词说清自己新增或修正的理解。
+我合书讲了第一章（来—送—约），真实断点处翻诗补说过；我的章意写进了故事轨道第一格。
 【故事回接】
-页面结束前由一句自然复述回到谁做了什么、人物处境怎样变化以及故事推进到哪里。
+第一章以“章意＋轨道第一格”固定；切页句：“下一章，约定之后的日子从等待复关开始”。
 【删除损失】
 删除后前四页仍是碎片
 【相邻反证】
-相邻页不同时处理“学生容易看见“氓之蚩蚩，抱布贸丝。匪来贸丝，来即我谋。送子涉淇，至于顿丘。匪我愆期，子无良媒。将子无怒，秋以为期。”，却不能把它准确接回人物和前后故事。”；合并会挤掉必要首答、校准或故事回接。
+每章只此一次正式合书重建（手法库规则）；C206 是两章接续且用不同结构（接力＋因果句），不复制本页单人旁白模板。
 【失败信号】
-学生只能复述活动手续，不能复述诗意；首答前已经看见完成关系或答案；产物在后页没有真实消费者
+旁白时教材未合上（照读）；教师先示范完整旁白；章意是活动罗列而非故事句
 【声明边界】V5无插图桌面候选；不声称真实课堂或学生掌握已经通过。</a:t>
             </a:r>
             <a:endParaRPr lang="en-US" dirty="0"/>
@@ -3209,45 +3209,45 @@
 目光落向复关。现在把‘不见’和‘既见’放在一起，看这两句怎样突然转过去，又能不能被耳朵听出来。
 【V6.6逻辑页】C201｜逻辑页14｜5分钟
 【前页输入】
-学生已经完成前页任务，手中保留与“乘彼垝垣，以望复关。不见复关，泣涕涟涟。既见复关，载笑载言。尔卜尔筮，体无咎言。以尔车来，以我贿迁。”有关的原词或初稿。
+轨道第一格已存（C105 章意）；学生带着“秋以为期”的约定进入；尚未读第二章。
 【唯一困难】
-学生容易看见“乘彼垝垣，以望复关。不见复关，泣涕涟涟。既见复关，载笑载言。尔卜尔筮，体无咎言。以尔车来，以我贿迁。”，却不能把它准确接回人物和前后故事。
+从第一章事件链切到等待与情绪波动，学生易把“泣涕／笑言”直接标签成喜怒；困难是先留下动作与视线（乘—望），情绪留给 C202 对照读。
 【唯一功能】
 从秋期进入登垣等待，使‘乘—望’成为具体站位与视线。
 【文学对象】
 乘彼垝垣，以望复关。不见复关，泣涕涟涟。既见复关，载笑载言。尔卜尔筮，体无咎言。以尔车来，以我贿迁。
 【信息状态】
-首答前只给原诗、必要字面和一个自然问题；解释、分类、关系与代表答案在学生首稿后出现。
+首读态只有原诗与动作／视线标记要求；“哭因为想他／笑因为见到他”式解释不出现。
 【学生主动作】
 整章读；留下三个动作和一道视线
 【参与路径】
-个人先形成；需要交流时并行同桌或四人轮说；全班只公开少量有差异材料。
+教师听读38秒→学生完整朗读38秒→发03A写三动作58秒→引用初稿29秒→首句口译画目光58秒→同桌核对与校词79秒。
 【可见产物】
 动作与视线初稿
 【教师作用】
-准确释词、引用真实回答、追问原词、后置归纳并守住解释边界。
+完整读章承载声音；引用动作初稿后再进首句；校词只限乘／垝垣／望／复关，情绪词不解释。
 【真实等待】
-逐字稿内有首答等待、限定反馈和本人修订的明确时间。
+时间盒明示六段；个人写三动作58秒期间零插话。
 【反馈与本人修订】
-学生依据原词、同伴追问或教师校准，亲自保留、补充、改写或撤回初稿。
+同桌核对后改动作标记；首句口译在校词后回句修订。
 【首次后用】
 C202
 【正常反例】
-想不起、无新增、已经准确、不同意或暂时沉默均有诚实完成路径，不要求伪造改变。
+动作找不满三个先留两个；目光画不出的学生等 C202 对照再落笔。
 【主视觉职责】
 垝垣到复关的视线
 【插图资格】
 I03待A/B
 【第一人称接收】
-我刚才面对“乘彼垝垣，以望复关。不见复关，泣涕涟涟。既见复关，载笑载言。尔卜尔筮，体无咎言。以尔车来，以我贿迁。”，留下了动作与视线初稿；我能用原词说清自己新增或修正的理解。
+我完整读了第二章，留下三个动作与一道视线；能说出她站到哪里（垝垣）、目光投向哪里（复关）。
 【故事回接】
-页面结束前由一句自然复述回到谁做了什么、人物处境怎样变化以及故事推进到哪里。
+约定之后的日子从登垣等待开始——切页句把“不见／既见”交给对照读。
 【删除损失】
 删除会让哭笑失去等待空间
 【相邻反证】
-相邻页不同时处理“学生容易看见“乘彼垝垣，以望复关。不见复关，泣涕涟涟。既见复关，载笑载言。尔卜尔筮，体无咎言。以尔车来，以我贿迁。”，却不能把它准确接回人物和前后故事。”；合并会挤掉必要首答、校准或故事回接。
+C202 才处理不见／既见的对照；本页若预讲情绪转折，C202 的对照首答即被泄。
 【失败信号】
-学生只能复述活动手续，不能复述诗意；首答前已经看见完成关系或答案；产物在后页没有真实消费者
+首读态出现喜怒标签；三动作被教师预先报出；轨道第一格被改写而非承接
 【声明边界】V5无插图桌面候选；不声称真实课堂或学生掌握已经通过。</a:t>
             </a:r>
             <a:endParaRPr lang="en-US" dirty="0"/>
@@ -3366,45 +3366,45 @@
 见与不见的变化已经能被耳朵听见。下面把两句连起来：一次占问之后，婚事又怎样走向了实际迁移？
 【V6.6逻辑页】C202｜逻辑页15｜5分钟
 【前页输入】
-学生已经完成前页任务，手中保留与“不见复关，泣涕涟涟。既见复关，载笑载言。”有关的原词或初稿。
+三动作与视线初稿在手（C201）；知道她站垝垣望复关。
 【唯一困难】
-学生容易看见“不见复关，泣涕涟涟。既见复关，载笑载言。”，却不能把它准确接回人物和前后故事。
+“泣涕涟涟／载笑载言”易被直接归因为想他／见到他；困难是沿“不见什么→已见什么→她实际做什么”自己读出条件与动作的扣合，并让耳朵听见转折。
 【唯一功能】
 用正面对照读清条件变化怎样触发泣涕与笑言。
 【文学对象】
 不见复关，泣涕涟涟。既见复关，载笑载言。
 【信息状态】
-首答前只给原诗、必要字面和一个自然问题；解释、分类、关系与代表答案在学生首稿后出现。
+首答态只有两句原诗与对齐任务；“条件—动作”术语与教师示范读均后置。
 【学生主动作】
 对齐四组原词；试读并说听见的转轴
 【参与路径】
-个人先形成；需要交流时并行同桌或四人轮说；全班只公开少量有差异材料。
+个人口译圈词63秒→双人对读互问44秒→分享释义53秒→单点朗读设计34秒→盲听互馈69秒→声音分享37秒；人人设计、人人被听。
 【可见产物】
 条件—动作对照
 【教师作用】
-准确释词、引用真实回答、追问原词、后置归纳并守住解释边界。
+巡视不示范读；分享后定点释义并收“条件变化触发动作”；盲听反馈只说“听见／没听见转折”，不评感情。
 【真实等待】
-逐字稿内有首答等待、限定反馈和本人修订的明确时间。
+时间盒明示六段；个人圈词63秒与朗读设计34秒期间零插话；盲听双方各一轮。
 【反馈与本人修订】
-学生依据原词、同伴追问或教师校准，亲自保留、补充、改写或撤回初稿。
+盲听反馈后各自改读一次（改重音／停顿位置）；释义后回原词修订对齐。
 【首次后用】
 C206
 【正常反例】
-想不起、无新增、已经准确、不同意或暂时沉默均有诚实完成路径，不要求伪造改变。
+设计不出声音方案的用“慢读前句、快读后句”保底；听不出转折的学生如实说“没听出来”，二遍再试。
 【主视觉职责】
 两组正面对照
 【插图资格】
 无
 【第一人称接收】
-我刚才面对“不见复关，泣涕涟涟。既见复关，载笑载言。”，留下了条件—动作对照；我能用原词说清自己新增或修正的理解。
+我对齐了四组原词（不见／既见、泣涕／笑言等），设计并试读了一个单点，盲听后改过一次读法；转折现在能被我的耳朵听见。
 【故事回接】
-页面结束前由一句自然复述回到谁做了什么、人物处境怎样变化以及故事推进到哪里。
+见与不见的变化被耳朵听见；切页句把“一次占问之后婚事怎样迁移”交给 C204。
 【删除损失】
 删除会丢失第二章最强情态转折
 【相邻反证】
-相邻页不同时处理“学生容易看见“不见复关，泣涕涟涟。既见复关，载笑载言。”，却不能把它准确接回人物和前后故事。”；合并会挤掉必要首答、校准或故事回接。
+C204 处理卜筮与迁移；声音对照与因序分析是两种经验，朗读谱设计并入 C204 将超载。
 【失败信号】
-学生只能复述活动手续，不能复述诗意；首答前已经看见完成关系或答案；产物在后页没有真实消费者
+对齐表被教师预先填好；盲听反馈变成朗读打分；情绪标签先于原词对齐出现
 【声明边界】V5无插图桌面候选；不声称真实课堂或学生掌握已经通过。</a:t>
             </a:r>
             <a:endParaRPr lang="en-US" dirty="0"/>
@@ -3524,9 +3524,9 @@
 占问无不祥，车来、财物迁，第二章已经走到实际迁移。现在收起局部提示，把等待到迁移完整讲一次。
 【V6.6逻辑页】C204｜逻辑页16｜6分钟
 【前页输入】
-学生已经完成前页任务，手中保留与“尔卜尔筮，体无咎言。以尔车来，以我贿迁。”有关的原词或初稿。
+对照读完不见／既见（C202）；知道第二章在情绪高点；尚未接触卜筮知识。
 【唯一困难】
-学生容易看见“尔卜尔筮，体无咎言。以尔车来，以我贿迁。”，却不能把它准确接回人物和前后故事。
+卜／筮／体／咎言四项知识无法靠猜；困难是先准确口译占问，再沿“以尔／以我”看清占问→车来→贿迁的因序与双方主体。
 【唯一功能】
 准确理解本次卜筮，并沿‘以尔/以我’读清占问到迁嫁的因序。
 【文学对象】
@@ -3536,31 +3536,31 @@
 【学生主动作】
 区分双方主体、物件与动作；口头连接因序
 【参与路径】
-个人先形成；需要交流时并行同桌或四人轮说；全班只公开少量有差异材料。
+个人占问口译56秒→同桌名物核对64秒→拆分以尔以我56秒→同桌对应核对60秒→合回故事83秒；两轮同桌各有边界。
 【可见产物】
 两句因序
 【教师作用】
-准确释词、引用真实回答、追问原词、后置归纳并守住解释边界。
+开头即给四项知识最小支架（41秒，台词明示“支架到这里”）后退开；校词只限名物；不作婚俗评价引申。
 【真实等待】
-逐字稿内有首答等待、限定反馈和本人修订的明确时间。
+时间盒明示六段；两轮个人时段（56＋56秒）零插话。
 【反馈与本人修订】
-学生依据原词、同伴追问或教师校准，亲自保留、补充、改写或撤回初稿。
+同桌核对后改正主体归属；两句合回故事时本人修订自己的因序句。
 【首次后用】
 C206
 【正常反例】
-想不起、无新增、已经准确、不同意或暂时沉默均有诚实完成路径，不要求伪造改变。
+名物记不住可留半开（“筮＝用蓍草？”），核对后补全；因序连不出先并排两句事实。
 【主视觉职责】
 三节点因序
 【插图资格】
 仅抽象因序示意
 【第一人称接收】
-我刚才面对“尔卜尔筮，体无咎言。以尔车来，以我贿迁。”，留下了两句因序；我能用原词说清自己新增或修正的理解。
+我口译了占问句并写出结果；亲手拆分了以尔（车来）与以我（贿迁）的主体—物件—动作；两句因序连成了话。
 【故事回接】
-页面结束前由一句自然复述回到谁做了什么、人物处境怎样变化以及故事推进到哪里。
+占问无不祥→车来→财物迁，第二章走到实际迁移；切页句把等待到迁移的整体讲述交给 C206。
 【删除损失】
 删除会把无咎—车来—贿迁压成泛泛成婚
 【相邻反证】
-相邻页不同时处理“学生容易看见“尔卜尔筮，体无咎言。以尔车来，以我贿迁。”，却不能把它准确接回人物和前后故事。”；合并会挤掉必要首答、校准或故事回接。
+C206 两章接续以本页因序完成为前提；卜筮四词属“无法靠猜测可靠获得”的教师微讲项，拆入 C206 会稀释重建时间。
 【失败信号】
 默认画面出现卜筮→无咎→车来→贿迁完成流程；文化微讲扩展成占卜史；主体混淆未修订
 【声明边界】V5无插图桌面候选；不声称真实课堂或学生掌握已经通过。</a:t>
@@ -3678,9 +3678,9 @@
 故事已经走到迁嫁。第三章却没有立刻写婚后的日子，眼前先出现了一树桑叶。
 【V6.6逻辑页】C206｜逻辑页17｜6分钟
 【前页输入】
-学生已经完成前页任务，手中保留与“乘彼垝垣，以望复关。不见复关，泣涕涟涟。既见复关，载笑载言。尔卜尔筮，体无咎言。以尔车来，以我贿迁。”有关的原词或初稿。
+第一章章意在轨道第一格；C202／C204 的对照与因序完成；教材摊开可返。
 【唯一困难】
-学生容易看见“乘彼垝垣，以望复关。不见复关，泣涕涟涟。既见复关，载笑载言。尔卜尔筮，体无咎言。以尔车来，以我贿迁。”，却不能把它准确接回人物和前后故事。
+单章各自能讲后，章间因果（秋期之约→等待→迁移）仍是暗的；困难是接力讲时不分工、各自补出因果句——不复制 C105 的单人旁白模板。
 【唯一功能】
 把第一、二章接成‘约定怎样成为等待与迁移’，避免第二次复制章末模板。
 【文学对象】
@@ -3690,33 +3690,33 @@
 【学生主动作】
 每人先写两章各发生什么；同桌接力后各自补出章间因果
 【参与路径】
-个人先形成；需要交流时并行同桌或四人轮说；全班只公开少量有差异材料。
+个人两章概括90秒（台词明示“不要分工”）→同桌接力120秒→个人章间因果55秒→公开两组65秒→本人修订30秒。
 【可见产物】
 个人两章自然概括和秋期因果句
 【教师作用】
-准确释词、引用真实回答、追问原词、后置归纳并守住解释边界。
+巡视确认接力两人都讲；公开时板书两组因果句原文；不提供标准因果表述；修订归本人。
 【真实等待】
-逐字稿内有首答等待、限定反馈和本人修订的明确时间。
+时间盒明示五段；90秒个人概括与55秒因果句期间零插话。
 【反馈与本人修订】
-学生依据原词、同伴追问或教师校准，亲自保留、补充、改写或撤回初稿。
+公开两组后30秒本人修订自己的因果句；接力中卡壳由本人返诗补说，同桌不代讲。
 【首次后用】
 C301
 【正常反例】
-想不起、无新增、已经准确、不同意或暂时沉默均有诚实完成路径，不要求伪造改变。
+因果补不出先并排两句事实并标“关系待想”；接力卡壳返诗，不硬编。
 【主视觉职责】
 章间铰链
 【插图资格】
 无
 【第一人称接收】
-我刚才面对“乘彼垝垣，以望复关。不见复关，泣涕涟涟。既见复关，载笑载言。尔卜尔筮，体无咎言。以尔车来，以我贿迁。”，留下了个人两章自然概括和秋期因果句；我能用原词说清自己新增或修正的理解。
+我写了两章各一句概括、与同桌接力各讲过一章、并亲手补出一句章间因果（如“约在秋天，所以她天天登垣望”）；修订后因果句是我的。
 【故事回接】
-页面结束前由一句自然复述回到谁做了什么、人物处境怎样变化以及故事推进到哪里。
+约定怎样成为等待与迁移——两章连成一段；切页句转折：“第三章却没有立刻写婚后的日子，眼前先出现了一树桑叶”。
 【删除损失】
 删除会失去跨章因果
 【相邻反证】
-相邻页不同时处理“学生容易看见“乘彼垝垣，以望复关。不见复关，泣涕涟涟。既见复关，载笑载言。尔卜尔筮，体无咎言。以尔车来，以我贿迁。”，却不能把它准确接回人物和前后故事。”；合并会挤掉必要首答、校准或故事回接。
+与 C105 构成“单章重建→两章接续”的能力升级链；S 系列不再重复此式——综合页改用证据组织而非再讲故事。
 【失败信号】
-学生只能复述活动手续，不能复述诗意；首答前已经看见完成关系或答案；产物在后页没有真实消费者
+接力变成一人独讲两章；因果句由教师板书后学生抄；两章概括照抄章意格无一字新组织
 【声明边界】V5无插图桌面候选；不声称真实课堂或学生掌握已经通过。</a:t>
             </a:r>
             <a:endParaRPr lang="en-US" dirty="0"/>
@@ -3833,9 +3833,9 @@
 先不越过这片桑叶。它还没有落，叶子正是‘沃若’。这个词究竟让你看见什么？
 【V6.6逻辑页】C301｜逻辑页18｜4分钟
 【前页输入】
-学生已经完成前页任务，手中保留与“桑之未落，其叶沃若。于嗟鸠兮，无食桑葚。于嗟女兮，无与士耽。士之耽兮，犹可说也。女之耽兮，不可说也。”有关的原词或初稿。
+前两格故事轨道已连讲（C206 的两章因果）；学生尚未读第三章。
 【唯一困难】
-学生容易看见“桑之未落，其叶沃若。于嗟鸠兮，无食桑葚。于嗟女兮，无与士耽。士之耽兮，犹可说也。女之耽兮，不可说也。”，却不能把它准确接回人物和前后故事。
+迁嫁之后学生期待“接着讲婚后”，诗却转入桑叶与劝告；困难是不急着问“桑叶象征什么”，先完整接收这次换声并留下物象与劝告句。
 【唯一功能】
 发现迁嫁之后诗没有立即写婚后事件，而先转入物象和劝告。
 【文学对象】
@@ -3845,33 +3845,33 @@
 【学生主动作】
 完整读章；留下物象和换声句
 【参与路径】
-个人先形成；需要交流时并行同桌或四人轮说；全班只公开少量有差异材料。
+教师范读＋学生完整低声读85秒→个人读后生成55秒→同桌来源核对40秒→引用初稿转场25秒；个人生成先于任何交流。
 【可见产物】
 换声初稿
 【教师作用】
-准确释词、引用真实回答、追问原词、后置归纳并守住解释边界。
+恢复故事位置后退开；台词明示“先不要问桑叶象征什么，也不要找手法”；收束只引用换声初稿原句。
 【真实等待】
-逐字稿内有首答等待、限定反馈和本人修订的明确时间。
+时间盒明示：恢复35秒→范读与低声读85秒→个人生成55秒→同桌核对40秒→引用25秒；生成期零插话。
 【反馈与本人修订】
-学生依据原词、同伴追问或教师校准，亲自保留、补充、改写或撤回初稿。
+同桌核对“物象与换声句是否真在诗中”后修订；解释性联想本页不处理（留给 C302 假设卡）。
 【首次后用】
 C302—C303
 【正常反例】
-想不起、无新增、已经准确、不同意或暂时沉默均有诚实完成路径，不要求伪造改变。
+读不出换声的学生如实只留物象；“为什么插桑叶”的疑问先写在页边不展开。
 【主视觉职责】
 第三章完整换声
 【插图资格】
 无
 【第一人称接收】
-我刚才面对“桑之未落，其叶沃若。于嗟鸠兮，无食桑葚。于嗟女兮，无与士耽。士之耽兮，犹可说也。女之耽兮，不可说也。”，留下了换声初稿；我能用原词说清自己新增或修正的理解。
+我完整读了第三章，留下了物象（桑叶／斑鸠）与换声句（于嗟女兮…）；我注意到诗没有立刻写婚后事件，但先不解释为什么。
 【故事回接】
-页面结束前由一句自然复述回到谁做了什么、人物处境怎样变化以及故事推进到哪里。
+迁嫁之后诗先给一树未落的桑叶与两声劝告——叙事暂停、警告先行；切页句把“沃若”交给 C302 细看。
 【删除损失】
 删除会把比兴变成教师答案
 【相邻反证】
-相邻页不同时处理“学生容易看见“桑之未落，其叶沃若。于嗟鸠兮，无食桑葚。于嗟女兮，无与士耽。士之耽兮，犹可说也。女之耽兮，不可说也。”，却不能把它准确接回人物和前后故事。”；合并会挤掉必要首答、校准或故事回接。
+C302 逐句处理“沃若”；本页若提前释义桑叶，C302 的感官首答与 C303 的删句实验均被泄。
 【失败信号】
-学生只能复述活动手续，不能复述诗意；首答前已经看见完成关系或答案；产物在后页没有真实消费者
+首读态追问或回答了桑叶的象征义；换声句由教师预先圈好；学生把五句当成注释逐条抄
 【声明边界】V5无插图桌面候选；不声称真实课堂或学生掌握已经通过。</a:t>
             </a:r>
             <a:endParaRPr lang="en-US" dirty="0"/>
@@ -3986,9 +3986,9 @@
 先给这首诗一个最小的来处，再让她不被打断地把六章说完。
 【V6.6逻辑页】O03｜逻辑页3｜3分钟
 【前页输入】
-学生已经完成前页任务，手中保留与“《诗经·卫风·氓》的题名、出处与第一句”有关的原词或初稿。
+黑板长卷已在（O02 产物，含每组增量）；每人清单带新增栏；学生尚未见过课题、注音与出处。
 【唯一困难】
-学生容易看见“《诗经·卫风·氓》的题名、出处与第一句”，却不能把它准确接回人物和前后故事。
+学生刚经历大量同伴声音，注意力仍在“量”上；困难是教师准确引用现场原话把长卷归属给本班，再聚焦到一位先秦女子的声音而不丢弃刚才的成果。
 【唯一功能】
 教师用现场文学长卷完成后置归纳，再从众多旧作聚焦到一位先秦女子的声音，完成题名、正音和出处。
 【文学对象】
@@ -3998,19 +3998,19 @@
 【学生主动作】
 核对教师是否准确引用本班材料；读准méng并定位首句
 【参与路径】
-个人先形成；需要交流时并行同桌或四人轮说；全班只公开少量有差异材料。
+全班核对教师引用是否为本班原话（纠错即参与）→齐读正音一次；本页无小组环节，个人以“核对者”身份在场。
 【可见产物】
 主题谱照片和题名旁注音
 【教师作用】
-准确释词、引用真实回答、追问原词、后置归纳并守住解释边界。
+后置归纳：只从长卷选三条彼此不同的材料朗读，按学生当场纠正改写；不引入任何预备例子；正音 méng、板书“《诗经·卫风》”，不讲作者生平。
 【真实等待】
-逐字稿内有首答等待、限定反馈和本人修订的明确时间。
+三条引用后停顿等纠错（台词明示“如果这些不是你们刚才的原话，请立刻纠正我”）；正音后即转场，无展开讲解的停留。
 【反馈与本人修订】
 学生只纠正教师对现场篇名和主题的事实误记；教师当场改写。
 【首次后用】
 O04文化定位和O05起读
 【正常反例】
-想不起、无新增、已经准确、不同意或暂时沉默均有诚实完成路径，不要求伪造改变。
+被引用的学生可否认或修正自己的原话；无话可纠的学生只需目视黑板核对；注音后读不准不追读，后文跟读中自然校正。
 【主视觉职责】
 先由黑板长卷主导，再切换为题名和留白
 【插图资格】
@@ -4018,13 +4018,13 @@
 【第一人称接收】
 我看见本班文学回忆被准确保存，也知道新故事叫《氓》、读méng、出自《诗经·卫风》。
 【故事回接】
-页面结束前由一句自然复述回到谁做了什么、人物处境怎样变化以及故事推进到哪里。
+题名与“她自己说”确立叙事主体：接下来六章由这位女子第一人称讲完（切页句“让她不被打断地把六章说完”）。
 【删除损失】
 导入成为篇目堆积，揭题与现场发言断裂。
 【相邻反证】
 只有本页把导入的真实公共作品接到新文本；独立抽象转场页已经删除。
 【失败信号】
-学生只能复述活动手续，不能复述诗意；首答前已经看见完成关系或答案；产物在后页没有真实消费者
+教师引用了不在黑板上的篇目（=预填）；正音后学生仍读 máng；长卷未拍照留档即被擦除（S06 回望失去对照物）
 【声明边界】V5无插图桌面候选；不声称真实课堂或学生掌握已经通过。</a:t>
             </a:r>
             <a:endParaRPr lang="en-US" dirty="0"/>
@@ -4141,9 +4141,9 @@
 桑叶的意思先不封口。下一句，一声‘于嗟’落在斑鸠身上；再一声，又落到了谁身上？
 【V6.6逻辑页】C302｜逻辑页19｜4分钟
 【前页输入】
-学生已经完成前页任务，手中保留与“桑之未落，其叶沃若。”有关的原词或初稿。
+换声初稿已留物象（C301）；学生尚未给“沃若”任何书面解释。
 【唯一困难】
-学生容易看见“桑之未落，其叶沃若。”，却不能把它准确接回人物和前后故事。
+“沃若”最容易被“比喻女子年轻貌美”的熟悉答案直接封口；困难是先形成色泽、质地、生命感的感官词，并把解释留成可被后文检验的假设。
 【唯一功能】
 从‘沃若’形成色泽、质地和生命感，再留下可由后文检验的联想。
 【文学对象】
@@ -4153,33 +4153,33 @@
 【学生主动作】
 写两个感官词；留下一种可能
 【参与路径】
-个人先形成；需要交流时并行同桌或四人轮说；全班只公开少量有差异材料。
+个人口译与校准44秒→静默观察写感官词43秒→两项假设独立生成63秒→同桌依据追问43秒→个人修订47秒；假设严格个人先行。
 【可见产物】
 桑叶假设
 【教师作用】
-准确释词、引用真实回答、追问原词、后置归纳并守住解释边界。
+给“沃若＝润泽”的最小校准后即退；不提供任何象征答案；追问只问“你的依据是哪个词”，不评对错。
 【真实等待】
-逐字稿内有首答等待、限定反馈和本人修订的明确时间。
+时间盒明示：口译44秒→静默观察43秒（台词“静静看十秒”）→独立假设63秒→同桌追问43秒→修订47秒；假设生成期零插话零示例。
 【反馈与本人修订】
-学生依据原词、同伴追问或教师校准，亲自保留、补充、改写或撤回初稿。
+同桌依据追问后修订假设措辞（不是换答案）；修订权在作者本人。
 【首次后用】
 C402真修订
 【正常反例】
-想不起、无新增、已经准确、不同意或暂时沉默均有诚实完成路径，不要求伪造改变。
+感官词写不出的先留一个；两个解释想不全就写一个＋“另一种待想”，不借同桌的。
 【主视觉职责】
 青润桑叶与原词
 【插图资格】
 I04a待A/B
 【第一人称接收】
-我刚才面对“桑之未落，其叶沃若。”，留下了桑叶假设；我能用原词说清自己新增或修正的理解。
+我静静看了这行诗十秒，写下两个能被“沃若”托住的感官词和两种可能解释；我知道这只是假设，第四章会来检验它。
 【故事回接】
-页面结束前由一句自然复述回到谁做了什么、人物处境怎样变化以及故事推进到哪里。
+桑叶的意思先不封口——切页句把第二声“于嗟”引向斑鸠与女子；本页假设卡成为第四章的真实待证材料。
 【删除损失】
 删除会退回标准象征义
 【相邻反证】
-相邻页不同时处理“学生容易看见“桑之未落，其叶沃若。”，却不能把它准确接回人物和前后故事。”；合并会挤掉必要首答、校准或故事回接。
+C402 将以“桑之落矣”真检验本页假设（经历后文改变前文）；若本页提前给唯一解释，C402 的保留／改写／撤回三选即无对象。
 【失败信号】
-学生只能复述活动手续，不能复述诗意；首答前已经看见完成关系或答案；产物在后页没有真实消费者
+教师说出“比喻女子青春”类封口答案；假设卡上只有一个标准答案且全班相同；感官词抄自注释
 【声明边界】V5无插图桌面候选；不声称真实课堂或学生掌握已经通过。</a:t>
             </a:r>
             <a:endParaRPr lang="en-US" dirty="0"/>
@@ -4295,9 +4295,9 @@
 现在把纸移开，让桑叶和斑鸠重新回来。
 【V6.6逻辑页】C303A｜逻辑页20｜3分钟
 【前页输入】
-学生已经完成前页任务，手中保留与“桑之未落，其叶沃若。于嗟鸠兮，无食桑葚！于嗟女兮，无与士耽！”有关的原词或初稿。
+第三章已完整读过（C301）；学生手头有换声初稿；空白纸一张用于盖句。
 【唯一困难】
-学生容易看见“桑之未落，其叶沃若。于嗟鸠兮，无食桑葚！于嗟女兮，无与士耽！”，却不能把它准确接回人物和前后故事。
+完整读过第三章后，学生难以察觉劝女句对前两句的依赖；困难是有意删句重听（而非假装忘记），真实感受句群被抽空后的声音损失。
 【唯一功能】
 在已经读过第三章以后，有意删去桑叶和斑鸠两句重新听劝女句，感受原诗句群被抽空后的声音损失。
 【文学对象】
@@ -4307,19 +4307,19 @@
 【学生主动作】
 有意删去前两句后再听劝女句；写删句后的声音变化
 【参与路径】
-个人先形成；需要交流时并行同桌或四人轮说；全班只公开少量有差异材料。
+说明删句实验边界35秒→删句再听与个人记录75秒→两份公开45秒→封存转场25秒；记录严格个人、再听时无声。
 【可见产物】
 删句再听记录
 【教师作用】
-准确释词、引用真实回答、追问原词、后置归纳并守住解释边界。
+只宣实验边界（“不假装忘记前文”）；再听期间零提示；公开两份记录时不作优劣比较。
 【真实等待】
-逐字稿内有首答等待、限定反馈和本人修订的明确时间。
+时间盒明示：边界35秒→删句再听75秒（教师不读不评）→公开45秒→封存25秒。
 【反馈与本人修订】
-学生依据原词、同伴追问或教师校准，亲自保留、补充、改写或撤回初稿。
+本页无修订——删句记录封存，待 C303B 恢复句群后比较修订（两页构成一次实验的对照臂）。
 【首次后用】
 C303B恢复句群后比较
 【正常反例】
-想不起、无新增、已经准确、不同意或暂时沉默均有诚实完成路径，不要求伪造改变。
+听不出差别的学生如实写“暂时没听出少了什么”；记录不要求术语。
 【主视觉职责】
 唯一暴露的劝女原句和大面积暗色留白
 【插图资格】
@@ -4327,7 +4327,7 @@
 【第一人称接收】
 我明知前文存在，却故意拿掉两句再听，感到了句群被删后的声音变化。
 【故事回接】
-页面结束前由一句自然复述回到谁做了什么、人物处境怎样变化以及故事推进到哪里。
+劝告被抽空物象后单薄地悬着——声音损失本身是“兴”存在的证据；切页句：“把纸移开，让桑叶和斑鸠重新回来”。
 【删除损失】
 无法把比兴从术语还原为句群有无造成的可感差异。
 【相邻反证】
@@ -4447,9 +4447,9 @@
 你们已经听见差异，现在再给这种写法准确的名字。
 【V6.6逻辑页】C303B｜逻辑页21｜5分钟
 【前页输入】
-学生已经完成前页任务，手中保留与“桑之未落，其叶沃若。于嗟鸠兮，无食桑葚！于嗟女兮，无与士耽！”有关的原词或初稿。
+删句记录在手（C303A 封存物）；三章已读；尚未接触比兴术语。
 【唯一困难】
-学生容易看见“桑之未落，其叶沃若。于嗟鸠兮，无食桑葚！于嗟女兮，无与士耽！”，却不能把它准确接回人物和前后故事。
+恢复句群后，学生易直接接受“比兴”定义而跳过比较；困难是先用自己的词说出“回来以后我多听见了什么”，再接受后置命名。
 【唯一功能】
 恢复完整句群，让学生比较删句前后声音增加了什么，再后置命名由物起声、由物及人的兴与比。
 【文学对象】
@@ -4459,19 +4459,19 @@
 【学生主动作】
 恢复并连读三句；比较删句记录并用原词修订
 【参与路径】
-个人先形成；需要交流时并行同桌或四人轮说；全班只公开少量有差异材料。
+恢复句群连读50秒→前后比较与个人修订85秒→公开两份与原词追问65秒→释词、命名比兴与重读100秒；比较先于命名。
 【可见产物】
 由物及人的比较修订句
 【教师作用】
-准确释词、引用真实回答、追问原词、后置归纳并守住解释边界。
+追问只用原词（“多听见的是哪个字给的声音？”）；比兴命名在学生比较句出现之后（后置归纳）；随后领一次重读体会由物及人。
 【真实等待】
-逐字稿内有首答等待、限定反馈和本人修订的明确时间。
+时间盒明示：连读50秒→个人比较修订85秒→公开65秒→命名与重读100秒；修订期内不出现术语。
 【反馈与本人修订】
-学生依据原词、同伴追问或教师校准，亲自保留、补充、改写或撤回初稿。
+在删句记录下方续写“原句回来以后，我又听见了____，因为____”——旧记录保留，修订以续写呈现（修订痕迹本身是证据）。
 【首次后用】
 C305处境对照；S06艺术收纳
 【正常反例】
-想不起、无新增、已经准确、不同意或暂时沉默均有诚实完成路径，不要求伪造改变。
+比较多不出的学生重听一遍后再写；不接受术语（比／兴）替换自己的话作为比较句。
 【主视觉职责】
 桑—鸠—女三句的连续声音，不预画完成箭头
 【插图资格】
@@ -4479,7 +4479,7 @@
 【第一人称接收】
 我比较了有意删句与恢复原句时的声音差异，再理解比兴怎样从桑、鸠来到女子。
 【故事回接】
-页面结束前由一句自然复述回到谁做了什么、人物处境怎样变化以及故事推进到哪里。
+声音由物来到人（桑叶→斑鸠→女子），“兴”在经验后获得名字；切页句把“耽”的男女差异交给 C305。
 【删除损失】
 比兴仍是没有经历的术语。
 【相邻反证】
@@ -4599,9 +4599,9 @@
 声音由物来到人，同一个‘耽’落在男女身上却并不相同。
 【V6.6逻辑页】C303B｜逻辑页21｜5分钟
 【前页输入】
-学生已经完成前页任务，手中保留与“桑之未落，其叶沃若。于嗟鸠兮，无食桑葚！于嗟女兮，无与士耽！”有关的原词或初稿。
+删句记录在手（C303A 封存物）；三章已读；尚未接触比兴术语。
 【唯一困难】
-学生容易看见“桑之未落，其叶沃若。于嗟鸠兮，无食桑葚！于嗟女兮，无与士耽！”，却不能把它准确接回人物和前后故事。
+恢复句群后，学生易直接接受“比兴”定义而跳过比较；困难是先用自己的词说出“回来以后我多听见了什么”，再接受后置命名。
 【唯一功能】
 恢复完整句群，让学生比较删句前后声音增加了什么，再后置命名由物起声、由物及人的兴与比。
 【文学对象】
@@ -4611,19 +4611,19 @@
 【学生主动作】
 恢复并连读三句；比较删句记录并用原词修订
 【参与路径】
-个人先形成；需要交流时并行同桌或四人轮说；全班只公开少量有差异材料。
+恢复句群连读50秒→前后比较与个人修订85秒→公开两份与原词追问65秒→释词、命名比兴与重读100秒；比较先于命名。
 【可见产物】
 由物及人的比较修订句
 【教师作用】
-准确释词、引用真实回答、追问原词、后置归纳并守住解释边界。
+追问只用原词（“多听见的是哪个字给的声音？”）；比兴命名在学生比较句出现之后（后置归纳）；随后领一次重读体会由物及人。
 【真实等待】
-逐字稿内有首答等待、限定反馈和本人修订的明确时间。
+时间盒明示：连读50秒→个人比较修订85秒→公开65秒→命名与重读100秒；修订期内不出现术语。
 【反馈与本人修订】
-学生依据原词、同伴追问或教师校准，亲自保留、补充、改写或撤回初稿。
+在删句记录下方续写“原句回来以后，我又听见了____，因为____”——旧记录保留，修订以续写呈现（修订痕迹本身是证据）。
 【首次后用】
 C305处境对照；S06艺术收纳
 【正常反例】
-想不起、无新增、已经准确、不同意或暂时沉默均有诚实完成路径，不要求伪造改变。
+比较多不出的学生重听一遍后再写；不接受术语（比／兴）替换自己的话作为比较句。
 【主视觉职责】
 桑—鸠—女三句的连续声音，不预画完成箭头
 【插图资格】
@@ -4631,7 +4631,7 @@
 【第一人称接收】
 我比较了有意删句与恢复原句时的声音差异，再理解比兴怎样从桑、鸠来到女子。
 【故事回接】
-页面结束前由一句自然复述回到谁做了什么、人物处境怎样变化以及故事推进到哪里。
+声音由物来到人（桑叶→斑鸠→女子），“兴”在经验后获得名字；切页句把“耽”的男女差异交给 C305。
 【删除损失】
 比兴仍是没有经历的术语。
 【相邻反证】
@@ -4754,45 +4754,45 @@
 五句诗已经逐句走过。现在撤去局部提示，把桑叶、两声劝告和脱身差异讲回女子的一段回望。
 【V6.6逻辑页】C305｜逻辑页22｜5分钟
 【前页输入】
-学生已经完成前页任务，手中保留与“士之耽兮，犹可说也。女之耽兮，不可说也！”有关的原词或初稿。
+劝告句群已连读（C303B）；学生尚未处理末两句。
 【唯一困难】
-学生容易看见“士之耽兮，犹可说也。女之耽兮，不可说也！”，却不能把它准确接回人物和前后故事。
+“女之耽不可说”极易滑成“女子太傻／男子负心”的归因；困难是只用诗中明写（耽／说相同，士女／可不可不同）写一条处境对照句，不越出文本。
 【唯一功能】
 从相同‘耽/说’和不同‘士/女、可/不可’读出处境不对等。
 【文学对象】
 士之耽兮，犹可说也。女之耽兮，不可说也！
 【信息状态】
-首答前只给原诗、必要字面和一个自然问题；解释、分类、关系与代表答案在学生首稿后出现。
+首答态只有两句原诗与圈框任务；“说＝脱”校准在个人口译后给出；归因式结论（谁负心）不出现。
 【学生主动作】
 写一条只陈述诗中处境的对照句
 【参与路径】
-个人先形成；需要交流时并行同桌或四人轮说；全班只公开少量有差异材料。
+个人口译与通假义58秒→同异圈框50秒→处境句生成63秒→同桌越界词核查46秒→作者修订与边界校准58秒→连读25秒。
 【可见产物】
 处境判断
 【教师作用】
-准确释词、引用真实回答、追问原词、后置归纳并守住解释边界。
+给“说＝tuō，同脱”的最小校准；核查环节只辨“诗里写了／我推断”；校准责任边界（处境不同是诗写的事实，不引申为性别论断）。
 【真实等待】
-逐字稿内有首答等待、限定反馈和本人修订的明确时间。
+时间盒明示六段；处境句生成63秒零插话；越界核查同桌执行、作者本人改。
 【反馈与本人修订】
-学生依据原词、同伴追问或教师校准，亲自保留、补充、改写或撤回初稿。
+越界词被指出后由作者本人降格（改回“诗写”或删除）；修订后的句子保留原句对照。
 【首次后用】
 第四、五章验证并由S03回收
 【正常反例】
-想不起、无新增、已经准确、不同意或暂时沉默均有诚实完成路径，不要求伪造改变。
+写不出整句的先列两组词的差异；“我推断”标注后允许保留，不算失败。
 【主视觉职责】
 两句并排
 【插图资格】
 无
 【第一人称接收】
-我刚才面对“士之耽兮，犹可说也。女之耽兮，不可说也！”，留下了处境判断；我能用原词说清自己新增或修正的理解。
+我圈出了完全相同的词（耽／说）、框住了改变结果的词（士／女、可／不可），写出了一条只陈述诗中处境的对照句；越界词被同桌核查过。
 【故事回接】
-页面结束前由一句自然复述回到谁做了什么、人物处境怎样变化以及故事推进到哪里。
+同一个“耽”，脱身处境并不相同——警告落定为处境事实；切页句把五章合起来交给 C306 整体重讲。
 【删除损失】
 删除会把劝女归为天性论
 【相邻反证】
-相邻页不同时处理“学生容易看见“士之耽兮，犹可说也。女之耽兮，不可说也！”，却不能把它准确接回人物和前后故事。”；合并会挤掉必要首答、校准或故事回接。
+第四、五章将验证这条处境句并由 S03 回收原因判断；本页若提前给原因，S03 的因果链首答即被泄。
 【失败信号】
-学生只能复述活动手续，不能复述诗意；首答前已经看见完成关系或答案；产物在后页没有真实消费者
+处境句写成对男子的道德审判；“可／不可”被教师预先框出；对照句抄注释而无圈框痕迹
 【声明边界】V5无插图桌面候选；不声称真实课堂或学生掌握已经通过。</a:t>
             </a:r>
             <a:endParaRPr lang="en-US" dirty="0"/>
@@ -4910,7 +4910,7 @@
 【前页输入】
 学生已经体验由物及人的比兴，并读出处境不等。
 【唯一困难】
-学生容易看见“桑之未落，其叶沃若。于嗟鸠兮，无食桑葚。于嗟女兮，无与士耽。士之耽兮，犹可说也。女之耽兮，不可说也。”，却不能把它准确接回人物和前后故事。
+物象、劝告、处境差异三层都走过之后，学生仍可能并列复述；困难是把“经历后的回望”这一层也讲进章意——这像当时她旁边人的事后感叹，而不是现场日记。
 【唯一功能】
 让每个人把第三章的物象、由物及人的劝告、男女处境差异和经历后回望重新讲成一段。
 【文学对象】
@@ -4924,15 +4924,15 @@
 【可见产物】
 个人第三章自然章意
 【教师作用】
-准确释词、引用真实回答、追问原词、后置归纳并守住解释边界。
+只给“当时旁人／事后回望”的视角提示，不给章意框架；公开一份后由他人定位断点；修订归本人。
 【真实等待】
-逐字稿内有首答等待、限定反馈和本人修订的明确时间。
+时间盒明示：完整重读35秒→个人自然章意95秒→合书低声口述与返诗55秒→公开一份55秒；章意撰写期零提示。
 【反馈与本人修订】
-学生依据原词、同伴追问或教师校准，亲自保留、补充、改写或撤回初稿。
+公开定位断点后本人返诗修订章意；口述断点即补说。
 【首次后用】
 C401进入桑叶落下；C606六章检索
 【正常反例】
-想不起、无新增、已经准确、不同意或暂时沉默均有诚实完成路径，不要求伪造改变。
+章意写不出“回望”层的先写三层事实再标注“感叹待补”；口述卡壳返诗，不背书。
 【主视觉职责】
 第三章完整原诗和一条开放叙事入口
 【插图资格】
@@ -4940,7 +4940,7 @@
 【第一人称接收】
 我能把比兴和处境差异放回迁嫁后的回望，而不只记一个术语。
 【故事回接】
-页面结束前由一句自然复述回到谁做了什么、人物处境怎样变化以及故事推进到哪里。
+第三章以“警告＋回望”形态收束并写入轨道；切页句转折：“第四章，桑叶真正落下，婚后的生活也随之出现”。
 【删除损失】
 第三章仍是比兴术语和两句性别对照，不能接回故事。
 【相邻反证】
@@ -5063,45 +5063,45 @@
 先回到那片桑叶。第三章它‘沃若’，这一章却‘黄而陨’；你原来的两种想法，经得住这一落吗？
 【V6.6逻辑页】C401｜逻辑页24｜4分钟
 【前页输入】
-学生已经完成前页任务，手中保留与“桑之落矣，其黄而陨。自我徂尔，三岁食贫。淇水汤汤，渐车帷裳。女也不爽，士贰其行。士也罔极，二三其德。”有关的原词或初稿。
+手边有两件未封口材料：沃若双假设卡与“为何女子更难脱身”问号（C302/C305 产物）；尚未读第四章。
 【唯一困难】
-学生容易看见“桑之落矣，其黄而陨。自我徂尔，三岁食贫。淇水汤汤，渐车帷裳。女也不爽，士贰其行。士也罔极，二三其德。”，却不能把它准确接回人物和前后故事。
+学生易把“女也不爽，士贰其行”直接读成情绪控诉；困难是整章读时先分三区——物象、生活事实、责任判断——让判断有事实托底。
 【唯一功能】
 先找到重现的桑，再区分生活事实和责任判断。
 【文学对象】
 桑之落矣，其黄而陨。自我徂尔，三岁食贫。淇水汤汤，渐车帷裳。女也不爽，士贰其行。士也罔极，二三其德。
 【信息状态】
-首答前只给原诗、必要字面和一个自然问题；解释、分类、关系与代表答案在学生首稿后出现。
+首读态只有原诗与三区标记任务；假设卡与问号此刻不打开（台词明示“不急着打开答案”）；责任结论不出现。
 【学生主动作】
 整章读；圈物象、画事实、框判断
 【参与路径】
-个人先形成；需要交流时并行同桌或四人轮说；全班只公开少量有差异材料。
+恢复待证材料30秒→范读与完整朗读85秒→个人两项初稿55秒→同桌来源核对40秒→引用转场30秒。
 【可见产物】
 章内三区
 【教师作用】
-准确释词、引用真实回答、追问原词、后置归纳并守住解释边界。
+宣“两件材料先放一边不打开”；巡视确认三区标记；引用现场原句收束，不预告桑叶答案。
 【真实等待】
-逐字稿内有首答等待、限定反馈和本人修订的明确时间。
+时间盒明示五段；个人初稿55秒零插话。
 【反馈与本人修订】
-学生依据原词、同伴追问或教师校准，亲自保留、补充、改写或撤回初稿。
+同桌核对三区归属后修订标记；判断词误入事实区的移回。
 【首次后用】
 C402—C404_405
 【正常反例】
-想不起、无新增、已经准确、不同意或暂时沉默均有诚实完成路径，不要求伪造改变。
+三区分不清的句子先归“待定”区；假设卡忍住不翻的学生如实等待。
 【主视觉职责】
 完整第四章三区
 【插图资格】
 无
 【第一人称接收】
-我刚才面对“桑之落矣，其黄而陨。自我徂尔，三岁食贫。淇水汤汤，渐车帷裳。女也不爽，士贰其行。士也罔极，二三其德。”，留下了章内三区；我能用原词说清自己新增或修正的理解。
+我完整读了第四章，圈出物象、画出生活事实、框出判断词；我能指出哪一句是“发生了什么”、哪一句是“她说谁变了”。
 【故事回接】
-页面结束前由一句自然复述回到谁做了什么、人物处境怎样变化以及故事推进到哪里。
+桑叶重现但已“黄而陨”，生活事实（食贫／渡水）与责任判断（不爽／贰行）同章出现；切页句把旧假设推向检验。
 【删除损失】
 删除会失去事实与判断的边界
 【相邻反证】
-相邻页不同时处理“学生容易看见“桑之落矣，其黄而陨。自我徂尔，三岁食贫。淇水汤汤，渐车帷裳。女也不爽，士贰其行。士也罔极，二三其德。”，却不能把它准确接回人物和前后故事。”；合并会挤掉必要首答、校准或故事回接。
+C402 才翻回假设卡检验；本页若先释“黄而陨”的对照义，C402 的保留／改写／撤回首答即被泄。
 【失败信号】
-学生只能复述活动手续，不能复述诗意；首答前已经看见完成关系或答案；产物在后页没有真实消费者
+首读态打开并讲解了假设卡；判断词被当成事实画出；教师预告桑叶落下的象征义
 【声明边界】V5无插图桌面候选；不声称真实课堂或学生掌握已经通过。</a:t>
             </a:r>
             <a:endParaRPr lang="en-US" dirty="0"/>
@@ -5218,45 +5218,45 @@
 桑叶由盛转衰，诗也从劝告走进日子。接下来的两句，一句压着多年，一句忽然把淇水推到眼前。
 【V6.6逻辑页】C402｜逻辑页25｜5分钟
 【前页输入】
-学生已经完成前页任务，手中保留与“桑之未落，其叶沃若。桑之落矣，其黄而陨。”有关的原词或初稿。
+沃若双假设卡在手（C302 产物，未封口）；刚读完第四章首句“黄而陨”。
 【唯一困难】
-学生容易看见“桑之未落，其叶沃若。桑之落矣，其黄而陨。”，却不能把它准确接回人物和前后故事。
+后文检验前文时，学生最省力的动作是“换一个新答案”；困难是真翻回第三章旧卡，在保留／改写／撤回三选中作出决定并补新依据。
 【唯一功能】
 用后文真正检验前文的桑叶解释，经历后文改变前文。
 【文学对象】
 桑之未落，其叶沃若。桑之落矣，其黄而陨。
 【信息状态】
-首答前只给原诗、必要字面和一个自然问题；解释、分类、关系与代表答案在学生首稿后出现。
+旧卡此刻翻回（真实分发时点）；两句并读；“陨＝坠落”校准后置；教师不给“正确解释”。
 【学生主动作】
 保留、改写或撤回旧假设；补新依据
 【参与路径】
-个人先形成；需要交流时并行同桌或四人轮说；全班只公开少量有差异材料。
+恢复旧稿对读54秒→圈状态词与校准46秒→个人三选83秒→同桌追问语境依据54秒→再修与教师后置归纳63秒。
 【可见产物】
 桑叶解释修订
 【教师作用】
-准确释词、引用真实回答、追问原词、后置归纳并守住解释边界。
+两句同节拍各读两遍的领读者；“陨”校准者；归纳后置——只在学生三选完成后引用原话整理，不给唯一答案。
 【真实等待】
-逐字稿内有首答等待、限定反馈和本人修订的明确时间。
+时间盒明示五段；三选83秒零插话零示例。
 【反馈与本人修订】
-学生依据原词、同伴追问或教师校准，亲自保留、补充、改写或撤回初稿。
+同桌追问依据后可再修一次；改写与撤回须在旧卡上留痕（划线保留原句）。
 【首次后用】
 C406与S06
 【正常反例】
-想不起、无新增、已经准确、不同意或暂时沉默均有诚实完成路径，不要求伪造改变。
+两个假设都舍不得删的允许“保留但降格”；依据找不出的标“待第四章后再验”。
 【主视觉职责】
 同枝前后状态
 【插图资格】
 I04c待A/B
 【第一人称接收】
-我刚才面对“桑之未落，其叶沃若。桑之落矣，其黄而陨。”，留下了桑叶解释修订；我能用原词说清自己新增或修正的理解。
+我把旧卡翻回来（没有另起新纸），对读两句后作出了三选之一并补了新依据（如“黄而陨”顶住了“茂盛”的解释）；旧答案的改动痕迹在卡上。
 【故事回接】
-页面结束前由一句自然复述回到谁做了什么、人物处境怎样变化以及故事推进到哪里。
+桑叶由盛转衰，解释随证据修订——诗从劝告走进日子；切页句把“三岁食贫／淇水汤汤”交给 C403。
 【删除损失】
 删除会让意象理解仍是猜答案
 【相邻反证】
-相邻页不同时处理“学生容易看见“桑之未落，其叶沃若。桑之落矣，其黄而陨。”，却不能把它准确接回人物和前后故事。”；合并会挤掉必要首答、校准或故事回接。
+本页是“经历后文改变前文”的机制实现（U3/U8）；若允许另起新纸，前文理解的变化不可见，检验退化为替换。
 【失败信号】
-学生只能复述活动手续，不能复述诗意；首答前已经看见完成关系或答案；产物在后页没有真实消费者
+学生另起新纸写答案（检验不可见）；教师宣布标准解释后学生照抄三选；旧假设无人选择撤回（全保留＝假检验）
 【声明边界】V5无插图桌面候选；不声称真实课堂或学生掌握已经通过。</a:t>
             </a:r>
             <a:endParaRPr lang="en-US" dirty="0"/>
@@ -5374,9 +5374,9 @@
 多年食贫，淇水浸帷，这是她讲出的经历。紧接着，她不再只讲发生了什么，而开始说：谁没有差错，谁的行为变了。
 【V6.6逻辑页】C403｜逻辑页26｜5分钟
 【前页输入】
-学生已经完成前页任务，手中保留与“自我徂尔，三岁食贫。淇水汤汤，渐车帷裳。”有关的原词或初稿。
+桑叶解释已修订（C402）；四项音义（徂／食贫／汤汤／渐）待校准。
 【唯一困难】
-学生容易看见“自我徂尔，三岁食贫。淇水汤汤，渐车帷裳。”，却不能把它准确接回人物和前后故事。
+“三岁食贫”是压在一起的多年，“淇水汤汤”是推到眼前的片刻；困难是让长时与瞬间同时存在于一段双镜头旁白，而不是概括成“生活艰苦”。
 【唯一功能】
 让多年生活与当下渡水片刻同时存在。
 【文学对象】
@@ -5386,33 +5386,33 @@
 【学生主动作】
 听长时与展开的声音；写双时间旁白
 【参与路径】
-个人先形成；需要交流时并行同桌或四人轮说；全班只公开少量有差异材料。
+个人口译与定点释义61秒→两轮分部朗读与闭眼听64秒→个人双镜头旁白61秒→同桌越界词核查39秒→作者修订分享与转场75秒。
 【可见产物】
 双时间旁白
 【教师作用】
-准确释词、引用真实回答、追问原词、后置归纳并守住解释边界。
+四项音义的最小校准者；分部朗读的组织者；闭眼听期间零语言；分享只引旁白原句不评文采。
 【真实等待】
-逐字稿内有首答等待、限定反馈和本人修订的明确时间。
+时间盒明示五段；旁白撰写61秒与闭眼听64秒期间零插话。
 【反馈与本人修订】
-学生依据原词、同伴追问或教师校准，亲自保留、补充、改写或撤回初稿。
+越界词核查后作者本人改写；重听后允许调换两个镜头的顺序并说明理由。
 【首次后用】
 C404_405与S02
 【正常反例】
-想不起、无新增、已经准确、不同意或暂时沉默均有诚实完成路径，不要求伪造改变。
+双镜头写不出的先分别写“多年一句＋当天一句”不要求衔接；听不出的如实写感受不到时间差。
 【主视觉职责】
 多年与片刻并置
 【插图资格】
 I05待A/B
 【第一人称接收】
-我刚才面对“自我徂尔，三岁食贫。淇水汤汤，渐车帷裳。”，留下了双时间旁白；我能用原词说清自己新增或修正的理解。
+我闭眼听了两轮分部朗读，写了一段双时间旁白——一句压着多年、一句推到眼前；越界词被同桌核查过，修订后是我的。
 【故事回接】
-页面结束前由一句自然复述回到谁做了什么、人物处境怎样变化以及故事推进到哪里。
+多年食贫、淇水浸帷——她讲出的经历有了两种时间；切页句：“她不再只讲发生了什么，而开始说谁没有差错、谁的行为变了”。
 【删除损失】
 删除会让责任判断缺少婚后事实
 【相邻反证】
-相邻页不同时处理“学生容易看见“自我徂尔，三岁食贫。淇水汤汤，渐车帷裳。”，却不能把它准确接回人物和前后故事。”；合并会挤掉必要首答、校准或故事回接。
+C404_405 处理责任词链；时间体验与责任判断是两种经验；本页旁白将被 S02 生活事实直接取回，不可省。
 【失败信号】
-学生只能复述活动手续，不能复述诗意；首答前已经看见完成关系或答案；产物在后页没有真实消费者
+旁白被概括成“生活很苦”一句；闭眼听被取消或插话；教师示范了双镜头写法
 【声明边界】V5无插图桌面候选；不声称真实课堂或学生掌握已经通过。</a:t>
             </a:r>
             <a:endParaRPr lang="en-US" dirty="0"/>
@@ -5526,45 +5526,45 @@
 两份真实标法已经抽出，下一页只比较分歧。
 【V6.6逻辑页】C404_405｜逻辑页27｜7分钟
 【前页输入】
-学生已经完成前页任务，手中保留与“女也不爽，士贰其行。士也罔极，二三其德。”有关的原词或初稿。
+生活事实与双时间旁白已完成（C403）；学生尚未面对责任四词。
 【唯一困难】
-学生容易看见“女也不爽，士贰其行。士也罔极，二三其德。”，却不能把它准确接回人物和前后故事。
+不爽／贰行／罔极／二三其德易被抄成四条注释；困难是先写此刻能确定的短义（不确定留问号），再把四组词排成逐步加重的证据链并分清谁在说谁。
 【唯一功能】
 把四组词连成逐步加重的责任证据链。
 【文学对象】
 女也不爽，士贰其行。士也罔极，二三其德。
 【信息状态】
-首答前只给原诗、必要字面和一个自然问题；解释、分类、关系与代表答案在学生首稿后出现。
+首答态只有两句原诗与短义任务；释义校准在公开首答之后（逐词）；责任结论的因果解释（为什么变）留给 S03。
 【学生主动作】
 排序着色四组词；用自然话说清责任
 【参与路径】
-个人先形成；需要交流时并行同桌或四人轮说；全班只公开少量有差异材料。
+连读与个人短义首答105秒→公开两份与逐词校准115秒→个人画关系与黑板质询120秒→责任边界、重读与转场80秒。
 【可见产物】
 责任证据链
 【教师作用】
-准确释词、引用真实回答、追问原词、后置归纳并守住解释边界。
+短义首答后才逐词校准（爽／贰／罔极／二三其德）；黑板只呈现学生的链并接受质询；边界守住“诗写行为与责任，不写原因”。
 【真实等待】
-逐字稿内有首答等待、限定反馈和本人修订的明确时间。
+时间盒明示四段；105秒首答期零提示（台词明示“不要先抄现成释义”）；质询期学生主导。
 【反馈与本人修订】
-学生依据原词、同伴追问或教师校准，亲自保留、补充、改写或撤回初稿。
+校准后回词修订短义；链条顺序在质询后可重排，本人执笔。
 【首次后用】
 C406与S03
 【正常反例】
-想不起、无新增、已经准确、不同意或暂时沉默均有诚实完成路径，不要求伪造改变。
+短义不确定就留问号待校准，不算错；排不出全链的先排两词并说明理由。
 【主视觉职责】
 四词递进链
 【插图资格】
 无
 【第一人称接收】
-我刚才面对“女也不爽，士贰其行。士也罔极，二三其德。”，留下了责任证据链；我能用原词说清自己新增或修正的理解。
+我在四个词下各写了短义（有问号的后来校准了），用深浅两色标出说女子与说男子的词，排出了一条逐步加重的链，并能用自然话说清“谁没有差错、谁变了”。
 【故事回接】
-页面结束前由一句自然复述回到谁做了什么、人物处境怎样变化以及故事推进到哪里。
+桑叶、生活事实、责任判断三层齐备；切页句：“只把这三层讲回一个完整故事”（交 C406）。
 【删除损失】
 拆页会把同一判断切碎并重复核查
 【相邻反证】
-相邻页不同时处理“学生容易看见“女也不爽，士贰其行。士也罔极，二三其德。”，却不能把它准确接回人物和前后故事。”；合并会挤掉必要首答、校准或故事回接。
+C406 章意与 S03 原因回收都以这条链为证据；本页若提前讲“为什么变”（时代／性格归因），S03 因果首答即被泄。
 【失败信号】
-学生只能复述活动手续，不能复述诗意；首答前已经看见完成关系或答案；产物在后页没有真实消费者
+短义首答前出现注释投影；链条由教师排好后学生着色；责任词被引申为对男子的人身审判
 【声明边界】V5无插图桌面候选；不声称真实课堂或学生掌握已经通过。</a:t>
             </a:r>
             <a:endParaRPr lang="en-US" dirty="0"/>
@@ -5831,45 +5831,45 @@
 人物已经分清，接下来把四个词的判断力度读出来。
 【V6.6逻辑页】C404_405｜逻辑页27｜7分钟
 【前页输入】
-学生已经完成前页任务，手中保留与“女也不爽，士贰其行。士也罔极，二三其德。”有关的原词或初稿。
+生活事实与双时间旁白已完成（C403）；学生尚未面对责任四词。
 【唯一困难】
-学生容易看见“女也不爽，士贰其行。士也罔极，二三其德。”，却不能把它准确接回人物和前后故事。
+不爽／贰行／罔极／二三其德易被抄成四条注释；困难是先写此刻能确定的短义（不确定留问号），再把四组词排成逐步加重的证据链并分清谁在说谁。
 【唯一功能】
 把四组词连成逐步加重的责任证据链。
 【文学对象】
 女也不爽，士贰其行。士也罔极，二三其德。
 【信息状态】
-首答前只给原诗、必要字面和一个自然问题；解释、分类、关系与代表答案在学生首稿后出现。
+首答态只有两句原诗与短义任务；释义校准在公开首答之后（逐词）；责任结论的因果解释（为什么变）留给 S03。
 【学生主动作】
 排序着色四组词；用自然话说清责任
 【参与路径】
-个人先形成；需要交流时并行同桌或四人轮说；全班只公开少量有差异材料。
+连读与个人短义首答105秒→公开两份与逐词校准115秒→个人画关系与黑板质询120秒→责任边界、重读与转场80秒。
 【可见产物】
 责任证据链
 【教师作用】
-准确释词、引用真实回答、追问原词、后置归纳并守住解释边界。
+短义首答后才逐词校准（爽／贰／罔极／二三其德）；黑板只呈现学生的链并接受质询；边界守住“诗写行为与责任，不写原因”。
 【真实等待】
-逐字稿内有首答等待、限定反馈和本人修订的明确时间。
+时间盒明示四段；105秒首答期零提示（台词明示“不要先抄现成释义”）；质询期学生主导。
 【反馈与本人修订】
-学生依据原词、同伴追问或教师校准，亲自保留、补充、改写或撤回初稿。
+校准后回词修订短义；链条顺序在质询后可重排，本人执笔。
 【首次后用】
 C406与S03
 【正常反例】
-想不起、无新增、已经准确、不同意或暂时沉默均有诚实完成路径，不要求伪造改变。
+短义不确定就留问号待校准，不算错；排不出全链的先排两词并说明理由。
 【主视觉职责】
 四词递进链
 【插图资格】
 无
 【第一人称接收】
-我刚才面对“女也不爽，士贰其行。士也罔极，二三其德。”，留下了责任证据链；我能用原词说清自己新增或修正的理解。
+我在四个词下各写了短义（有问号的后来校准了），用深浅两色标出说女子与说男子的词，排出了一条逐步加重的链，并能用自然话说清“谁没有差错、谁变了”。
 【故事回接】
-页面结束前由一句自然复述回到谁做了什么、人物处境怎样变化以及故事推进到哪里。
+桑叶、生活事实、责任判断三层齐备；切页句：“只把这三层讲回一个完整故事”（交 C406）。
 【删除损失】
 拆页会把同一判断切碎并重复核查
 【相邻反证】
-相邻页不同时处理“学生容易看见“女也不爽，士贰其行。士也罔极，二三其德。”，却不能把它准确接回人物和前后故事。”；合并会挤掉必要首答、校准或故事回接。
+C406 章意与 S03 原因回收都以这条链为证据；本页若提前讲“为什么变”（时代／性格归因），S03 因果首答即被泄。
 【失败信号】
-学生只能复述活动手续，不能复述诗意；首答前已经看见完成关系或答案；产物在后页没有真实消费者
+短义首答前出现注释投影；链条由教师排好后学生着色；责任词被引申为对男子的人身审判
 【声明边界】V5无插图桌面候选；不声称真实课堂或学生掌握已经通过。</a:t>
             </a:r>
             <a:endParaRPr lang="en-US" dirty="0"/>
@@ -5983,45 +5983,45 @@
 词义已经分清，现在把第四章重新讲回桑叶落下后的生活。
 【V6.6逻辑页】C404_405｜逻辑页27｜7分钟
 【前页输入】
-学生已经完成前页任务，手中保留与“女也不爽，士贰其行。士也罔极，二三其德。”有关的原词或初稿。
+生活事实与双时间旁白已完成（C403）；学生尚未面对责任四词。
 【唯一困难】
-学生容易看见“女也不爽，士贰其行。士也罔极，二三其德。”，却不能把它准确接回人物和前后故事。
+不爽／贰行／罔极／二三其德易被抄成四条注释；困难是先写此刻能确定的短义（不确定留问号），再把四组词排成逐步加重的证据链并分清谁在说谁。
 【唯一功能】
 把四组词连成逐步加重的责任证据链。
 【文学对象】
 女也不爽，士贰其行。士也罔极，二三其德。
 【信息状态】
-首答前只给原诗、必要字面和一个自然问题；解释、分类、关系与代表答案在学生首稿后出现。
+首答态只有两句原诗与短义任务；释义校准在公开首答之后（逐词）；责任结论的因果解释（为什么变）留给 S03。
 【学生主动作】
 排序着色四组词；用自然话说清责任
 【参与路径】
-个人先形成；需要交流时并行同桌或四人轮说；全班只公开少量有差异材料。
+连读与个人短义首答105秒→公开两份与逐词校准115秒→个人画关系与黑板质询120秒→责任边界、重读与转场80秒。
 【可见产物】
 责任证据链
 【教师作用】
-准确释词、引用真实回答、追问原词、后置归纳并守住解释边界。
+短义首答后才逐词校准（爽／贰／罔极／二三其德）；黑板只呈现学生的链并接受质询；边界守住“诗写行为与责任，不写原因”。
 【真实等待】
-逐字稿内有首答等待、限定反馈和本人修订的明确时间。
+时间盒明示四段；105秒首答期零提示（台词明示“不要先抄现成释义”）；质询期学生主导。
 【反馈与本人修订】
-学生依据原词、同伴追问或教师校准，亲自保留、补充、改写或撤回初稿。
+校准后回词修订短义；链条顺序在质询后可重排，本人执笔。
 【首次后用】
 C406与S03
 【正常反例】
-想不起、无新增、已经准确、不同意或暂时沉默均有诚实完成路径，不要求伪造改变。
+短义不确定就留问号待校准，不算错；排不出全链的先排两词并说明理由。
 【主视觉职责】
 四词递进链
 【插图资格】
 无
 【第一人称接收】
-我刚才面对“女也不爽，士贰其行。士也罔极，二三其德。”，留下了责任证据链；我能用原词说清自己新增或修正的理解。
+我在四个词下各写了短义（有问号的后来校准了），用深浅两色标出说女子与说男子的词，排出了一条逐步加重的链，并能用自然话说清“谁没有差错、谁变了”。
 【故事回接】
-页面结束前由一句自然复述回到谁做了什么、人物处境怎样变化以及故事推进到哪里。
+桑叶、生活事实、责任判断三层齐备；切页句：“只把这三层讲回一个完整故事”（交 C406）。
 【删除损失】
 拆页会把同一判断切碎并重复核查
 【相邻反证】
-相邻页不同时处理“学生容易看见“女也不爽，士贰其行。士也罔极，二三其德。”，却不能把它准确接回人物和前后故事。”；合并会挤掉必要首答、校准或故事回接。
+C406 章意与 S03 原因回收都以这条链为证据；本页若提前讲“为什么变”（时代／性格归因），S03 因果首答即被泄。
 【失败信号】
-学生只能复述活动手续，不能复述诗意；首答前已经看见完成关系或答案；产物在后页没有真实消费者
+短义首答前出现注释投影；链条由教师排好后学生着色；责任词被引申为对男子的人身审判
 【声明边界】V5无插图桌面候选；不声称真实课堂或学生掌握已经通过。</a:t>
             </a:r>
             <a:endParaRPr lang="en-US" dirty="0"/>
@@ -6137,9 +6137,9 @@
 第四章已经把生活事实和责任说清。第五章会把三岁拆成每一天，又让屋外的笑声传进来。
 【V6.6逻辑页】C406｜逻辑页28｜6分钟
 【前页输入】
-学生已经完成前页任务，手中保留与“桑之落矣，其黄而陨。自我徂尔，三岁食贫。淇水汤汤，渐车帷裳。女也不爽，士贰其行。士也罔极，二三其德。”有关的原词或初稿。
+C402 假设已检验、C403 双时间旁白、C404_405 证据链在手；尚未写第四章章意。
 【唯一困难】
-学生容易看见“桑之落矣，其黄而陨。自我徂尔，三岁食贫。淇水汤汤，渐车帷裳。女也不爽，士贰其行。士也罔极，二三其德。”，却不能把它准确接回人物和前后故事。
+三层（物象／事实／责任）都走过，学生仍可能逐层罗列；困难是合成一段章意——且本页要求在教师板书模型之前独立成文，板书后置验证而非先给框架。
 【唯一功能】
 在教师三层板书模型后，独立完成第四章章意。
 【文学对象】
@@ -6149,31 +6149,31 @@
 【学生主动作】
 每人写第四章自然章意；合书口述并在断点返诗修订
 【参与路径】
-个人先形成；需要交流时并行同桌或四人轮说；全班只公开少量有差异材料。
+完整重读40秒→个人章意125秒→合书低声口述与返诗65秒→公开一份与定位断点60秒→教师后置板书与本人修订70秒。
 【可见产物】
 个人第四章自然章意
 【教师作用】
-准确释词、引用真实回答、追问原词、后置归纳并守住解释边界。
+章意期零提示（台词明示“不给三层标题”）；公开一份后由他人定位断点；板书在修订之前只作对照模型。
 【真实等待】
-逐字稿内有首答等待、限定反馈和本人修订的明确时间。
+时间盒明示五段；125秒独立章意期零插话。
 【反馈与本人修订】
-学生依据原词、同伴追问或教师校准，亲自保留、补充、改写或撤回初稿。
+断点返诗补说；板书出现后本人对照修订（只改自己认为该改处）。
 【首次后用】
 C501与S03
 【正常反例】
-想不起、无新增、已经准确、不同意或暂时沉默均有诚实完成路径，不要求伪造改变。
+章意先写三层关键词再连成句；口述断点如实返诗，不背板书。
 【主视觉职责】
 三层板书
 【插图资格】
 无
 【第一人称接收】
-我刚才面对“桑之落矣，其黄而陨。自我徂尔，三岁食贫。淇水汤汤，渐车帷裳。女也不爽，士贰其行。士也罔极，二三其德。”，留下了个人第四章自然章意；我能用原词说清自己新增或修正的理解。
+我先独立写出了第四章章意（没等三层标题），合书口述过、断点返诗补说过；教师板书后我对照修订了一处。
 【故事回接】
-页面结束前由一句自然复述回到谁做了什么、人物处境怎样变化以及故事推进到哪里。
+第四章以“桑落—食贫渡水—责任分明”收束并写入轨道；切页句预告第五章“把三岁拆成每一天，又让屋外的笑声传进来”。
 【删除损失】
 删除会使第四章三层关系散开
 【相邻反证】
-相邻页不同时处理“学生容易看见“桑之落矣，其黄而陨。自我徂尔，三岁食贫。淇水汤汤，渐车帷裳。女也不爽，士贰其行。士也罔极，二三其德。”，却不能把它准确接回人物和前后故事。”；合并会挤掉必要首答、校准或故事回接。
+教师三层板书模型若前置，本页退化为填表（G3 覆盖虚假）；与 C306 同构但能力升级——本页多了“独立成文先于模型”的要求。
 【失败信号】
 只有随机一人形成章意；学生只抄三层标题；个人文字没有任何原词或责任边界
 【声明边界】V5无插图桌面候选；不声称真实课堂或学生掌握已经通过。</a:t>
@@ -7372,7 +7372,7 @@
 【前页输入】
 学生知道作品来处，但尚未收到人物主题和三问框架。
 【唯一困难】
-学生容易看见“《氓》第一至第三章的完整声音”，却不能把它准确接回人物和前后故事。
+初次见面即逐句讲解会把完整声音切碎；困难是让前三章作为声音整体被接收——学生只留停点，不理解任务、不留答案。
 【唯一功能】
 不中断地接收第一至三章，让初见、等待、迁嫁和劝告先作为声音发生。
 【文学对象】
@@ -7382,33 +7382,33 @@
 【学生主动作】
 眼随声走；只在真实停顿处留点或问号
 【参与路径】
-个人先形成；需要交流时并行同桌或四人轮说；全班只公开少量有差异材料。
+个人与文本独处：静听＋教材旁留点/问号；本页无任何交流环节，停点不收集、不比较。
 【可见产物】
 教材停点
 【教师作用】
-准确释词、引用真实回答、追问原词、后置归纳并守住解释边界。
+朗读载体：教师连续听读承载节奏，零讲解零提问；声速与停顿本身就是本页唯一的教学行为。
 【真实等待】
-逐字稿内有首答等待、限定反馈和本人修订的明确时间。
+三分钟连续朗读零插话（时间盒：朗读全程）；停点标记随听随点、不打断跟读。
 【反馈与本人修订】
-学生依据原词、同伴追问或教师校准，亲自保留、补充、改写或撤回初稿。
+本页无修订；停点将在 O07 被取回转化为文字（初听卡）。
 【首次后用】
 O06无声接续
 【正常反例】
-想不起、无新增、已经准确、不同意或暂时沉默均有诚实完成路径，不要求伪造改变。
+没有停顿处“也只管继续听”（台词已含）；全篇无停点的学生如实不留标记，不造点。
 【主视觉职责】
 第一至三章原诗
 【插图资格】
 无
 【第一人称接收】
-我刚才面对“《氓》第一至第三章的完整声音”，留下了教材停点；我能用原词说清自己新增或修正的理解。
+我完整听完了第一至三章；在某句旁留下了自己的停点或问号；我知道那是我停下的地方，不是老师规定的重点。
 【故事回接】
-页面结束前由一句自然复述回到谁做了什么、人物处境怎样变化以及故事推进到哪里。
+声音层面经历初见→等待→迁嫁→劝告（一至三章事件在听中发生）；为 O06 后半段的婚变转折蓄势。
 【删除损失】
 删除会失去开放接收
 【相邻反证】
-相邻页不同时处理“学生容易看见“《氓》第一至第三章的完整声音”，却不能把它准确接回人物和前后故事。”；合并会挤掉必要首答、校准或故事回接。
+O05 与 O06 是一次不间断全文首读的两段物理承接（切页句“无声切页，朗读不断”）；若并入 O06，三章后的自然换气点与听者确认停点的时点消失。
 【失败信号】
-学生只能复述活动手续，不能复述诗意；首答前已经看见完成关系或答案；产物在后页没有真实消费者
+朗读被打断插入讲解；停点被教师收集比较（变成任务）；教师预告后三章内容（剧透）
 【声明边界】V5无插图桌面候选；不声称真实课堂或学生掌握已经通过。</a:t>
             </a:r>
             <a:endParaRPr lang="en-US" dirty="0"/>
@@ -7686,7 +7686,7 @@
 【文学对象】
 总角之宴，言笑晏晏。信誓旦旦，不思其反。
 【信息状态】
-六张原词卡为同一中性色、随机散放；学生首排以后才显示旧日与后来两组事实。
+六张原词卡等大、同一中性色，按对齐托盘排布；源顺序交错两个语义族，使任何一行或一列都不构成分组暗示；学生首排以后才显示旧日与后来两组事实。
 【学生主动作】
 完成旧日事实与后来事实双栏；讨论两个极端答案
 【参与路径】
@@ -7838,7 +7838,7 @@
 【文学对象】
 总角之宴，言笑晏晏。信誓旦旦，不思其反。
 【信息状态】
-六张原词卡为同一中性色、随机散放；学生首排以后才显示旧日与后来两组事实。
+六张原词卡等大、同一中性色，按对齐托盘排布；源顺序交错两个语义族，使任何一行或一列都不构成分组暗示；学生首排以后才显示旧日与后来两组事实。
 【学生主动作】
 完成旧日事实与后来事实双栏；讨论两个极端答案
 【参与路径】
@@ -9051,7 +9051,7 @@
 【前页输入】
 学生知道作品来处，但尚未收到人物主题和三问框架。
 【唯一困难】
-学生容易看见“《氓》第一至第三章的完整声音”，却不能把它准确接回人物和前后故事。
+初次见面即逐句讲解会把完整声音切碎；困难是让前三章作为声音整体被接收——学生只留停点，不理解任务、不留答案。
 【唯一功能】
 不中断地接收第一至三章，让初见、等待、迁嫁和劝告先作为声音发生。
 【文学对象】
@@ -9061,33 +9061,33 @@
 【学生主动作】
 眼随声走；只在真实停顿处留点或问号
 【参与路径】
-个人先形成；需要交流时并行同桌或四人轮说；全班只公开少量有差异材料。
+个人与文本独处：静听＋教材旁留点/问号；本页无任何交流环节，停点不收集、不比较。
 【可见产物】
 教材停点
 【教师作用】
-准确释词、引用真实回答、追问原词、后置归纳并守住解释边界。
+朗读载体：教师连续听读承载节奏，零讲解零提问；声速与停顿本身就是本页唯一的教学行为。
 【真实等待】
-逐字稿内有首答等待、限定反馈和本人修订的明确时间。
+三分钟连续朗读零插话（时间盒：朗读全程）；停点标记随听随点、不打断跟读。
 【反馈与本人修订】
-学生依据原词、同伴追问或教师校准，亲自保留、补充、改写或撤回初稿。
+本页无修订；停点将在 O07 被取回转化为文字（初听卡）。
 【首次后用】
 O06无声接续
 【正常反例】
-想不起、无新增、已经准确、不同意或暂时沉默均有诚实完成路径，不要求伪造改变。
+没有停顿处“也只管继续听”（台词已含）；全篇无停点的学生如实不留标记，不造点。
 【主视觉职责】
 第一至三章原诗
 【插图资格】
 无
 【第一人称接收】
-我刚才面对“《氓》第一至第三章的完整声音”，留下了教材停点；我能用原词说清自己新增或修正的理解。
+我完整听完了第一至三章；在某句旁留下了自己的停点或问号；我知道那是我停下的地方，不是老师规定的重点。
 【故事回接】
-页面结束前由一句自然复述回到谁做了什么、人物处境怎样变化以及故事推进到哪里。
+声音层面经历初见→等待→迁嫁→劝告（一至三章事件在听中发生）；为 O06 后半段的婚变转折蓄势。
 【删除损失】
 删除会失去开放接收
 【相邻反证】
-相邻页不同时处理“学生容易看见“《氓》第一至第三章的完整声音”，却不能把它准确接回人物和前后故事。”；合并会挤掉必要首答、校准或故事回接。
+O05 与 O06 是一次不间断全文首读的两段物理承接（切页句“无声切页，朗读不断”）；若并入 O06，三章后的自然换气点与听者确认停点的时点消失。
 【失败信号】
-学生只能复述活动手续，不能复述诗意；首答前已经看见完成关系或答案；产物在后页没有真实消费者
+朗读被打断插入讲解；停点被教师收集比较（变成任务）；教师预告后三章内容（剧透）
 【声明边界】V5无插图桌面候选；不声称真实课堂或学生掌握已经通过。</a:t>
             </a:r>
             <a:endParaRPr lang="en-US" dirty="0"/>
@@ -10724,7 +10724,7 @@
 【前页输入】
 学生知道作品来处，但尚未收到人物主题和三问框架。
 【唯一困难】
-学生容易看见“《氓》第一至第三章的完整声音”，却不能把它准确接回人物和前后故事。
+初次见面即逐句讲解会把完整声音切碎；困难是让前三章作为声音整体被接收——学生只留停点，不理解任务、不留答案。
 【唯一功能】
 不中断地接收第一至三章，让初见、等待、迁嫁和劝告先作为声音发生。
 【文学对象】
@@ -10734,33 +10734,33 @@
 【学生主动作】
 眼随声走；只在真实停顿处留点或问号
 【参与路径】
-个人先形成；需要交流时并行同桌或四人轮说；全班只公开少量有差异材料。
+个人与文本独处：静听＋教材旁留点/问号；本页无任何交流环节，停点不收集、不比较。
 【可见产物】
 教材停点
 【教师作用】
-准确释词、引用真实回答、追问原词、后置归纳并守住解释边界。
+朗读载体：教师连续听读承载节奏，零讲解零提问；声速与停顿本身就是本页唯一的教学行为。
 【真实等待】
-逐字稿内有首答等待、限定反馈和本人修订的明确时间。
+三分钟连续朗读零插话（时间盒：朗读全程）；停点标记随听随点、不打断跟读。
 【反馈与本人修订】
-学生依据原词、同伴追问或教师校准，亲自保留、补充、改写或撤回初稿。
+本页无修订；停点将在 O07 被取回转化为文字（初听卡）。
 【首次后用】
 O06无声接续
 【正常反例】
-想不起、无新增、已经准确、不同意或暂时沉默均有诚实完成路径，不要求伪造改变。
+没有停顿处“也只管继续听”（台词已含）；全篇无停点的学生如实不留标记，不造点。
 【主视觉职责】
 第一至三章原诗
 【插图资格】
 无
 【第一人称接收】
-我刚才面对“《氓》第一至第三章的完整声音”，留下了教材停点；我能用原词说清自己新增或修正的理解。
+我完整听完了第一至三章；在某句旁留下了自己的停点或问号；我知道那是我停下的地方，不是老师规定的重点。
 【故事回接】
-页面结束前由一句自然复述回到谁做了什么、人物处境怎样变化以及故事推进到哪里。
+声音层面经历初见→等待→迁嫁→劝告（一至三章事件在听中发生）；为 O06 后半段的婚变转折蓄势。
 【删除损失】
 删除会失去开放接收
 【相邻反证】
-相邻页不同时处理“学生容易看见“《氓》第一至第三章的完整声音”，却不能把它准确接回人物和前后故事。”；合并会挤掉必要首答、校准或故事回接。
+O05 与 O06 是一次不间断全文首读的两段物理承接（切页句“无声切页，朗读不断”）；若并入 O06，三章后的自然换气点与听者确认停点的时点消失。
 【失败信号】
-学生只能复述活动手续，不能复述诗意；首答前已经看见完成关系或答案；产物在后页没有真实消费者
+朗读被打断插入讲解；停点被教师收集比较（变成任务）；教师预告后三章内容（剧透）
 【声明边界】V5无插图桌面候选；不声称真实课堂或学生掌握已经通过。</a:t>
             </a:r>
             <a:endParaRPr lang="en-US" dirty="0"/>
@@ -12396,7 +12396,7 @@
 【前页输入】
 前三章已经连续响过，朗读不因换页停止。
 【唯一困难】
-学生容易看见“《氓》第四至第六章的完整声音及全诗结尾”，却不能把它准确接回人物和前后故事。
+后三章情绪急转（劳苦、受暴、决绝），困难是让声音把转折带完而不被提前解释；“亦已焉哉”需要完整落下的空间。
 【唯一功能】
 无缝接收第四至六章并让末句落下。
 【文学对象】
@@ -12406,33 +12406,33 @@
 【学生主动作】
 继续听读；末句后确认停点
 【参与路径】
-个人先形成；需要交流时并行同桌或四人轮说；全班只公开少量有差异材料。
+继续个人静听；末句后默数自己的停点数（为 O07 选句做准备），无交流环节。
 【可见产物】
 教材停点
 【教师作用】
-准确释词、引用真实回答、追问原词、后置归纳并守住解释边界。
+延续同一朗读声不换节奏；末句后完全静默切页，绝不接“这首诗表达了……”式总结。
 【真实等待】
-逐字稿内有首答等待、限定反馈和本人修订的明确时间。
+三分钟连续朗读零插话；末句后停顿至切页句出现，期间教师零语言。
 【反馈与本人修订】
-学生依据原词、同伴追问或教师校准，亲自保留、补充、改写或撤回初稿。
+本页无修订；停点在下一页转化为初听卡文字。
 【首次后用】
 O07取回
 【正常反例】
-想不起、无新增、已经准确、不同意或暂时沉默均有诚实完成路径，不要求伪造改变。
+无停点的学生等末句落下即可，不强制造句；跟不上朗读速度的学生听完全程即算完成。
 【主视觉职责】
 第四至六章原诗
 【插图资格】
 无
 【第一人称接收】
-我刚才面对“《氓》第四至第六章的完整声音及全诗结尾”，留下了教材停点；我能用原词说清自己新增或修正的理解。
+我听完了全诗六章；末句落下后，我能指出一句最留住我的句子，并知道它在第几章。
 【故事回接】
-页面结束前由一句自然复述回到谁做了什么、人物处境怎样变化以及故事推进到哪里。
+声音层面完成婚变→决绝；切页句把全诗第一次完整经历交给学生：“把第一次听见的《氓》，留在纸上”。
 【删除损失】
 删除会把全诗压成婚前故事
 【相邻反证】
-相邻页不同时处理“学生容易看见“《氓》第四至第六章的完整声音及全诗结尾”，却不能把它准确接回人物和前后故事。”；合并会挤掉必要首答、校准或故事回接。
+与 O05 合并则一次首读的物理承接与换气点消失；与 O07 合并则末句落下后的静默书写被挤掉——三页各承担“声音上半/声音下半/起点文字化”。
 【失败信号】
-学生只能复述活动手续，不能复述诗意；首答前已经看见完成关系或答案；产物在后页没有真实消费者
+末句后教师立即总结主题；后半朗读节奏与前半不一致（声音断裂）；学生被要求当场分享停点（应留到O07）
 【声明边界】V5无插图桌面候选；不声称真实课堂或学生掌握已经通过。</a:t>
             </a:r>
             <a:endParaRPr lang="en-US" dirty="0"/>
@@ -12854,7 +12854,7 @@
 【前页输入】
 前三章已经连续响过，朗读不因换页停止。
 【唯一困难】
-学生容易看见“《氓》第四至第六章的完整声音及全诗结尾”，却不能把它准确接回人物和前后故事。
+后三章情绪急转（劳苦、受暴、决绝），困难是让声音把转折带完而不被提前解释；“亦已焉哉”需要完整落下的空间。
 【唯一功能】
 无缝接收第四至六章并让末句落下。
 【文学对象】
@@ -12864,33 +12864,33 @@
 【学生主动作】
 继续听读；末句后确认停点
 【参与路径】
-个人先形成；需要交流时并行同桌或四人轮说；全班只公开少量有差异材料。
+继续个人静听；末句后默数自己的停点数（为 O07 选句做准备），无交流环节。
 【可见产物】
 教材停点
 【教师作用】
-准确释词、引用真实回答、追问原词、后置归纳并守住解释边界。
+延续同一朗读声不换节奏；末句后完全静默切页，绝不接“这首诗表达了……”式总结。
 【真实等待】
-逐字稿内有首答等待、限定反馈和本人修订的明确时间。
+三分钟连续朗读零插话；末句后停顿至切页句出现，期间教师零语言。
 【反馈与本人修订】
-学生依据原词、同伴追问或教师校准，亲自保留、补充、改写或撤回初稿。
+本页无修订；停点在下一页转化为初听卡文字。
 【首次后用】
 O07取回
 【正常反例】
-想不起、无新增、已经准确、不同意或暂时沉默均有诚实完成路径，不要求伪造改变。
+无停点的学生等末句落下即可，不强制造句；跟不上朗读速度的学生听完全程即算完成。
 【主视觉职责】
 第四至六章原诗
 【插图资格】
 无
 【第一人称接收】
-我刚才面对“《氓》第四至第六章的完整声音及全诗结尾”，留下了教材停点；我能用原词说清自己新增或修正的理解。
+我听完了全诗六章；末句落下后，我能指出一句最留住我的句子，并知道它在第几章。
 【故事回接】
-页面结束前由一句自然复述回到谁做了什么、人物处境怎样变化以及故事推进到哪里。
+声音层面完成婚变→决绝；切页句把全诗第一次完整经历交给学生：“把第一次听见的《氓》，留在纸上”。
 【删除损失】
 删除会把全诗压成婚前故事
 【相邻反证】
-相邻页不同时处理“学生容易看见“《氓》第四至第六章的完整声音及全诗结尾”，却不能把它准确接回人物和前后故事。”；合并会挤掉必要首答、校准或故事回接。
+与 O05 合并则一次首读的物理承接与换气点消失；与 O07 合并则末句落下后的静默书写被挤掉——三页各承担“声音上半/声音下半/起点文字化”。
 【失败信号】
-学生只能复述活动手续，不能复述诗意；首答前已经看见完成关系或答案；产物在后页没有真实消费者
+末句后教师立即总结主题；后半朗读节奏与前半不一致（声音断裂）；学生被要求当场分享停点（应留到O07）
 【声明边界】V5无插图桌面候选；不声称真实课堂或学生掌握已经通过。</a:t>
             </a:r>
             <a:endParaRPr lang="en-US" dirty="0"/>

</xml_diff>

<commit_message>
feat: meng v66 boilerplate cleared to zero (462->188->0, 19 pages rewritten)
- C5/C6/S 十九页 + O08 共 130+62 处 contract() 默认模板串逐页改写为具体陈述：
  时间盒秒数、真实动作序列、页面特定困难与边界全部取自各页 script 与 v6.6 字段
- 守卫反转：LessonJsSyncTest 从「默认串在场同步」改为「默认串回潮即失败」（清零守卫）
- 门禁：validate_lesson_schema --strict 0 样板；check_trace_evidence --strict 0 处；node 4/4；pytest 全绿（试卷线 1 预存红除外）
- L3 重建：真实剧本 V5/功能总账 V5/PPTX+manifest 同步刷新
</commit_message>
<xml_diff>
--- a/work/备课/选择性必修下册/氓/_v62_stage/v66/pptx/04_氓_V66逐页功能重构_81状态无插图逐字稿_V5.pptx
+++ b/work/备课/选择性必修下册/氓/_v62_stage/v66/pptx/04_氓_V66逐页功能重构_81状态无插图逐字稿_V5.pptx
@@ -614,7 +614,7 @@
 【唯一功能】
 让每个人从自己的阅读经历中先得到至少一条可说材料，并尽量扩大爱情与婚姻文学的篇目和主题范围。
 【文学对象】
-学生小学至高中语文课文、小说与整本书中的爱情、婚姻故事
+[object Object]
 【信息状态】
 公共篇目和教师分类全部未知；首答态只显示三个自然落笔处。
 【学生主动作】
@@ -766,7 +766,7 @@
 【唯一功能】
 无缝接收第四至六章并让末句落下。
 【文学对象】
-《氓》第四至第六章的完整声音及全诗结尾
+桑之落矣，其黄而陨,自我徂尔，三岁食贫,淇水汤汤，渐车帷裳,女也不爽，士贰其行,士也罔极，二三其德,三岁为妇，靡室劳矣,夙兴夜寐，靡有朝矣,言既遂矣，至于暴矣,兄弟不知，咥其笑矣,静言思之，躬自悼矣,及尔偕老，老使我怨,淇则有岸，隰则有泮,总角之宴，言笑晏晏,信誓旦旦，不思其反,反是不思，亦已焉哉
 【信息状态】
 只继续暴露原诗，末句后保持十五秒无解释静默。
 【学生主动作】
@@ -920,7 +920,7 @@
 【唯一功能】
 保存每个人第一次真正听见的句子，不让三问覆盖个人起点。
 【文学对象】
-学生在六章完整声音中的个人停顿句、画面、声音或问题
+[object Object]
 【信息状态】
 三问尚未出现；卡片此刻发放（登记首次可见）；教师不示范“好的初听句”，黑板右侧只承载学生真实文字。
 【学生主动作】
@@ -1073,7 +1073,7 @@
 【唯一功能】
 把三问变成读后生成的全文导航：先讲经历，再看生活，最后追原因。
 【文学对象】
-在完整听读和学生初听文字之后出现的经历、不幸表现与婚姻原因三个问题
+[object Object]
 【信息状态】
 三问此刻首次出现；不显示标准答案和原因框架。
 【学生主动作】
@@ -1091,7 +1091,7 @@
 【首次后用】
 六章积证并由S02—S04回收
 【正常反例】
-想不起、无新增、已经准确、不同意或暂时沉默均有诚实完成路径，不要求伪造改变。
+暂时想不出问题的学生保留三问原句作为阅读书签内容；立即能答者把话写在相应问题旁，标注为待原诗检验的初步判断，不冒充读过全诗的结论。
 【主视觉职责】
 三个自然问题
 【插图资格】
@@ -2292,7 +2292,7 @@
 【唯一功能】
 分别实现每个人低压开口和全班文学版图的广度，让作品与朴素主题从学生话语中相遇。
 【文学对象】
-全班学生真正记得的爱情与婚姻文学作品及其朴素主题
+[object Object]
 【信息状态】
 教师不预填篇目和分类；课堂只逐步暴露同伴真实作品。
 【学生主动作】
@@ -3992,7 +3992,7 @@
 【唯一功能】
 教师用现场文学长卷完成后置归纳，再从众多旧作聚焦到一位先秦女子的声音，完成题名、正音和出处。
 【文学对象】
-《诗经·卫风·氓》的题名、出处与第一句
+[object Object]
 【信息状态】
 归纳时投影熄暗，不以预制PPT覆盖现场；揭题时只暴露题名、读音和出处。
 【学生主动作】
@@ -5685,7 +5685,7 @@
 【唯一功能】
 在不打断初听的前提下，给学生阅读《氓》所需的最低文化坐标，并只点名后文会亲自遇见的赋、比、兴。
 【文学对象】
-《诗经》最低文化坐标及《氓》的归属
+[object Object]
 【信息状态】
 只揭示最低事实和术语名称；比兴定义及本诗例子保持未知。
 【学生主动作】
@@ -6292,45 +6292,45 @@
 先不走向兄弟的笑声。前两句只写一天从什么时候开始、什么时候结束，却说这一天重复了许多年。
 【V6.6逻辑页】C501｜逻辑页29｜4分钟
 【前页输入】
-学生已经完成前页任务，手中保留与“三岁为妇，靡室劳矣。夙兴夜寐，靡有朝矣。言既遂矣，至于暴矣。兄弟不知，咥其笑矣。静言思之，躬自悼矣。”有关的原词或初稿。
+第四章已辨明男子行为反复（贰其行、二三其德）；学生保留C404行动判断与C401标记经验，第五章未读，空间声音初稿为空。
 【唯一困难】
-学生容易看见“三岁为妇，靡室劳矣。夙兴夜寐，靡有朝矣。言既遂矣，至于暴矣。兄弟不知，咥其笑矣。静言思之，躬自悼矣。”，却不能把它准确接回人物和前后故事。
+学生易把第五章五句压成“女子很惨”的标签，听不出诗先写身体与日常（靡室劳、夙兴夜寐），再让外部声音（暴、咥笑）进入，最后收进女子内心（静言思之）的层次。
 【唯一功能】
 完整听见第五章，并定位动作和声音的主体。
 【文学对象】
 三岁为妇，靡室劳矣。夙兴夜寐，靡有朝矣。言既遂矣，至于暴矣。兄弟不知，咥其笑矣。静言思之，躬自悼矣。
 【信息状态】
-首答前只给原诗、必要字面和一个自然问题；解释、分类、关系与代表答案在学生首稿后出现。
+整章五句先完整响一遍，屏上不出现劳作、粗暴、孤立等归纳词；学生先以“谁在做事、谁的声音从外面来”听读，两项初稿落在读后。
 【学生主动作】
 整章读；标主体、动作和声音来源
 【参与路径】
-个人先形成；需要交流时并行同桌或四人轮说；全班只公开少量有差异材料。
+教师范读+学生低声整读90秒→个人抄一个反复动作与一处转入内心的原句60秒→同桌只核来源40秒→两条现场引用转场。
 【可见产物】
 空间声音初稿
 【教师作用】
-准确释词、引用真实回答、追问原词、后置归纳并守住解释边界。
+范读承载章的声音；巡视确认动作与声音两类标记都有；收束只引用学生现场原句并保留“大致路径”，不预告词义与责任判断。
 【真实等待】
-逐字稿内有首答等待、限定反馈和本人修订的明确时间。
+时间盒明示：承接25秒→整读90秒→个人两项初稿60秒→同桌来源核对40秒→现场引用与转场25秒；初稿期间零插话。
 【反馈与本人修订】
-学生依据原词、同伴追问或教师校准，亲自保留、补充、改写或撤回初稿。
+同桌只核对所抄是否出自第五章，不讲对错；学生把情绪词改回动作或完整原句，或移动内心转折位置并保留理由。
 【首次后用】
 C502—C504
 【正常反例】
-想不起、无新增、已经准确、不同意或暂时沉默均有诚实完成路径，不要求伪造改变。
+只找到早起或晚睡一个动作可先保留；把“惨”当动作者回到原句改写；转折位置判不同可留待C504再修。
 【主视觉职责】
 第五章完整声场
 【插图资格】
 无
 【第一人称接收】
-我刚才面对“三岁为妇，靡室劳矣。夙兴夜寐，靡有朝矣。言既遂矣，至于暴矣。兄弟不知，咥其笑矣。静言思之，躬自悼矣。”，留下了空间声音初稿；我能用原词说清自己新增或修正的理解。
+我完整听了第五章并抄下一个会反复发生的生活动作与一处声音转入内心的原句；我能说出这两处分别是谁在动、谁在发声。
 【故事回接】
-页面结束前由一句自然复述回到谁做了什么、人物处境怎样变化以及故事推进到哪里。
+婚后日常被打开：她多年操持家务、早起晚睡→他如愿后转粗暴→兄弟不知而笑→她静下来独自思量；切页句指向“一天叠成许多年”。
 【删除损失】
 删除会让不幸仍是标签
 【相邻反证】
-相邻页不同时处理“学生容易看见“三岁为妇，靡室劳矣。夙兴夜寐，靡有朝矣。言既遂矣，至于暴矣。兄弟不知，咥其笑矣。静言思之，躬自悼矣。”，却不能把它准确接回人物和前后故事。”；合并会挤掉必要首答、校准或故事回接。
+不并入C502：整章必须在词义与日程支架出现前完整接收；若首屏即注“靡室劳＝家务劳苦”，学生先记注释而失去“谁在做事”的整听。
 【失败信号】
-学生只能复述活动手续，不能复述诗意；首答前已经看见完成关系或答案；产物在后页没有真实消费者
+学生只记住“很惨”不能指认动作主体；读前屏上已出现劳苦或孤立归纳；两项初稿被同桌讲评成对错
 【声明边界】V5无插图桌面候选；不声称真实课堂或学生掌握已经通过。</a:t>
             </a:r>
             <a:endParaRPr lang="en-US" dirty="0"/>
@@ -6449,45 +6449,45 @@
 多年这样生活以后，下一句忽然写‘既遂’和‘至于暴’。一个人的愿望满足了，另一个人的日子却走向哪里？
 【V6.6逻辑页】C502｜逻辑页30｜5分钟
 【前页输入】
-学生已经完成前页任务，手中保留与“三岁为妇，靡室劳矣。夙兴夜寐，靡有朝矣。”有关的原词或初稿。
+C501已留一个反复生活动作与一处内心原句；靡、朝等词义尚未校准，嵌套时间线为空。
 【唯一困难】
-学生容易看见“三岁为妇，靡室劳矣。夙兴夜寐，靡有朝矣。”，却不能把它准确接回人物和前后故事。
+学生把“夙兴夜寐”译成勤劳贤惠的标签，听不出一天首尾被“三岁”“靡有朝”叠成多年重复，也可能用赞美掩盖劳动长期集中在一人身上。
 【唯一功能】
 把夙兴—夜寐拉成一天首尾，再叠入三岁与靡有朝的多年重复。
 【文学对象】
 三岁为妇，靡室劳矣。夙兴夜寐，靡有朝矣。
 【信息状态】
-首答前只给原诗、必要字面和一个自然问题；解释、分类、关系与代表答案在学生首稿后出现。
+原句与必要词义主位，问题开放；屏上不出现勤劳、贤惠、权责失衡等完成判断。
 【学生主动作】
 完成嵌套时间线；口头概括日常
 【参与路径】
-个人先形成；需要交流时并行同桌或四人轮说；全班只公开少量有差异材料。
+口译64秒→两位同学分站教室前后接读“夙兴”“夜寐”、全班句末低接“靡”两轮72秒→个人第三人称旁白61秒→同桌用词核查39秒→修订分享转场64秒。
 【可见产物】
 嵌套时间线
 【教师作用】
-准确释词、引用真实回答、追问原词、后置归纳并守住解释边界。
+先借注释把两句说成自然话；听者报告只限早晚跨度与无一日例外是否听见；不概括人物性格。
 【真实等待】
-逐字稿内有首答等待、限定反馈和本人修订的明确时间。
+时间盒明示：口译64秒→两轮声场72秒（听者闭眼）→个人旁白61秒→同桌核查39秒→修订分享64秒；旁白写作期间零插话。
 【反馈与本人修订】
-学生依据原词、同伴追问或教师校准，亲自保留、补充、改写或撤回初稿。
+同桌只圈“贤妻无怨”一类浪漫化词或无证家务清单；作者把重音或停顿调整一次，改成有原句依据的长期家务与早起晚睡事实。
 【首次后用】
 C505与S02
 【正常反例】
-想不起、无新增、已经准确、不同意或暂时沉默均有诚实完成路径，不要求伪造改变。
+不愿走位者在座位两端指向朗读即可；认为勤劳值得赞美者保留赞许，但须另写劳动长期集中在一人身上的事实句。
 【主视觉职责】
 一天叠入多年
 【插图资格】
 I06须重审
 【第一人称接收】
-我刚才面对“三岁为妇，靡室劳矣。夙兴夜寐，靡有朝矣。”，留下了嵌套时间线；我能用原词说清自己新增或修正的理解。
+我在前后接读中听见一天从夙兴到夜寐、由靡连成无一日例外；我的旁白同时含一天与多年，核查后删去了浪漫化词。
 【故事回接】
-页面结束前由一句自然复述回到谁做了什么、人物处境怎样变化以及故事推进到哪里。
+她的多年被写成日复一日：早起晚睡无一日例外、家务无一样不扛；切页句指向“愿望满足后他变成了什么样”。
 【删除损失】
 删除会失去日常劳作的时间结构
 【相邻反证】
-相邻页不同时处理“学生容易看见“三岁为妇，靡室劳矣。夙兴夜寐，靡有朝矣。”，却不能把它准确接回人物和前后故事。”；合并会挤掉必要首答、校准或故事回接。
+不并入C503：本页须让“一天×多年”的时间结构先成立；与“既遂—至暴”的行为反差同屏会两种思维互相淹没。
 【失败信号】
-学生只能复述活动手续，不能复述诗意；首答前已经看见完成关系或答案；产物在后页没有真实消费者
+旁白只剩“她很勤劳”无一天／多年结构；声场轮齐读或未闭眼听；同桌核查讲了人物评价
 【声明边界】V5无插图桌面候选；不声称真实课堂或学生掌握已经通过。</a:t>
             </a:r>
             <a:endParaRPr lang="en-US" dirty="0"/>
@@ -6603,45 +6603,45 @@
 男子的变化已经写明。第五章还有另一重孤立：外面的笑声散去以后，她只能独自思量。
 【V6.6逻辑页】C503｜逻辑页31｜6分钟
 【前页输入】
-学生已经完成前页任务，手中保留与“言既遂矣，至于暴矣。氓之蚩蚩，抱布贸丝。匪来贸丝，来即我谋。将子无怒，秋以为期。”有关的原词或初稿。
+C502已成立多年投入事实；第一章原文在教材可翻回；双行句（值得留意／不能断定）为空。
 【唯一困难】
-学生容易看见“言既遂矣，至于暴矣。氓之蚩蚩，抱布贸丝。匪来贸丝，来即我谋。将子无怒，秋以为期。”，却不能把它准确接回人物和前后故事。
+学生易把“暴”虚构为具体身体伤害，或把婚前细节一律倒推为有预谋伪装；难在后见之明使早期信息值得重看，而不等于当时已能断定。
 【唯一功能】
 读清既遂—至暴的变化，并有限回看婚前警讯而不倒推预谋。
 【文学对象】
 言既遂矣，至于暴矣。氓之蚩蚩，抱布贸丝。匪来贸丝，来即我谋。将子无怒，秋以为期。
 【信息状态】
-首答前只给原诗、必要字面和一个自然问题；解释、分类、关系与代表答案在学生首稿后出现。
+当前句在上、三处早期原词在下；问题允许发现警告而不预判蓄意欺骗或具体伤害方式；证据边界由教师在校准段明确。
 【学生主动作】
 任选一处婚前细节；写现在能说明与仍不能说明
 【参与路径】
-个人先形成；需要交流时并行同桌或四人轮说；全班只公开少量有差异材料。
+释义与翻回开头65秒→个人双行首答105秒→三份公开＋听众追问85秒→边界校准与本人修订105秒。
 【可见产物】
 有限回看双行句
 【教师作用】
-准确释词、引用真实回答、追问原词、后置归纳并守住解释边界。
+明确“暴”只到粗暴、诗未写方式；引用三份真实双行句整理“值得重看≠已证明”；不替学生生成唯一警告清单。
 【真实等待】
-逐字稿内有首答等待、限定反馈和本人修订的明确时间。
+时间盒明示：释义65秒→首答105秒（零插话）→公开追问85秒→校准修订105秒；追问只认原词与后来事实。
 【反馈与本人修订】
-学生依据原词、同伴追问或教师校准，亲自保留、补充、改写或撤回初稿。
+听众只追问“由哪个原词、哪条后来事实托住”；作者把“一定伪装／早有暴力”改为“值得重看但此处尚不能证明”，或补一个被忽略的原词。
 【首次后用】
 C505与S03
 【正常反例】
-想不起、无新增、已经准确、不同意或暂时沉默均有诚实完成路径，不要求伪造改变。
+认为早期细节无异常者可保留，但须说明后文是否改变自己的阅读；判全是伪装者删去“一定、预谋”等超证据词。
 【主视觉职责】
 今昔证据边界
 【插图资格】
 无
 【第一人称接收】
-我刚才面对“言既遂矣，至于暴矣。氓之蚩蚩，抱布贸丝。匪来贸丝，来即我谋。将子无怒，秋以为期。”，留下了有限回看双行句；我能用原词说清自己新增或修正的理解。
+我选了“将子无怒”写下“后来值得重看／当时不能断定”两行；修订后我能说清自己的判断边界在哪两个原词之间。
 【故事回接】
-页面结束前由一句自然复述回到谁做了什么、人物处境怎样变化以及故事推进到哪里。
+愿望满足后的态度转折（既遂—至暴）使开头的贸丝、议婚、无怒成为值得重看的信息；故事从相遇推进到关系质变。
 【删除损失】
 删除会失去审慎与证据边界
 【相邻反证】
-相邻页不同时处理“学生容易看见“言既遂矣，至于暴矣。氓之蚩蚩，抱布贸丝。匪来贸丝，来即我谋。将子无怒，秋以为期。”，却不能把它准确接回人物和前后故事。”；合并会挤掉必要首答、校准或故事回接。
+不并入C502：跨章回看与证据强度判断需要日常事实先成立；也不并入C504——理性判断与声场体验同屏会失焦。
 【失败信号】
-学生只能复述活动手续，不能复述诗意；首答前已经看见完成关系或答案；产物在后页没有真实消费者
+双行句只写“他是骗子”；公开段教师替学生列标准警告清单；“暴”被讲成具体伤害情节
 【声明边界】V5无插图桌面候选；不声称真实课堂或学生掌握已经通过。</a:t>
             </a:r>
             <a:endParaRPr lang="en-US" dirty="0"/>
@@ -6756,45 +6756,45 @@
 把这间屋子里的时间、声音和人物留下。下一页，我们用一小段生活把许多年写出来。
 【V6.6逻辑页】C504｜逻辑页32｜5分钟
 【前页输入】
-学生已经完成前页任务，手中保留与“兄弟不知，咥其笑矣。静言思之，躬自悼矣。”有关的原词或初稿。
+长期劳作与行为粗暴已成立；咥、躬、悼音义未校准；三格声场图未画。
 【唯一困难】
-学生容易看见“兄弟不知，咥其笑矣。静言思之，躬自悼矣。”，却不能把它准确接回人物和前后故事。
+学生用“家人不支持”的标签掠过笑声与沉默的声场，或补写求助被拒、全部家人恶意等诗外事实。
 【唯一功能】
 用全课唯一声场体验外部笑声退去后女子独自思量。
 【文学对象】
 兄弟不知，咥其笑矣。静言思之，躬自悼矣。
 【信息状态】
-屏幕中间只保留空白；三秒沉默、站位和声场程序全部进入备注，不写在前台。
+两句上下相对只给最低词义；“支持缺失、孤立”等标签不出现；三秒沉默由课堂真实发生而非写在屏上。
 【学生主动作】
 听外声—沉默—内声；静写第三人称处境
 【参与路径】
-个人先形成；需要交流时并行同桌或四人轮说；全班只公开少量有差异材料。
+词义校准→两侧克制低读“兄弟不知，咥其笑矣”→真正沉默三秒→中间一人读“静言思之，躬自悼矣”→个人三格＋处境句（不交换不审稿）。
 【可见产物】
 声音层次与处境句
 【教师作用】
-准确释词、引用真实回答、追问原词、后置归纳并守住解释边界。
+只校音义（咥xì、躬、悼）与事实边界（只写兄弟、未写求助）；不审稿、不要求讲自己家庭、不代写处境句。
 【真实等待】
-逐字稿内有首答等待、限定反馈和本人修订的明确时间。
+300秒内声场—沉默—静写三段时点明确；外声退净后真实三秒内零言语；处境句写作不交换。
 【反馈与本人修订】
-学生依据原词、同伴追问或教师校准，亲自保留、补充、改写或撤回初稿。
+听者只报告外声停止后三秒里的空间感；作者把“全家拒绝救她”改为“兄弟不了解并讥笑，她缺少理解与托举”，或保留更克制的原句判断。
 【首次后用】
 C505、S02与S03
 【正常反例】
-想不起、无新增、已经准确、不同意或暂时沉默均有诚实完成路径，不要求伪造改变。
+不愿朗读者做听者即可；认为兄弟只是不知而非恶意者保留复杂判断；没有私人经验不影响参与。
 【主视觉职责】
 声场与留白
 【插图资格】
 I07须重审
 【第一人称接收】
-我刚才面对“兄弟不知，咥其笑矣。静言思之，躬自悼矣。”，留下了声音层次与处境句；我能用原词说清自己新增或修正的理解。
+我闭眼听见笑声退去、三秒空、然后只剩她自己的声音；我画的三格与处境句只用“兄弟不知、咥笑、静思自悼”以内的信息。
 【故事回接】
-页面结束前由一句自然复述回到谁做了什么、人物处境怎样变化以及故事推进到哪里。
+外部最后一点声音（兄弟之笑）也退去，她从被讥笑转入独自思量；故事只剩她一个人面对自己。
 【删除损失】
 删除会失去社会孤立的声音经验
 【相邻反证】
-相邻页不同时处理“学生容易看见“兄弟不知，咥其笑矣。静言思之，躬自悼矣。”，却不能把它准确接回人物和前后故事。”；合并会挤掉必要首答、校准或故事回接。
+不并入C503：证据强度是理性判断，本页是全课唯一声场体验；合并会让情绪体验被讨论挤掉。
 【失败信号】
-画面写出‘三秒沉默’；外声表演成夸张嘲笑；要求学生披露家庭经历
+三格画出“全家抛弃她”；沉默被教师口头倒计时填满；处境句后进入互审
 【声明边界】V5无插图桌面候选；不声称真实课堂或学生掌握已经通过。</a:t>
             </a:r>
             <a:endParaRPr lang="en-US" dirty="0"/>
@@ -6909,45 +6909,45 @@
 生活已经写到最深处。第六章不再增加新的日常事件，她开始重新看旧愿、旧事和誓言。
 【V6.6逻辑页】C505｜逻辑页33｜4分钟
 【前页输入】
-学生已经完成前页任务，手中保留与“三岁为妇，靡室劳矣。夙兴夜寐，靡有朝矣。言既遂矣，至于暴矣。兄弟不知，咥其笑矣。静言思之，躬自悼矣。”有关的原词或初稿。
+五句已分别生成时间体验（C502）、回看判断（C503）与支持处境（C504）；40—60字生活片段为空。
 【唯一困难】
-学生容易看见“三岁为妇，靡室劳矣。夙兴夜寐，靡有朝矣。言既遂矣，至于暴矣。兄弟不知，咥其笑矣。静言思之，躬自悼矣。”，却不能把它准确接回人物和前后故事。
+学生记住沉重标签却不能撤开支架复述谁在何种日常里做什么、关系如何一步步把她推向孤立；也易在片段里添家务清单或伤害方式。
 【唯一功能】
 把第五章转译成不虚构的生活片段，直接供全文第二问使用。
 【文学对象】
 三岁为妇，靡室劳矣。夙兴夜寐，靡有朝矣。言既遂矣，至于暴矣。兄弟不知，咥其笑矣。静言思之，躬自悼矣。
 【信息状态】
-首答前只给原诗、必要字面和一个自然问题；解释、分类、关系与代表答案在学生首稿后出现。
+完整原诗重新主位、三个自然问题限定旁白范围；随后必须合书、翻背材料、熄屏，检索真实发生而非口头宣告。
 【学生主动作】
 合书写40—60字生活片段；匿名猜回原句
 【参与路径】
-个人先形成；需要交流时并行同桌或四人轮说；全班只公开少量有差异材料。
+四个原句锚点呈现→合书写40—60字第三人称片段→匿名投影两份→全班说它由哪几句托住→作者定位断点合书补说。
 【可见产物】
 第五章生活片段
 【教师作用】
-准确释词、引用真实回答、追问原词、后置归纳并守住解释边界。
+安静巡视不让同桌互改；只读两份匿名片段；只修事实顺序与暴、家人范围边界，不制造统一情绪。
 【真实等待】
-逐字稿内有首答等待、限定反馈和本人修订的明确时间。
+240秒内写作段零互改；匿名展读后讲述者只定位断点合书补说，不重写全篇。
 【反馈与本人修订】
-学生依据原词、同伴追问或教师校准，亲自保留、补充、改写或撤回初稿。
+听者只核对“日常—变化—独处”三层是否齐全不代讲；作者用自己的自然话写第五格，删去勤劳、悲惨等标签替代。
 【首次后用】
 S02直接展读
 【正常反例】
-想不起、无新增、已经准确、不同意或暂时沉默均有诚实完成路径，不要求伪造改变。
+暂时讲不全者从最确定的一句开始，再只开教材找前后；没有遗漏者如实说完整，不制造不同。
 【主视觉职责】
 学生文字
 【插图资格】
 无
 【第一人称接收】
-我刚才面对“三岁为妇，靡室劳矣。夙兴夜寐，靡有朝矣。言既遂矣，至于暴矣。兄弟不知，咥其笑矣。静言思之，躬自悼矣。”，留下了第五章生活片段；我能用原词说清自己新增或修正的理解。
+我合上书写出她的一间屋子里的许多年；被投影时我能说出每一层由哪句原诗托住，断点在哪句补说。
 【故事回接】
-页面结束前由一句自然复述回到谁做了什么、人物处境怎样变化以及故事推进到哪里。
+第五章成为可讲述的生活：多年操持→他如愿变粗暴→笑声退去→她独自思量；片段直接进入全文第二问（S02）。
 【删除损失】
 删除会使全文活动重新从零写
 【相邻反证】
-相邻页不同时处理“学生容易看见“三岁为妇，靡室劳矣。夙兴夜寐，靡有朝矣。言既遂矣，至于暴矣。兄弟不知，咥其笑矣。静言思之，躬自悼矣。”，却不能把它准确接回人物和前后故事。”；合并会挤掉必要首答、校准或故事回接。
+不并入C504：C504仍在声场体验两句，本页撤除全部支架做章内跨章重建；同屏会使体验与检索互相打断。
 【失败信号】
-学生只能复述活动手续，不能复述诗意；首答前已经看见完成关系或答案；产物在后页没有真实消费者
+片段写成家务或伤害清单；投影后教师代讲章意；未合书抄原文冒充重建
 【声明边界】V5无插图桌面候选；不声称真实课堂或学生掌握已经通过。</a:t>
             </a:r>
             <a:endParaRPr lang="en-US" dirty="0"/>
@@ -7064,45 +7064,45 @@
 先看第一个回环：同一个‘老’字，一边是愿望，一边为什么成了怨？
 【V6.6逻辑页】C601｜逻辑页34｜4分钟
 【前页输入】
-学生已经完成前页任务，手中保留与“及尔偕老，老使我怨。淇则有岸，隰则有泮。总角之宴，言笑晏晏。信誓旦旦，不思其反。反是不思，亦已焉哉。”有关的原词或初稿。
+第五章止于“静言思之，躬自悼矣”的独自思量；学生保留C505生活片段与一个内心声音位置，第六章未读，回望初稿为空。
 【唯一困难】
-学生容易看见“及尔偕老，老使我怨。淇则有岸，隰则有泮。总角之宴，言笑晏晏。信誓旦旦，不思其反。反是不思，亦已焉哉。”，却不能把它准确接回人物和前后故事。
+学生带着第五章孤立处境进入末章，容易直接抓住末句的决绝，看不见女子在说出“停止”之前重新核验了旧愿（及尔偕老）、共同记忆（总角之宴）与誓言（信誓旦旦）。
 【唯一功能】
 发现末章不再新增生活事件，而在重新评价旧愿、旧事和誓言。
 【文学对象】
 及尔偕老，老使我怨。淇则有岸，隰则有泮。总角之宴，言笑晏晏。信誓旦旦，不思其反。反是不思，亦已焉哉。
 【信息状态】
-首答前只给原诗、必要字面和一个自然问题；解释、分类、关系与代表答案在学生首稿后出现。
+整章五句先完整响一遍；标题与提示不出现违誓、觉醒、离开、决绝等结论词；“旧事回望＋收束句＋一个声音词”的初稿在读后落笔。
 【学生主动作】
 整章读；标旧事与可能收束句
 【参与路径】
-个人先形成；需要交流时并行同桌或四人轮说；全班只公开少量有差异材料。
+教师范读+学生低声整读90秒→个人抄一处回到过去的原句、一处收束全诗的原句并留一个声音词60秒→同桌只核来源与时间感40秒→引用原句转场25秒。
 【可见产物】
 回望初稿
 【教师作用】
-准确释词、引用真实回答、追问原词、后置归纳并守住解释边界。
+范读承载章声；巡视确认两类原句与声音词都有；收束只确认本章把怨意、边界、少年言笑、信誓放进同一回望，不命名末句情绪。
 【真实等待】
-逐字稿内有首答等待、限定反馈和本人修订的明确时间。
+时间盒明示：承接25秒→整读90秒→个人两项初稿60秒→同桌来源核对40秒→引用与转场25秒；初稿期间零插话。
 【反馈与本人修订】
-学生依据原词、同伴追问或教师校准，亲自保留、补充、改写或撤回初稿。
+同桌只核对是否原句、时间是否回到过去，不替对方命名情绪；学生移动一次时间标记，或把抽象结论改回完整原句并保留声音问号。
 【首次后用】
 C602—C605
 【正常反例】
-想不起、无新增、已经准确、不同意或暂时沉默均有诚实完成路径，不要求伪造改变。
+第一句视为过去或当下可暂存分歧；声音词写不出留问号；同桌后仍有分歧不由教师立即裁决。
 【主视觉职责】
 第六章完整回望
 【插图资格】
 无
 【第一人称接收】
-我刚才面对“及尔偕老，老使我怨。淇则有岸，隰则有泮。总角之宴，言笑晏晏。信誓旦旦，不思其反。反是不思，亦已焉哉。”，留下了回望初稿；我能用原词说清自己新增或修正的理解。
+我完整听了第六章并抄下一处回到过去的原句与一处收束全诗的原句；我能说出它们分别把她带回了什么、把全诗收在了哪里。
 【故事回接】
-页面结束前由一句自然复述回到谁做了什么、人物处境怎样变化以及故事推进到哪里。
+末章不再新增生活事件：她重新经过偕老旧愿、自然边界、少年言笑与誓言，最后收在“亦已焉哉”；切页句指向“及尔偕老”的旧愿。
 【删除损失】
 删除会使末章被拆成名句
 【相邻反证】
-相邻页不同时处理“学生容易看见“及尔偕老，老使我怨。淇则有岸，隰则有泮。总角之宴，言笑晏晏。信誓旦旦，不思其反。反是不思，亦已焉哉。”，却不能把它准确接回人物和前后故事。”；合并会挤掉必要首答、校准或故事回接。
+不并入C602：整章的未知声音必须先于“老”字解释发生；首屏即讲回环，学生只会去课下找修辞而不再听诗。
 【失败信号】
-学生只能复述活动手续，不能复述诗意；首答前已经看见完成关系或答案；产物在后页没有真实消费者
+初稿只有末句“亦已焉哉”；同桌替对方命名“觉醒”或“决绝”；标题或提示出现违誓等结论词
 【声明边界】V5无插图桌面候选；不声称真实课堂或学生掌握已经通过。</a:t>
             </a:r>
             <a:endParaRPr lang="en-US" dirty="0"/>
@@ -7218,45 +7218,45 @@
 旧愿折回现实以后，诗忽然写淇水有岸、湿地有边。先把地貌看清，再谈它怎样接住前后文。
 【V6.6逻辑页】C602｜逻辑页35｜4分钟
 【前页输入】
-学生已经完成前页任务，手中保留与“及尔偕老，老使我怨。”有关的原词或初稿。
+C601已发现本章在重新回望旧事；两个“老”字未区分，旧愿／现实双行为空。
 【唯一困难】
-学生容易看见“及尔偕老，老使我怨。”，却不能把它准确接回人物和前后故事。
+学生把“及尔偕老，老使我怨”平直译成“不能白头偕老”，听不出同一个“老”字如何把曾经的共同愿望反折成当下的怨意。
 【唯一功能】
 从同一‘老’字读出旧愿怎样折成现实怨意。
 【文学对象】
 及尔偕老，老使我怨。
 【信息状态】
-首答前只给原诗、必要字面和一个自然问题；解释、分类、关系与代表答案在学生首稿后出现。
+原句与最低词义居中，不显示愿望破裂、幻灭等教师答案；两个“老”的分别由学生在接读与双行中自己听出。
 【学生主动作】
 接读两个老；写旧愿与现实双行
 【参与路径】
-个人先形成；需要交流时并行同桌或四人轮说；全班只公开少量有差异材料。
+一组接读前半句／后半句，85秒内完成个人双行首答→两份公开与时间辨认60秒→教师示范与学生自定停顿重读65秒→文学归纳转场30秒。
 【可见产物】
 同词反折
 【教师作用】
-准确释词、引用真实回答、追问原词、后置归纳并守住解释边界。
+先不给解释；示范一次“前半句送向将来、后半句折回怨与生活”的读法；归纳只到同词回环，不急着发“反讽”标签。
 【真实等待】
-逐字稿内有首答等待、限定反馈和本人修订的明确时间。
+时间盒明示：接读与双行首答85秒→公开辨认60秒→示范重读65秒→归纳转场30秒；个人落笔期间零插话。
 【反馈与本人修订】
-学生依据原词、同伴追问或教师校准，亲自保留、补充、改写或撤回初稿。
+听众只指出两个“老”是否落在不同时间里；作者补写两个时间层或只改一处交接停顿，使翻转可被听见。
 【首次后用】
 C606_S01与S06
 【正常反例】
-想不起、无新增、已经准确、不同意或暂时沉默均有诚实完成路径，不要求伪造改变。
+认为两处“老”都指年老者可先保留字面再补语境差异；不愿对读者做听者即可。
 【主视觉职责】
 同词复现
 【插图资格】
 无
 【第一人称接收】
-我刚才面对“及尔偕老，老使我怨。”，留下了同词反折；我能用原词说清自己新增或修正的理解。
+我在接读中第一次把“老”读向共同的将来、第二次读回眼下的怨；我的双行写出了这两个时间层，重读时调整了一处停顿。
 【故事回接】
-页面结束前由一句自然复述回到谁做了什么、人物处境怎样变化以及故事推进到哪里。
+白头到老的旧愿被同一个“老”字折回当下的怨苦；故事从共同设想折返她此刻的处境；切页句转向淇水与低地的边界。
 【删除损失】
 删除会失去末章时间折返
 【相邻反证】
-相邻页不同时处理“学生容易看见“及尔偕老，老使我怨。”，却不能把它准确接回人物和前后故事。”；合并会挤掉必要首答、校准或故事回接。
+不并入C603：本页核心是同词声音翻转，下一页是两种解释的证据比较；同屏会使两种证据状态互相干扰。
 【失败信号】
-学生只能复述活动手续，不能复述诗意；首答前已经看见完成关系或答案；产物在后页没有真实消费者
+双行写成两句翻译；公开段被评价“读得深情与否”；教师先讲“反讽”再让学生读
 【声明边界】V5无插图桌面候选；不声称真实课堂或学生掌握已经通过。</a:t>
             </a:r>
             <a:endParaRPr lang="en-US" dirty="0"/>
@@ -7376,7 +7376,7 @@
 【唯一功能】
 不中断地接收第一至三章，让初见、等待、迁嫁和劝告先作为声音发生。
 【文学对象】
-《氓》第一至第三章的完整声音
+氓之蚩蚩，抱布贸丝,匪来贸丝，来即我谋,送子涉淇，至于顿丘,匪我愆期，子无良媒,将子无怒，秋以为期,乘彼垝垣，以望复关,不见复关，泣涕涟涟,既见复关，载笑载言,尔卜尔筮，体无咎言,以尔车来，以我贿迁,桑之未落，其叶沃若,于嗟鸠兮，无食桑葚,于嗟女兮，无与士耽,士之耽兮，犹可说也,女之耽兮，不可说也
 【信息状态】
 只暴露原诗声音；主题、章意和知识解释保持未知。
 【学生主动作】
@@ -7526,45 +7526,45 @@
 自然边界之后，时间突然退回少年。她为什么在最痛的时候，还把当初的言笑和信誓完整地记起？
 【V6.6逻辑页】C603｜逻辑页36｜5分钟
 【前页输入】
-学生已经完成前页任务，手中保留与“淇则有岸，隰则有泮。”有关的原词或初稿。
+首句已把偕老旧愿折为怨；隰、泮字义未校准；第一种解释未写。
 【唯一困难】
-学生容易看见“淇则有岸，隰则有泮。”，却不能把它准确接回人物和前后故事。
+学生把岸、泮机械译成“做人要有边界”的口号，或只接受一个象征密码，忽略教材保留的多义衔接与证据比较过程。
 【唯一功能】
 先看清有界地貌，再形成能接前后文的一种或两种解释。
 【文学对象】
 淇则有岸，隰则有泮。
 【信息状态】
-首答前只给原诗、必要字面和一个自然问题；解释、分类、关系与代表答案在学生首稿后出现。
+原句与最低词义在先，只有开放问题；两种教材解释标签不提前展示，由个人首解与四人轮读生成。
 【学生主动作】
 选择或并列解释；写前后文依据
 【参与路径】
-个人先形成；需要交流时并行同桌或四人轮说；全班只公开少量有差异材料。
+口译词义46秒→个人第一种解释63秒→四人证据轮读71秒→个人补解与排序58秒→公开两种衔接29秒→教师后置归纳33秒。
 【可见产物】
 有依据解释
 【教师作用】
-准确释词、引用真实回答、追问原词、后置归纳并守住解释边界。
+只在最后说明教材两种理解（反衬男子无常／反衬女子怨苦无边）；轮读期间不投票、不站队；现代婚姻口号被改回原句语境。
 【真实等待】
-逐字稿内有首答等待、限定反馈和本人修订的明确时间。
+时间盒明示：口译46秒→首解63秒（零插话）→四人轮读71秒→补解排序58秒→公开29秒→归纳33秒；组内不投票。
 【反馈与本人修订】
-学生依据原词、同伴追问或教师校准，亲自保留、补充、改写或撤回初稿。
+同伴只问“这解释接哪句、靠哪个词”；作者补第二种解释、调整排序，或把“做人要有边界”改回男子无常／女子怨苦的语境。
 【首次后用】
 C606_S01与S06
 【正常反例】
-想不起、无新增、已经准确、不同意或暂时沉默均有诚实完成路径，不要求伪造改变。
+只想到一种解释者先保留，听同伴后补第二种；认为两种皆可者标并列并写保留理由；不站队也可。
 【主视觉职责】
 无人地貌与多解
 【插图资格】
 I09待A/B
 【第一人称接收】
-我刚才面对“淇则有岸，隰则有泮。”，留下了有依据解释；我能用原词说清自己新增或修正的理解。
+我写出了“自然有界反衬什么”的一种解释并补上第二种；我能指出自己更信的那一种靠哪个词接住了前后文。
 【故事回接】
-页面结束前由一句自然复述回到谁做了什么、人物处境怎样变化以及故事推进到哪里。
+淇水有岸、低地有边，反衬人事的无边——他的无常或她的怨苦；回望从旧愿经过自然落到誓言；切页句指向总角之宴的少年记忆。
 【删除损失】
 删除会把自然图景变现代口号
 【相邻反证】
-相邻页不同时处理“学生容易看见“淇则有岸，隰则有泮。”，却不能把它准确接回人物和前后故事。”；合并会挤掉必要首答、校准或故事回接。
+不并入C602：本页需要个人双解释与小组证据比较，时间结构和社会结构都与同词对读不同。
 【失败信号】
-学生只能复述活动手续，不能复述诗意；首答前已经看见完成关系或答案；产物在后页没有真实消费者
+解释停在“做事要有底线”口号；四人组投票决定正确解释；教师先亮两种标签再讨论
 【声明边界】V5无插图桌面候选；不声称真实课堂或学生掌握已经通过。</a:t>
             </a:r>
             <a:endParaRPr lang="en-US" dirty="0"/>
@@ -7678,9 +7678,9 @@
 先保留你的排法。现在用原诗核验其中两组事实。
 【V6.6逻辑页】C604｜逻辑页37｜5分钟
 【前页输入】
-学生已经完成前页任务，手中保留与“总角之宴，言笑晏晏。信誓旦旦，不思其反。”有关的原词或初稿。
+当下事实（劳作、粗暴、反复、孤立）已成立；六张原词卡未分组；旧日／后来双栏为空。
 【唯一困难】
-学生容易看见“总角之宴，言笑晏晏。信誓旦旦，不思其反。”，却不能把它准确接回人物和前后故事。
+学生把“总角之宴，言笑晏晏”当成关系本来很好的证据，或反过来把旧日全部判成伪装；难在同时保存当时经验的真实与后来违誓的责任。
 【唯一功能】
 同时保存旧日确有欢乐誓言和后来行为应受核验。
 【文学对象】
@@ -7690,33 +7690,33 @@
 【学生主动作】
 完成旧日事实与后来事实双栏；讨论两个极端答案
 【参与路径】
-个人先形成；需要交流时并行同桌或四人轮说；全班只公开少量有差异材料。
+词义校准与个人首排100秒→同桌只挑一张分歧卡比较55秒→两张分歧卡上黑板并返诗校准75秒→个人修订与转场70秒。
 【可见产物】
 双真相句
 【教师作用】
-准确释词、引用真实回答、追问原词、后置归纳并守住解释边界。
+只校词义与事实层（记忆真实＋行为违背）；不推断当初誓言的主观真伪；归纳时保存双真相。
 【真实等待】
-逐字稿内有首答等待、限定反馈和本人修订的明确时间。
+时间盒明示：首排100秒（零插话）→同桌分歧卡55秒→公开返诗75秒→修订归纳70秒；犹豫卡可放中间留问号。
 【反馈与本人修订】
-学生依据原词、同伴追问或教师校准，亲自保留、补充、改写或撤回初稿。
+同桌只圈抹除旧日经验或用旧日替后来免责的词；作者把“全是假象／有美好就该坚持”改为“曾有和悦经验与诚恳誓言，但后来行为违背”。
 【首次后用】
 C605与S03
 【正常反例】
-想不起、无新增、已经准确、不同意或暂时沉默均有诚实完成路径，不要求伪造改变。
+认为旧日或含表象者保留可能，但不抹去叙述者记得的言笑晏晏；不愿判断动机者只写经验与行为。
 【主视觉职责】
 双栏事实
 【插图资格】
 I08待A/B
 【第一人称接收】
-我刚才面对“总角之宴，言笑晏晏。信誓旦旦，不思其反。”，留下了双真相句；我能用原词说清自己新增或修正的理解。
+我把六张原词卡分进“她记得的旧日”与“后来核验的事实”，犹豫的放了中间；修订后我能同时说出少年的欢乐是真的、后来的违背也是真的。
 【故事回接】
-页面结束前由一句自然复述回到谁做了什么、人物处境怎样变化以及故事推进到哪里。
+少年言笑与信誓作为真实记忆被保存，又与“不思其反”的违誓对质；回望完成核验，故事只差一句收束；切页句指向末两句。
 【删除损失】
 删除会扁平化人物记忆
 【相邻反证】
-相邻页不同时处理“学生容易看见“总角之宴，言笑晏晏。信誓旦旦，不思其反。”，却不能把它准确接回人物和前后故事。”；合并会挤掉必要首答、校准或故事回接。
+不并入C605：旧日经验与违誓核验必须先完成，末句才有资格读停止判断与声音；顺序颠倒会让决断失去依据。
 【失败信号】
-学生只能复述活动手续，不能复述诗意；首答前已经看见完成关系或答案；产物在后页没有真实消费者
+双栏只剩“全假的”；同桌比较变成说服对方；教师判定誓言当时真假
 【声明边界】V5无插图桌面候选；不声称真实课堂或学生掌握已经通过。</a:t>
             </a:r>
             <a:endParaRPr lang="en-US" dirty="0"/>
@@ -7830,9 +7830,9 @@
 旧事没有被抹去，却也不能替后来的失信免责。末句因此更重。
 【V6.6逻辑页】C604｜逻辑页37｜5分钟
 【前页输入】
-学生已经完成前页任务，手中保留与“总角之宴，言笑晏晏。信誓旦旦，不思其反。”有关的原词或初稿。
+当下事实（劳作、粗暴、反复、孤立）已成立；六张原词卡未分组；旧日／后来双栏为空。
 【唯一困难】
-学生容易看见“总角之宴，言笑晏晏。信誓旦旦，不思其反。”，却不能把它准确接回人物和前后故事。
+学生把“总角之宴，言笑晏晏”当成关系本来很好的证据，或反过来把旧日全部判成伪装；难在同时保存当时经验的真实与后来违誓的责任。
 【唯一功能】
 同时保存旧日确有欢乐誓言和后来行为应受核验。
 【文学对象】
@@ -7842,33 +7842,33 @@
 【学生主动作】
 完成旧日事实与后来事实双栏；讨论两个极端答案
 【参与路径】
-个人先形成；需要交流时并行同桌或四人轮说；全班只公开少量有差异材料。
+词义校准与个人首排100秒→同桌只挑一张分歧卡比较55秒→两张分歧卡上黑板并返诗校准75秒→个人修订与转场70秒。
 【可见产物】
 双真相句
 【教师作用】
-准确释词、引用真实回答、追问原词、后置归纳并守住解释边界。
+只校词义与事实层（记忆真实＋行为违背）；不推断当初誓言的主观真伪；归纳时保存双真相。
 【真实等待】
-逐字稿内有首答等待、限定反馈和本人修订的明确时间。
+时间盒明示：首排100秒（零插话）→同桌分歧卡55秒→公开返诗75秒→修订归纳70秒；犹豫卡可放中间留问号。
 【反馈与本人修订】
-学生依据原词、同伴追问或教师校准，亲自保留、补充、改写或撤回初稿。
+同桌只圈抹除旧日经验或用旧日替后来免责的词；作者把“全是假象／有美好就该坚持”改为“曾有和悦经验与诚恳誓言，但后来行为违背”。
 【首次后用】
 C605与S03
 【正常反例】
-想不起、无新增、已经准确、不同意或暂时沉默均有诚实完成路径，不要求伪造改变。
+认为旧日或含表象者保留可能，但不抹去叙述者记得的言笑晏晏；不愿判断动机者只写经验与行为。
 【主视觉职责】
 双栏事实
 【插图资格】
 I08待A/B
 【第一人称接收】
-我刚才面对“总角之宴，言笑晏晏。信誓旦旦，不思其反。”，留下了双真相句；我能用原词说清自己新增或修正的理解。
+我把六张原词卡分进“她记得的旧日”与“后来核验的事实”，犹豫的放了中间；修订后我能同时说出少年的欢乐是真的、后来的违背也是真的。
 【故事回接】
-页面结束前由一句自然复述回到谁做了什么、人物处境怎样变化以及故事推进到哪里。
+少年言笑与信誓作为真实记忆被保存，又与“不思其反”的违誓对质；回望完成核验，故事只差一句收束；切页句指向末两句。
 【删除损失】
 删除会扁平化人物记忆
 【相邻反证】
-相邻页不同时处理“学生容易看见“总角之宴，言笑晏晏。信誓旦旦，不思其反。”，却不能把它准确接回人物和前后故事。”；合并会挤掉必要首答、校准或故事回接。
+不并入C605：旧日经验与违誓核验必须先完成，末句才有资格读停止判断与声音；顺序颠倒会让决断失去依据。
 【失败信号】
-学生只能复述活动手续，不能复述诗意；首答前已经看见完成关系或答案；产物在后页没有真实消费者
+双栏只剩“全假的”；同桌比较变成说服对方；教师判定誓言当时真假
 【声明边界】V5无插图桌面候选；不声称真实课堂或学生掌握已经通过。</a:t>
             </a:r>
             <a:endParaRPr lang="en-US" dirty="0"/>
@@ -7984,45 +7984,45 @@
 末句已经停住。现在回看六章，只让各章的人物、动作和转折在黑板上重新相接。
 【V6.6逻辑页】C605｜逻辑页38｜5分钟
 【前页输入】
-学生已经完成前页任务，手中保留与“信誓旦旦，不思其反。反是不思，亦已焉哉。”有关的原词或初稿。
+旧日言笑与信誓已保存、违誓已核验（C604）；末句词义未校准；边界双行为空。
 【唯一困难】
-学生容易看见“信誓旦旦，不思其反。反是不思，亦已焉哉。”，却不能把它准确接回人物和前后故事。
+学生把“亦已焉哉”只读成爽快决绝并直接叙述她已离家成功，或只读成无力悲伤；难在“判断已形成”与“行动未写”之间的边界。
 【唯一功能】
 读清反—不思—已的收束，并区分停止判断与实际离开。
 【文学对象】
 信誓旦旦，不思其反。反是不思，亦已焉哉。
 【信息状态】
-首答前只给原诗、必要字面和一个自然问题；解释、分类、关系与代表答案在学生首稿后出现。
+末两句完整并列、只给最低词义；标题不出现觉醒、离开、胜利；屏上只有两个问题，不替学生填答案。
 【学生主动作】
 选择停顿与声线；写诗写到与没有写到
 【参与路径】
-个人先形成；需要交流时并行同桌或四人轮说；全班只公开少量有差异材料。
+连读释词与自然口译70秒→个人“诗写到／没写到”双行首答75秒→公开两份与原词追问65秒→后置校准、自选朗读与转场90秒。
 【可见产物】
 停止判断边界
 【教师作用】
-准确释词、引用真实回答、追问原词、后置归纳并守住解释边界。
+校准只到“停止判断”与“实际离开未写”的边界；朗读允许疲惫、痛、清醒、决绝并存；不评最佳朗读。
 【真实等待】
-逐字稿内有首答等待、限定反馈和本人修订的明确时间。
+时间盒明示：口译70秒→双行首答75秒（零插话）→公开追问65秒→校准与自选朗读90秒；追问只认“写在哪个词里”。
 【反馈与本人修订】
-学生依据原词、同伴追问或教师校准，亲自保留、补充、改写或撤回初稿。
+听者只写实际听见的声音与原词位置；作者把“她已成功离开”改为“她形成到此为止的判断，后续行动未写”，并按听感改一处停顿重音。
 【首次后用】
 C606_S01、S03与S08
 【正常反例】
-想不起、无新增、已经准确、不同意或暂时沉默均有诚实完成路径，不要求伪造改变。
+两种声线都听不出者先准确平读；认为两种兼有者写先后层次；不要求每人公开朗读。
 【主视觉职责】
 末句与静默
 【插图资格】
 无
 【第一人称接收】
-我刚才面对“信誓旦旦，不思其反。反是不思，亦已焉哉。”，留下了停止判断边界；我能用原词说清自己新增或修正的理解。
+我写出了末句“诗明确写到的判断”与“诗没有交代的部分”；重读时我选定的停顿让我听见了自己的声线，而不是标签。
 【故事回接】
-页面结束前由一句自然复述回到谁做了什么、人物处境怎样变化以及故事推进到哪里。
+“反—不思”回环核验违誓后，“亦已焉哉”收束全诗：她形成停止的判断；故事在此停住，后面的生活由诗外想象止步。
 【删除损失】
 删除会把末句变成觉醒出走标签
 【相邻反证】
-相邻页不同时处理“学生容易看见“信誓旦旦，不思其反。反是不思，亦已焉哉。”，却不能把它准确接回人物和前后故事。”；合并会挤掉必要首答、校准或故事回接。
+不并入C604：记忆保存与违誓核验先于双声体验与边界判断；合并会让末句在没有依据时被读成口号。
 【失败信号】
-学生只能复述活动手续，不能复述诗意；首答前已经看见完成关系或答案；产物在后页没有真实消费者
+双行写成“她离家出走成功了”；朗读被评出“最佳”；校准段教师补写后续生活
 【声明边界】V5无插图桌面候选；不声称真实课堂或学生掌握已经通过。</a:t>
             </a:r>
             <a:endParaRPr lang="en-US" dirty="0"/>
@@ -8136,9 +8136,9 @@
 个人长卷已经封存，现在六组各自把一章说准。
 【V6.6逻辑页】C606_S01｜逻辑页39｜17分钟
 【前页输入】
-学生已经完成前页任务，手中保留与“及尔偕老，老使我怨。淇则有岸，隰则有泮。总角之宴，言笑晏晏。信誓旦旦，不思其反。反是不思，亦已焉哉。”有关的原词或初稿。
+五句的字词、声音、多解与事实边界均已生成（C601—C605）；六章小长卷为空，材料未封存。
 【唯一困难】
-学生容易看见“及尔偕老，老使我怨。淇则有岸，隰则有泮。总角之宴，言笑晏晏。信誓旦旦，不思其反。反是不思，亦已焉哉。”，却不能把它准确接回人物和前后故事。
+学生分别记住了多义（岸泮）、双声（末句）与边界（停止判断），却不能撤开支架讲清她为何要回到旧事、停止判断怎样一步步形成。
 【唯一功能】
 只进行一次全诗人生统整，让六章成为有转折、有因果的长卷。
 【文学对象】
@@ -8152,27 +8152,27 @@
 【可见产物】
 时间封存的个人六章长卷和公共人生长卷
 【教师作用】
-准确释词、引用真实回答、追问原词、后置归纳并守住解释边界。
+沿原诗朴素串讲转折与因果；只修事实、顺序与多解边界；不替学生统一末句声线。
 【真实等待】
-逐字稿内有首答等待、限定反馈和本人修订的明确时间。
+时间盒明示：首答283秒（不看同伴）→互证216秒（全员先说）→接长卷181秒→串讲108秒→闭卷复述164秒→收束68秒；封存后翻回即违规。
 【反馈与本人修订】
-学生依据原词、同伴追问或教师校准，亲自保留、补充、改写或撤回初稿。
+听者只核对“事件—原句—变化”三层与停止边界；讲述者定位断点后合书补说，用自然话写第六格；把实际离开改回停止判断。
 【首次后用】
 S02与S03
 【正常反例】
-想不起、无新增、已经准确、不同意或暂时沉默均有诚实完成路径，不要求伪造改变。
+讲不全者从“亦已焉哉”往前找理由；听者没有遗漏如实确认；缺一张章末卡者借同桌核对后在便笺补一格，不假装材料齐全。
 【主视觉职责】
 现场六章长卷
 【插图资格】
 无
 【第一人称接收】
-我刚才面对“及尔偕老，老使我怨。淇则有岸，隰则有泮。总角之宴，言笑晏晏。信誓旦旦，不思其反。反是不思，亦已焉哉。”，留下了时间封存的个人六章长卷和公共人生长卷；我能用原词说清自己新增或修正的理解。
+我先独立写出六章长卷，封存后靠闭卷复述接上公共长卷；我能从任一章说出它相对前一章的变化与关键原句。
 【故事回接】
-页面结束前由一句自然复述回到谁做了什么、人物处境怎样变化以及故事推进到哪里。
+她的一生接成有转折的长卷：相遇议婚→等待迁嫁→劝诫→婚变→孤立→回望与停止；第一问“她经历了什么”在此回答。
 【删除损失】
 删除会失去全文第一问，拆页会重复重建
 【相邻反证】
-相邻页不同时处理“学生容易看见“及尔偕老，老使我怨。淇则有岸，隰则有泮。总角之宴，言笑晏晏。信誓旦旦，不思其反。反是不思，亦已焉哉。”，却不能把它准确接回人物和前后故事。”；合并会挤掉必要首答、校准或故事回接。
+不并入C605：C605在两句支架内完成声音与边界，本页撤除全部支架做六章与全诗唯一一次统整；同屏会重复重建。
 【失败信号】
 个人纸带在公共答案后补抄；小组代表代替组员形成章意；长卷只有事件没有转折或因果
 【声明边界】V5无插图桌面候选；不声称真实课堂或学生掌握已经通过。</a:t>
@@ -8288,9 +8288,9 @@
 长卷已经由你们接起，下一页教师只校准顺序和断点。
 【V6.6逻辑页】C606_S01｜逻辑页39｜17分钟
 【前页输入】
-学生已经完成前页任务，手中保留与“及尔偕老，老使我怨。淇则有岸，隰则有泮。总角之宴，言笑晏晏。信誓旦旦，不思其反。反是不思，亦已焉哉。”有关的原词或初稿。
+五句的字词、声音、多解与事实边界均已生成（C601—C605）；六章小长卷为空，材料未封存。
 【唯一困难】
-学生容易看见“及尔偕老，老使我怨。淇则有岸，隰则有泮。总角之宴，言笑晏晏。信誓旦旦，不思其反。反是不思，亦已焉哉。”，却不能把它准确接回人物和前后故事。
+学生分别记住了多义（岸泮）、双声（末句）与边界（停止判断），却不能撤开支架讲清她为何要回到旧事、停止判断怎样一步步形成。
 【唯一功能】
 只进行一次全诗人生统整，让六章成为有转折、有因果的长卷。
 【文学对象】
@@ -8304,27 +8304,27 @@
 【可见产物】
 时间封存的个人六章长卷和公共人生长卷
 【教师作用】
-准确释词、引用真实回答、追问原词、后置归纳并守住解释边界。
+沿原诗朴素串讲转折与因果；只修事实、顺序与多解边界；不替学生统一末句声线。
 【真实等待】
-逐字稿内有首答等待、限定反馈和本人修订的明确时间。
+时间盒明示：首答283秒（不看同伴）→互证216秒（全员先说）→接长卷181秒→串讲108秒→闭卷复述164秒→收束68秒；封存后翻回即违规。
 【反馈与本人修订】
-学生依据原词、同伴追问或教师校准，亲自保留、补充、改写或撤回初稿。
+听者只核对“事件—原句—变化”三层与停止边界；讲述者定位断点后合书补说，用自然话写第六格；把实际离开改回停止判断。
 【首次后用】
 S02与S03
 【正常反例】
-想不起、无新增、已经准确、不同意或暂时沉默均有诚实完成路径，不要求伪造改变。
+讲不全者从“亦已焉哉”往前找理由；听者没有遗漏如实确认；缺一张章末卡者借同桌核对后在便笺补一格，不假装材料齐全。
 【主视觉职责】
 现场六章长卷
 【插图资格】
 无
 【第一人称接收】
-我刚才面对“及尔偕老，老使我怨。淇则有岸，隰则有泮。总角之宴，言笑晏晏。信誓旦旦，不思其反。反是不思，亦已焉哉。”，留下了时间封存的个人六章长卷和公共人生长卷；我能用原词说清自己新增或修正的理解。
+我先独立写出六章长卷，封存后靠闭卷复述接上公共长卷；我能从任一章说出它相对前一章的变化与关键原句。
 【故事回接】
-页面结束前由一句自然复述回到谁做了什么、人物处境怎样变化以及故事推进到哪里。
+她的一生接成有转折的长卷：相遇议婚→等待迁嫁→劝诫→婚变→孤立→回望与停止；第一问“她经历了什么”在此回答。
 【删除损失】
 删除会失去全文第一问，拆页会重复重建
 【相邻反证】
-相邻页不同时处理“学生容易看见“及尔偕老，老使我怨。淇则有岸，隰则有泮。总角之宴，言笑晏晏。信誓旦旦，不思其反。反是不思，亦已焉哉。”，却不能把它准确接回人物和前后故事。”；合并会挤掉必要首答、校准或故事回接。
+不并入C605：C605在两句支架内完成声音与边界，本页撤除全部支架做六章与全诗唯一一次统整；同屏会重复重建。
 【失败信号】
 个人纸带在公共答案后补抄；小组代表代替组员形成章意；长卷只有事件没有转折或因果
 【声明边界】V5无插图桌面候选；不声称真实课堂或学生掌握已经通过。</a:t>
@@ -8440,9 +8440,9 @@
 请看最后一眼。下一页不再显示这条答案。
 【V6.6逻辑页】C606_S01｜逻辑页39｜17分钟
 【前页输入】
-学生已经完成前页任务，手中保留与“及尔偕老，老使我怨。淇则有岸，隰则有泮。总角之宴，言笑晏晏。信誓旦旦，不思其反。反是不思，亦已焉哉。”有关的原词或初稿。
+五句的字词、声音、多解与事实边界均已生成（C601—C605）；六章小长卷为空，材料未封存。
 【唯一困难】
-学生容易看见“及尔偕老，老使我怨。淇则有岸，隰则有泮。总角之宴，言笑晏晏。信誓旦旦，不思其反。反是不思，亦已焉哉。”，却不能把它准确接回人物和前后故事。
+学生分别记住了多义（岸泮）、双声（末句）与边界（停止判断），却不能撤开支架讲清她为何要回到旧事、停止判断怎样一步步形成。
 【唯一功能】
 只进行一次全诗人生统整，让六章成为有转折、有因果的长卷。
 【文学对象】
@@ -8456,27 +8456,27 @@
 【可见产物】
 时间封存的个人六章长卷和公共人生长卷
 【教师作用】
-准确释词、引用真实回答、追问原词、后置归纳并守住解释边界。
+沿原诗朴素串讲转折与因果；只修事实、顺序与多解边界；不替学生统一末句声线。
 【真实等待】
-逐字稿内有首答等待、限定反馈和本人修订的明确时间。
+时间盒明示：首答283秒（不看同伴）→互证216秒（全员先说）→接长卷181秒→串讲108秒→闭卷复述164秒→收束68秒；封存后翻回即违规。
 【反馈与本人修订】
-学生依据原词、同伴追问或教师校准，亲自保留、补充、改写或撤回初稿。
+听者只核对“事件—原句—变化”三层与停止边界；讲述者定位断点后合书补说，用自然话写第六格；把实际离开改回停止判断。
 【首次后用】
 S02与S03
 【正常反例】
-想不起、无新增、已经准确、不同意或暂时沉默均有诚实完成路径，不要求伪造改变。
+讲不全者从“亦已焉哉”往前找理由；听者没有遗漏如实确认；缺一张章末卡者借同桌核对后在便笺补一格，不假装材料齐全。
 【主视觉职责】
 现场六章长卷
 【插图资格】
 无
 【第一人称接收】
-我刚才面对“及尔偕老，老使我怨。淇则有岸，隰则有泮。总角之宴，言笑晏晏。信誓旦旦，不思其反。反是不思，亦已焉哉。”，留下了时间封存的个人六章长卷和公共人生长卷；我能用原词说清自己新增或修正的理解。
+我先独立写出六章长卷，封存后靠闭卷复述接上公共长卷；我能从任一章说出它相对前一章的变化与关键原句。
 【故事回接】
-页面结束前由一句自然复述回到谁做了什么、人物处境怎样变化以及故事推进到哪里。
+她的一生接成有转折的长卷：相遇议婚→等待迁嫁→劝诫→婚变→孤立→回望与停止；第一问“她经历了什么”在此回答。
 【删除损失】
 删除会失去全文第一问，拆页会重复重建
 【相邻反证】
-相邻页不同时处理“学生容易看见“及尔偕老，老使我怨。淇则有岸，隰则有泮。总角之宴，言笑晏晏。信誓旦旦，不思其反。反是不思，亦已焉哉。”，却不能把它准确接回人物和前后故事。”；合并会挤掉必要首答、校准或故事回接。
+不并入C605：C605在两句支架内完成声音与边界，本页撤除全部支架做六章与全诗唯一一次统整；同屏会重复重建。
 【失败信号】
 个人纸带在公共答案后补抄；小组代表代替组员形成章意；长卷只有事件没有转折或因果
 【声明边界】V5无插图桌面候选；不声称真实课堂或学生掌握已经通过。</a:t>
@@ -8593,9 +8593,9 @@
 她的一生已经能离开屏幕和黑板讲出。现在回答第二个问题：这些不幸落在怎样的日子里？
 【V6.6逻辑页】C606_S01｜逻辑页39｜17分钟
 【前页输入】
-学生已经完成前页任务，手中保留与“及尔偕老，老使我怨。淇则有岸，隰则有泮。总角之宴，言笑晏晏。信誓旦旦，不思其反。反是不思，亦已焉哉。”有关的原词或初稿。
+五句的字词、声音、多解与事实边界均已生成（C601—C605）；六章小长卷为空，材料未封存。
 【唯一困难】
-学生容易看见“及尔偕老，老使我怨。淇则有岸，隰则有泮。总角之宴，言笑晏晏。信誓旦旦，不思其反。反是不思，亦已焉哉。”，却不能把它准确接回人物和前后故事。
+学生分别记住了多义（岸泮）、双声（末句）与边界（停止判断），却不能撤开支架讲清她为何要回到旧事、停止判断怎样一步步形成。
 【唯一功能】
 只进行一次全诗人生统整，让六章成为有转折、有因果的长卷。
 【文学对象】
@@ -8609,27 +8609,27 @@
 【可见产物】
 时间封存的个人六章长卷和公共人生长卷
 【教师作用】
-准确释词、引用真实回答、追问原词、后置归纳并守住解释边界。
+沿原诗朴素串讲转折与因果；只修事实、顺序与多解边界；不替学生统一末句声线。
 【真实等待】
-逐字稿内有首答等待、限定反馈和本人修订的明确时间。
+时间盒明示：首答283秒（不看同伴）→互证216秒（全员先说）→接长卷181秒→串讲108秒→闭卷复述164秒→收束68秒；封存后翻回即违规。
 【反馈与本人修订】
-学生依据原词、同伴追问或教师校准，亲自保留、补充、改写或撤回初稿。
+听者只核对“事件—原句—变化”三层与停止边界；讲述者定位断点后合书补说，用自然话写第六格；把实际离开改回停止判断。
 【首次后用】
 S02与S03
 【正常反例】
-想不起、无新增、已经准确、不同意或暂时沉默均有诚实完成路径，不要求伪造改变。
+讲不全者从“亦已焉哉”往前找理由；听者没有遗漏如实确认；缺一张章末卡者借同桌核对后在便笺补一格，不假装材料齐全。
 【主视觉职责】
 现场六章长卷
 【插图资格】
 无
 【第一人称接收】
-我刚才面对“及尔偕老，老使我怨。淇则有岸，隰则有泮。总角之宴，言笑晏晏。信誓旦旦，不思其反。反是不思，亦已焉哉。”，留下了时间封存的个人六章长卷和公共人生长卷；我能用原词说清自己新增或修正的理解。
+我先独立写出六章长卷，封存后靠闭卷复述接上公共长卷；我能从任一章说出它相对前一章的变化与关键原句。
 【故事回接】
-页面结束前由一句自然复述回到谁做了什么、人物处境怎样变化以及故事推进到哪里。
+她的一生接成有转折的长卷：相遇议婚→等待迁嫁→劝诫→婚变→孤立→回望与停止；第一问“她经历了什么”在此回答。
 【删除损失】
 删除会失去全文第一问，拆页会重复重建
 【相邻反证】
-相邻页不同时处理“学生容易看见“及尔偕老，老使我怨。淇则有岸，隰则有泮。总角之宴，言笑晏晏。信誓旦旦，不思其反。反是不思，亦已焉哉。”，却不能把它准确接回人物和前后故事。”；合并会挤掉必要首答、校准或故事回接。
+不并入C605：C605在两句支架内完成声音与边界，本页撤除全部支架做六章与全诗唯一一次统整；同屏会重复重建。
 【失败信号】
 个人纸带在公共答案后补抄；小组代表代替组员形成章意；长卷只有事件没有转折或因果
 【声明边界】V5无插图桌面候选；不声称真实课堂或学生掌握已经通过。</a:t>
@@ -8745,13 +8745,13 @@
 旧稿已经重新打开，现在把生活话做成可以由原诗核验的卡。
 【V6.6逻辑页】S02｜逻辑页40｜14分钟
 【前页输入】
-学生已经完成前页任务，手中保留与“第四、第五章关于食贫、长期劳作、男子失信粗暴、兄弟不知而笑和女子独自悲悼的原句”有关的原词或初稿。
+C505《一间屋子里的许多年》片段在手；S01人生长卷已接成；生活事实卡与第二问末答为空。
 【唯一困难】
-学生容易看见“第四、第五章关于食贫、长期劳作、男子失信粗暴、兄弟不知而笑和女子独自悲悼的原句”，却不能把它准确接回人物和前后故事。
+学生能复述“贫困、背叛、压榨、无支持”等标签，却不能把古诗还原成可观察的日常；也易补写诗中没有的具体伤害方式或求助史。
 【唯一功能】
 用现实生活语言说清婚后不幸的具体表现，再通过交换、猜诗和撤回越界表述返回原诗。
 【文学对象】
-第四、第五章关于食贫、长期劳作、男子失信粗暴、兄弟不知而笑和女子独自悲悼的原句
+桑之落矣，其黄而陨,自我徂尔，三岁食贫,淇水汤汤，渐车帷裳,女也不爽，士贰其行,士也罔极，二三其德,三岁为妇，靡室劳矣,夙兴夜寐，靡有朝矣,言既遂矣，至于暴矣,兄弟不知，咥其笑矣,静言思之，躬自悼矣
 【信息状态】
 首答不显示标准五类不幸；教师归纳只在学生卡组形成和核验以后出现。
 【学生主动作】
@@ -8761,15 +8761,15 @@
 【可见产物】
 C505个人片段、正反面生活事实卡和个人第二问末答
 【教师作用】
-准确释词、引用真实回答、追问原词、后置归纳并守住解释边界。
+不列现代术语清单；只引用现场片刻归纳长期贫苦劳作、失信粗暴、支持缺失与独自悲悼；不以标签替换学生作品。
 【真实等待】
-逐字稿内有首答等待、限定反馈和本人修订的明确时间。
+时间盒明示：个人取回146秒→四人轮说257秒（全员说过后才合并）→交换猜诗221秒→公共归纳216秒；轮说期间不评价不抢答。
 【反馈与本人修订】
-学生依据原词、同伴追问或教师校准，亲自保留、补充、改写或撤回初稿。
+同伴只配诗或指出越界，不评谁更悲惨；作者删去具体暴力、完整求助史、全部家人等无证细节，或把抽象标签改成一天中的行为。
 【首次后用】
 S03读取失衡事实
 【正常反例】
-想不起、无新增、已经准确、不同意或暂时沉默均有诚实完成路径，不要求伪造改变。
+能准确配回者写“可配回，无需改”；不要求每人犯错；暂时写不出者先把原句译成谁在做什么。
 【主视觉职责】
 自然书写入口和学生真实生活事实卡
 【插图资格】
@@ -8777,7 +8777,7 @@
 【第一人称接收】
 我能不用古词说清她婚后过着怎样的日子，又能把每一项送回原诗。
 【故事回接】
-页面结束前由一句自然复述回到谁做了什么、人物处境怎样变化以及故事推进到哪里。
+婚后不幸落成可观察的生活：她多年劳作、他失信转粗暴、兄弟不知而笑、她独自思量；第二问获得每人末答，事实卡交S03放置。
 【删除损失】
 不幸仍停在辛苦、悲惨等标签，C505也会沦为孤立写作。
 【相邻反证】
@@ -8897,13 +8897,13 @@
 卡片已经经得起原诗核验，下一页只归纳真实出现的生活事实。
 【V6.6逻辑页】S02｜逻辑页40｜14分钟
 【前页输入】
-学生已经完成前页任务，手中保留与“第四、第五章关于食贫、长期劳作、男子失信粗暴、兄弟不知而笑和女子独自悲悼的原句”有关的原词或初稿。
+C505《一间屋子里的许多年》片段在手；S01人生长卷已接成；生活事实卡与第二问末答为空。
 【唯一困难】
-学生容易看见“第四、第五章关于食贫、长期劳作、男子失信粗暴、兄弟不知而笑和女子独自悲悼的原句”，却不能把它准确接回人物和前后故事。
+学生能复述“贫困、背叛、压榨、无支持”等标签，却不能把古诗还原成可观察的日常；也易补写诗中没有的具体伤害方式或求助史。
 【唯一功能】
 用现实生活语言说清婚后不幸的具体表现，再通过交换、猜诗和撤回越界表述返回原诗。
 【文学对象】
-第四、第五章关于食贫、长期劳作、男子失信粗暴、兄弟不知而笑和女子独自悲悼的原句
+桑之落矣，其黄而陨,自我徂尔，三岁食贫,淇水汤汤，渐车帷裳,女也不爽，士贰其行,士也罔极，二三其德,三岁为妇，靡室劳矣,夙兴夜寐，靡有朝矣,言既遂矣，至于暴矣,兄弟不知，咥其笑矣,静言思之，躬自悼矣
 【信息状态】
 首答不显示标准五类不幸；教师归纳只在学生卡组形成和核验以后出现。
 【学生主动作】
@@ -8913,15 +8913,15 @@
 【可见产物】
 C505个人片段、正反面生活事实卡和个人第二问末答
 【教师作用】
-准确释词、引用真实回答、追问原词、后置归纳并守住解释边界。
+不列现代术语清单；只引用现场片刻归纳长期贫苦劳作、失信粗暴、支持缺失与独自悲悼；不以标签替换学生作品。
 【真实等待】
-逐字稿内有首答等待、限定反馈和本人修订的明确时间。
+时间盒明示：个人取回146秒→四人轮说257秒（全员说过后才合并）→交换猜诗221秒→公共归纳216秒；轮说期间不评价不抢答。
 【反馈与本人修订】
-学生依据原词、同伴追问或教师校准，亲自保留、补充、改写或撤回初稿。
+同伴只配诗或指出越界，不评谁更悲惨；作者删去具体暴力、完整求助史、全部家人等无证细节，或把抽象标签改成一天中的行为。
 【首次后用】
 S03读取失衡事实
 【正常反例】
-想不起、无新增、已经准确、不同意或暂时沉默均有诚实完成路径，不要求伪造改变。
+能准确配回者写“可配回，无需改”；不要求每人犯错；暂时写不出者先把原句译成谁在做什么。
 【主视觉职责】
 自然书写入口和学生真实生活事实卡
 【插图资格】
@@ -8929,7 +8929,7 @@
 【第一人称接收】
 我能不用古词说清她婚后过着怎样的日子，又能把每一项送回原诗。
 【故事回接】
-页面结束前由一句自然复述回到谁做了什么、人物处境怎样变化以及故事推进到哪里。
+婚后不幸落成可观察的生活：她多年劳作、他失信转粗暴、兄弟不知而笑、她独自思量；第二问获得每人末答，事实卡交S03放置。
 【删除损失】
 不幸仍停在辛苦、悲惨等标签，C505也会沦为孤立写作。
 【相邻反证】
@@ -9055,7 +9055,7 @@
 【唯一功能】
 不中断地接收第一至三章，让初见、等待、迁嫁和劝告先作为声音发生。
 【文学对象】
-《氓》第一至第三章的完整声音
+氓之蚩蚩，抱布贸丝,匪来贸丝，来即我谋,送子涉淇，至于顿丘,匪我愆期，子无良媒,将子无怒，秋以为期,乘彼垝垣，以望复关,不见复关，泣涕涟涟,既见复关，载笑载言,尔卜尔筮，体无咎言,以尔车来，以我贿迁,桑之未落，其叶沃若,于嗟鸠兮，无食桑葚,于嗟女兮，无与士耽,士之耽兮，犹可说也,女之耽兮，不可说也
 【信息状态】
 只暴露原诗声音；主题、章意和知识解释保持未知。
 【学生主动作】
@@ -9201,13 +9201,13 @@
 答案即将撤去，下一页只留下你自己的第二问回答。
 【V6.6逻辑页】S02｜逻辑页40｜14分钟
 【前页输入】
-学生已经完成前页任务，手中保留与“第四、第五章关于食贫、长期劳作、男子失信粗暴、兄弟不知而笑和女子独自悲悼的原句”有关的原词或初稿。
+C505《一间屋子里的许多年》片段在手；S01人生长卷已接成；生活事实卡与第二问末答为空。
 【唯一困难】
-学生容易看见“第四、第五章关于食贫、长期劳作、男子失信粗暴、兄弟不知而笑和女子独自悲悼的原句”，却不能把它准确接回人物和前后故事。
+学生能复述“贫困、背叛、压榨、无支持”等标签，却不能把古诗还原成可观察的日常；也易补写诗中没有的具体伤害方式或求助史。
 【唯一功能】
 用现实生活语言说清婚后不幸的具体表现，再通过交换、猜诗和撤回越界表述返回原诗。
 【文学对象】
-第四、第五章关于食贫、长期劳作、男子失信粗暴、兄弟不知而笑和女子独自悲悼的原句
+桑之落矣，其黄而陨,自我徂尔，三岁食贫,淇水汤汤，渐车帷裳,女也不爽，士贰其行,士也罔极，二三其德,三岁为妇，靡室劳矣,夙兴夜寐，靡有朝矣,言既遂矣，至于暴矣,兄弟不知，咥其笑矣,静言思之，躬自悼矣
 【信息状态】
 首答不显示标准五类不幸；教师归纳只在学生卡组形成和核验以后出现。
 【学生主动作】
@@ -9217,15 +9217,15 @@
 【可见产物】
 C505个人片段、正反面生活事实卡和个人第二问末答
 【教师作用】
-准确释词、引用真实回答、追问原词、后置归纳并守住解释边界。
+不列现代术语清单；只引用现场片刻归纳长期贫苦劳作、失信粗暴、支持缺失与独自悲悼；不以标签替换学生作品。
 【真实等待】
-逐字稿内有首答等待、限定反馈和本人修订的明确时间。
+时间盒明示：个人取回146秒→四人轮说257秒（全员说过后才合并）→交换猜诗221秒→公共归纳216秒；轮说期间不评价不抢答。
 【反馈与本人修订】
-学生依据原词、同伴追问或教师校准，亲自保留、补充、改写或撤回初稿。
+同伴只配诗或指出越界，不评谁更悲惨；作者删去具体暴力、完整求助史、全部家人等无证细节，或把抽象标签改成一天中的行为。
 【首次后用】
 S03读取失衡事实
 【正常反例】
-想不起、无新增、已经准确、不同意或暂时沉默均有诚实完成路径，不要求伪造改变。
+能准确配回者写“可配回，无需改”；不要求每人犯错；暂时写不出者先把原句译成谁在做什么。
 【主视觉职责】
 自然书写入口和学生真实生活事实卡
 【插图资格】
@@ -9233,7 +9233,7 @@
 【第一人称接收】
 我能不用古词说清她婚后过着怎样的日子，又能把每一项送回原诗。
 【故事回接】
-页面结束前由一句自然复述回到谁做了什么、人物处境怎样变化以及故事推进到哪里。
+婚后不幸落成可观察的生活：她多年劳作、他失信转粗暴、兄弟不知而笑、她独自思量；第二问获得每人末答，事实卡交S03放置。
 【删除损失】
 不幸仍停在辛苦、悲惨等标签，C505也会沦为孤立写作。
 【相邻反证】
@@ -9353,13 +9353,13 @@
 日子已经说清，下面追问这场婚姻为什么走到这一步。
 【V6.6逻辑页】S02｜逻辑页40｜14分钟
 【前页输入】
-学生已经完成前页任务，手中保留与“第四、第五章关于食贫、长期劳作、男子失信粗暴、兄弟不知而笑和女子独自悲悼的原句”有关的原词或初稿。
+C505《一间屋子里的许多年》片段在手；S01人生长卷已接成；生活事实卡与第二问末答为空。
 【唯一困难】
-学生容易看见“第四、第五章关于食贫、长期劳作、男子失信粗暴、兄弟不知而笑和女子独自悲悼的原句”，却不能把它准确接回人物和前后故事。
+学生能复述“贫困、背叛、压榨、无支持”等标签，却不能把古诗还原成可观察的日常；也易补写诗中没有的具体伤害方式或求助史。
 【唯一功能】
 用现实生活语言说清婚后不幸的具体表现，再通过交换、猜诗和撤回越界表述返回原诗。
 【文学对象】
-第四、第五章关于食贫、长期劳作、男子失信粗暴、兄弟不知而笑和女子独自悲悼的原句
+桑之落矣，其黄而陨,自我徂尔，三岁食贫,淇水汤汤，渐车帷裳,女也不爽，士贰其行,士也罔极，二三其德,三岁为妇，靡室劳矣,夙兴夜寐，靡有朝矣,言既遂矣，至于暴矣,兄弟不知，咥其笑矣,静言思之，躬自悼矣
 【信息状态】
 首答不显示标准五类不幸；教师归纳只在学生卡组形成和核验以后出现。
 【学生主动作】
@@ -9369,15 +9369,15 @@
 【可见产物】
 C505个人片段、正反面生活事实卡和个人第二问末答
 【教师作用】
-准确释词、引用真实回答、追问原词、后置归纳并守住解释边界。
+不列现代术语清单；只引用现场片刻归纳长期贫苦劳作、失信粗暴、支持缺失与独自悲悼；不以标签替换学生作品。
 【真实等待】
-逐字稿内有首答等待、限定反馈和本人修订的明确时间。
+时间盒明示：个人取回146秒→四人轮说257秒（全员说过后才合并）→交换猜诗221秒→公共归纳216秒；轮说期间不评价不抢答。
 【反馈与本人修订】
-学生依据原词、同伴追问或教师校准，亲自保留、补充、改写或撤回初稿。
+同伴只配诗或指出越界，不评谁更悲惨；作者删去具体暴力、完整求助史、全部家人等无证细节，或把抽象标签改成一天中的行为。
 【首次后用】
 S03读取失衡事实
 【正常反例】
-想不起、无新增、已经准确、不同意或暂时沉默均有诚实完成路径，不要求伪造改变。
+能准确配回者写“可配回，无需改”；不要求每人犯错；暂时写不出者先把原句译成谁在做什么。
 【主视觉职责】
 自然书写入口和学生真实生活事实卡
 【插图资格】
@@ -9385,7 +9385,7 @@
 【第一人称接收】
 我能不用古词说清她婚后过着怎样的日子，又能把每一项送回原诗。
 【故事回接】
-页面结束前由一句自然复述回到谁做了什么、人物处境怎样变化以及故事推进到哪里。
+婚后不幸落成可观察的生活：她多年劳作、他失信转粗暴、兄弟不知而笑、她独自思量；第二问获得每人末答，事实卡交S03放置。
 【删除损失】
 不幸仍停在辛苦、悲惨等标签，C505也会沦为孤立写作。
 【相邻反证】
@@ -9505,13 +9505,13 @@
 每组已经有个人判断，下一页让这些因果箭头接受质询。
 【V6.6逻辑页】S03｜逻辑页41｜18分钟
 【前页输入】
-学生已经完成前页任务，手中保留与“全诗中的婚前细节、婚后失信粗暴、女子长期投入与劳作、共同记忆、支持缺失及文本未写边界”有关的原词或初稿。
+S02生活事实卡已合成并核验；人生长卷在黑板；事实—作用—边界卡与原因末答为空。
 【唯一困难】
-学生容易看见“全诗中的婚前细节、婚后失信粗暴、女子长期投入与劳作、共同记忆、支持缺失及文本未写边界”，却不能把它准确接回人物和前后故事。
+原因讨论容易把早期警告、男子伤害责任、女子难以停止的条件与现代猜测混成一句，甚至把伤害责任转回女子身上。
 【唯一功能】
 沿人生长卷区分直接责任、使失衡持续的条件、支持缺失、割舍困难、婚前警讯边界和女子回应，形成不归责受伤者的完整原因结构。
 【文学对象】
-全诗中的婚前细节、婚后失信粗暴、女子长期投入与劳作、共同记忆、支持缺失及文本未写边界
+[object Object]
 【信息状态】
 首答不显示警讯、沉没成本、责任、托举等预制分类；类别名称在学生制卡后用于质询。
 【学生主动作】
@@ -9521,15 +9521,15 @@
 【可见产物】
 事实—作用—边界卡、经质询修订的原因长卷和个人原因末答
 【教师作用】
-准确释词、引用真实回答、追问原词、后置归纳并守住解释边界。
+阻断受伤者归责但不替学生猜男子动机；归纳给出“值得警惕≠完整预谋”“投入与支持缺失使停止困难但不分担责任”的边界。
 【真实等待】
-逐字稿内有首答等待、限定反馈和本人修订的明确时间。
+时间盒明示：首答204秒（封存）→轮说294秒（全员先说）→放置144秒→质询192秒→返诗修订114秒→归纳132秒；质询只认原句直接证明什么。
 【反馈与本人修订】
-学生依据原词、同伴追问或教师校准，亲自保留、补充、改写或撤回初稿。
+同桌只问原句直接证明什么、有没有把“她为何难停”写成“他为何伤害”；作者把投入、劳作、共同记忆、支持缺失放回难以停止，把失信、反复、粗暴放回直接责任。
 【首次后用】
 S04由悲剧反推共同生活支点
 【正常反例】
-想不起、无新增、已经准确、不同意或暂时沉默均有诚实完成路径，不要求伪造改变。
+责任清楚证据稳妥者写“两项均通过，保留”；全班无真实分歧时不人为制造争议，直接比较两种准确表述。
 【主视觉职责】
 未完成的人生长卷与学生原因证据卡
 【插图资格】
@@ -9537,7 +9537,7 @@
 【第一人称接收】
 我能独立说明责任、持续条件、支持缺失、为何难以割舍、婚前可观察而不可倒推的边界，以及她最后的回应。
 【故事回接】
-页面结束前由一句自然复述回到谁做了什么、人物处境怎样变化以及故事推进到哪里。
+悲剧的形成被分层说清：他的失信反复粗暴直接造成伤害，她的投入与支持缺失使停止困难；第三问获得不归责受伤者的完整回答，长卷交S04反推支点。
 【删除损失】
 三问第三问缺少整体、有界和不归责的个人解释。
 【相邻反证】
@@ -9657,13 +9657,13 @@
 箭头经受过质询，下一页教师只把责任和边界说清。
 【V6.6逻辑页】S03｜逻辑页41｜18分钟
 【前页输入】
-学生已经完成前页任务，手中保留与“全诗中的婚前细节、婚后失信粗暴、女子长期投入与劳作、共同记忆、支持缺失及文本未写边界”有关的原词或初稿。
+S02生活事实卡已合成并核验；人生长卷在黑板；事实—作用—边界卡与原因末答为空。
 【唯一困难】
-学生容易看见“全诗中的婚前细节、婚后失信粗暴、女子长期投入与劳作、共同记忆、支持缺失及文本未写边界”，却不能把它准确接回人物和前后故事。
+原因讨论容易把早期警告、男子伤害责任、女子难以停止的条件与现代猜测混成一句，甚至把伤害责任转回女子身上。
 【唯一功能】
 沿人生长卷区分直接责任、使失衡持续的条件、支持缺失、割舍困难、婚前警讯边界和女子回应，形成不归责受伤者的完整原因结构。
 【文学对象】
-全诗中的婚前细节、婚后失信粗暴、女子长期投入与劳作、共同记忆、支持缺失及文本未写边界
+[object Object]
 【信息状态】
 首答不显示警讯、沉没成本、责任、托举等预制分类；类别名称在学生制卡后用于质询。
 【学生主动作】
@@ -9673,15 +9673,15 @@
 【可见产物】
 事实—作用—边界卡、经质询修订的原因长卷和个人原因末答
 【教师作用】
-准确释词、引用真实回答、追问原词、后置归纳并守住解释边界。
+阻断受伤者归责但不替学生猜男子动机；归纳给出“值得警惕≠完整预谋”“投入与支持缺失使停止困难但不分担责任”的边界。
 【真实等待】
-逐字稿内有首答等待、限定反馈和本人修订的明确时间。
+时间盒明示：首答204秒（封存）→轮说294秒（全员先说）→放置144秒→质询192秒→返诗修订114秒→归纳132秒；质询只认原句直接证明什么。
 【反馈与本人修订】
-学生依据原词、同伴追问或教师校准，亲自保留、补充、改写或撤回初稿。
+同桌只问原句直接证明什么、有没有把“她为何难停”写成“他为何伤害”；作者把投入、劳作、共同记忆、支持缺失放回难以停止，把失信、反复、粗暴放回直接责任。
 【首次后用】
 S04由悲剧反推共同生活支点
 【正常反例】
-想不起、无新增、已经准确、不同意或暂时沉默均有诚实完成路径，不要求伪造改变。
+责任清楚证据稳妥者写“两项均通过，保留”；全班无真实分歧时不人为制造争议，直接比较两种准确表述。
 【主视觉职责】
 未完成的人生长卷与学生原因证据卡
 【插图资格】
@@ -9689,7 +9689,7 @@
 【第一人称接收】
 我能独立说明责任、持续条件、支持缺失、为何难以割舍、婚前可观察而不可倒推的边界，以及她最后的回应。
 【故事回接】
-页面结束前由一句自然复述回到谁做了什么、人物处境怎样变化以及故事推进到哪里。
+悲剧的形成被分层说清：他的失信反复粗暴直接造成伤害，她的投入与支持缺失使停止困难；第三问获得不归责受伤者的完整回答，长卷交S04反推支点。
 【删除损失】
 三问第三问缺少整体、有界和不归责的个人解释。
 【相邻反证】
@@ -9809,13 +9809,13 @@
 公共归纳到这里。下一页撤掉它，每个人独立完成第三问。
 【V6.6逻辑页】S03｜逻辑页41｜18分钟
 【前页输入】
-学生已经完成前页任务，手中保留与“全诗中的婚前细节、婚后失信粗暴、女子长期投入与劳作、共同记忆、支持缺失及文本未写边界”有关的原词或初稿。
+S02生活事实卡已合成并核验；人生长卷在黑板；事实—作用—边界卡与原因末答为空。
 【唯一困难】
-学生容易看见“全诗中的婚前细节、婚后失信粗暴、女子长期投入与劳作、共同记忆、支持缺失及文本未写边界”，却不能把它准确接回人物和前后故事。
+原因讨论容易把早期警告、男子伤害责任、女子难以停止的条件与现代猜测混成一句，甚至把伤害责任转回女子身上。
 【唯一功能】
 沿人生长卷区分直接责任、使失衡持续的条件、支持缺失、割舍困难、婚前警讯边界和女子回应，形成不归责受伤者的完整原因结构。
 【文学对象】
-全诗中的婚前细节、婚后失信粗暴、女子长期投入与劳作、共同记忆、支持缺失及文本未写边界
+[object Object]
 【信息状态】
 首答不显示警讯、沉没成本、责任、托举等预制分类；类别名称在学生制卡后用于质询。
 【学生主动作】
@@ -9825,15 +9825,15 @@
 【可见产物】
 事实—作用—边界卡、经质询修订的原因长卷和个人原因末答
 【教师作用】
-准确释词、引用真实回答、追问原词、后置归纳并守住解释边界。
+阻断受伤者归责但不替学生猜男子动机；归纳给出“值得警惕≠完整预谋”“投入与支持缺失使停止困难但不分担责任”的边界。
 【真实等待】
-逐字稿内有首答等待、限定反馈和本人修订的明确时间。
+时间盒明示：首答204秒（封存）→轮说294秒（全员先说）→放置144秒→质询192秒→返诗修订114秒→归纳132秒；质询只认原句直接证明什么。
 【反馈与本人修订】
-学生依据原词、同伴追问或教师校准，亲自保留、补充、改写或撤回初稿。
+同桌只问原句直接证明什么、有没有把“她为何难停”写成“他为何伤害”；作者把投入、劳作、共同记忆、支持缺失放回难以停止，把失信、反复、粗暴放回直接责任。
 【首次后用】
 S04由悲剧反推共同生活支点
 【正常反例】
-想不起、无新增、已经准确、不同意或暂时沉默均有诚实完成路径，不要求伪造改变。
+责任清楚证据稳妥者写“两项均通过，保留”；全班无真实分歧时不人为制造争议，直接比较两种准确表述。
 【主视觉职责】
 未完成的人生长卷与学生原因证据卡
 【插图资格】
@@ -9841,7 +9841,7 @@
 【第一人称接收】
 我能独立说明责任、持续条件、支持缺失、为何难以割舍、婚前可观察而不可倒推的边界，以及她最后的回应。
 【故事回接】
-页面结束前由一句自然复述回到谁做了什么、人物处境怎样变化以及故事推进到哪里。
+悲剧的形成被分层说清：他的失信反复粗暴直接造成伤害，她的投入与支持缺失使停止困难；第三问获得不归责受伤者的完整回答，长卷交S04反推支点。
 【删除损失】
 三问第三问缺少整体、有界和不归责的个人解释。
 【相邻反证】
@@ -9961,13 +9961,13 @@
 悲剧为什么发生已经说清，现在转向未来：好的共同生活靠什么站稳？
 【V6.6逻辑页】S03｜逻辑页41｜18分钟
 【前页输入】
-学生已经完成前页任务，手中保留与“全诗中的婚前细节、婚后失信粗暴、女子长期投入与劳作、共同记忆、支持缺失及文本未写边界”有关的原词或初稿。
+S02生活事实卡已合成并核验；人生长卷在黑板；事实—作用—边界卡与原因末答为空。
 【唯一困难】
-学生容易看见“全诗中的婚前细节、婚后失信粗暴、女子长期投入与劳作、共同记忆、支持缺失及文本未写边界”，却不能把它准确接回人物和前后故事。
+原因讨论容易把早期警告、男子伤害责任、女子难以停止的条件与现代猜测混成一句，甚至把伤害责任转回女子身上。
 【唯一功能】
 沿人生长卷区分直接责任、使失衡持续的条件、支持缺失、割舍困难、婚前警讯边界和女子回应，形成不归责受伤者的完整原因结构。
 【文学对象】
-全诗中的婚前细节、婚后失信粗暴、女子长期投入与劳作、共同记忆、支持缺失及文本未写边界
+[object Object]
 【信息状态】
 首答不显示警讯、沉没成本、责任、托举等预制分类；类别名称在学生制卡后用于质询。
 【学生主动作】
@@ -9977,15 +9977,15 @@
 【可见产物】
 事实—作用—边界卡、经质询修订的原因长卷和个人原因末答
 【教师作用】
-准确释词、引用真实回答、追问原词、后置归纳并守住解释边界。
+阻断受伤者归责但不替学生猜男子动机；归纳给出“值得警惕≠完整预谋”“投入与支持缺失使停止困难但不分担责任”的边界。
 【真实等待】
-逐字稿内有首答等待、限定反馈和本人修订的明确时间。
+时间盒明示：首答204秒（封存）→轮说294秒（全员先说）→放置144秒→质询192秒→返诗修订114秒→归纳132秒；质询只认原句直接证明什么。
 【反馈与本人修订】
-学生依据原词、同伴追问或教师校准，亲自保留、补充、改写或撤回初稿。
+同桌只问原句直接证明什么、有没有把“她为何难停”写成“他为何伤害”；作者把投入、劳作、共同记忆、支持缺失放回难以停止，把失信、反复、粗暴放回直接责任。
 【首次后用】
 S04由悲剧反推共同生活支点
 【正常反例】
-想不起、无新增、已经准确、不同意或暂时沉默均有诚实完成路径，不要求伪造改变。
+责任清楚证据稳妥者写“两项均通过，保留”；全班无真实分歧时不人为制造争议，直接比较两种准确表述。
 【主视觉职责】
 未完成的人生长卷与学生原因证据卡
 【插图资格】
@@ -9993,7 +9993,7 @@
 【第一人称接收】
 我能独立说明责任、持续条件、支持缺失、为何难以割舍、婚前可观察而不可倒推的边界，以及她最后的回应。
 【故事回接】
-页面结束前由一句自然复述回到谁做了什么、人物处境怎样变化以及故事推进到哪里。
+悲剧的形成被分层说清：他的失信反复粗暴直接造成伤害，她的投入与支持缺失使停止困难；第三问获得不归责受伤者的完整回答，长卷交S04反推支点。
 【删除损失】
 三问第三问缺少整体、有界和不归责的个人解释。
 【相邻反证】
@@ -10113,13 +10113,13 @@
 每个人都有一句话了，现在按座位依次说给小组听。
 【V6.6逻辑页】S04｜逻辑页42｜15分钟
 【前页输入】
-学生已经完成前页任务，手中保留与“O03保存的本班爱情与婚姻文学主题谱照片、学生开课时的一条朴素主题及《氓》反面证据”有关的原词或初稿。
+原因结构已完成（S03）；开课主题谱照片仍在教室；每人自选原诗一处与关系条件为空。
 【唯一困难】
-学生容易看见“O03保存的本班爱情与婚姻文学主题谱照片、学生开课时的一条朴素主题及《氓》反面证据”，却不能把它准确接回人物和前后故事。
+开课主题谱若不被重新打开，导入只是一场热闹；婚姻讨论又易滑向教师口号、私人自曝或抽象的“要有爱”。
 【唯一功能】
 让每个人以一处原诗形成婚姻观，再由全员轮说和冲突质询生成班级共同生活支点。
 【文学对象】
-O03保存的本班爱情与婚姻文学主题谱照片、学生开课时的一条朴素主题及《氓》反面证据
+[object Object]
 【信息状态】
 首屏不预填好的婚姻结构；教师支点只在学生卡片形成后归纳。
 【学生主动作】
@@ -10129,15 +10129,15 @@
 【可见产物】
 每组一张给未来的共同生活支点卡
 【教师作用】
-准确释词、引用真实回答、追问原词、后置归纳并守住解释边界。
+只谈作品或第三人称；不收集学生恋爱婚姻家庭经历；归纳只到审慎了解、言行一致、劳动与权力平衡、责任承担、理解支持、及时止损等方向，不宣布唯一模板。
 【真实等待】
-逐字稿内有首答等待、限定反馈和本人修订的明确时间。
+时间盒明示：个人准备115秒→全员轮说254秒（所有人说过以前不评价不抢答）→合并一卡173秒→质询162秒→归纳127秒→回投69秒。
 【反馈与本人修订】
-学生依据原词、同伴追问或教师校准，亲自保留、补充、改写或撤回初稿。
+同伴只核文本与行为是否对应，不评私人选择；作者把“要幸福、不要恋爱脑、要有爱”改成承诺是否经得起行动、劳动与决定是否长期失衡、伤害后是否担责等可观察行为。
 【首次后用】
 S08终课引用；真实试教评估
 【正常反例】
-想不起、无新增、已经准确、不同意或暂时沉默均有诚实完成路径，不要求伪造改变。
+原主题经《氓》后仍成立者写“保留”但说明多了哪一层；小组一致时不强制制造分歧；不愿公开者只在组内完成。
 【主视觉职责】
 开放问题；随后由真实学生卡形成平衡木
 【插图资格】
@@ -10145,7 +10145,7 @@
 【第一人称接收】
 我用一处原诗表达了自己的婚姻观，也听见并参与形成了一张给未来的共同生活条件卡。
 【故事回接】
-页面结束前由一句自然复述回到谁做了什么、人物处境怎样变化以及故事推进到哪里。
+从悲剧反推支点：理解、言行、平衡、责任、托举被贴上平衡木；开课主题谱被重新打开，导入的旧主题获得《氓》之后的新层次。
 【删除损失】
 全文讨论停在悲剧诊断，导入主题谱成为孤儿。
 【相邻反证】
@@ -10265,13 +10265,13 @@
 卡片已经来自你们，下一页教师只沿这些真实话语收束。
 【V6.6逻辑页】S04｜逻辑页42｜15分钟
 【前页输入】
-学生已经完成前页任务，手中保留与“O03保存的本班爱情与婚姻文学主题谱照片、学生开课时的一条朴素主题及《氓》反面证据”有关的原词或初稿。
+原因结构已完成（S03）；开课主题谱照片仍在教室；每人自选原诗一处与关系条件为空。
 【唯一困难】
-学生容易看见“O03保存的本班爱情与婚姻文学主题谱照片、学生开课时的一条朴素主题及《氓》反面证据”，却不能把它准确接回人物和前后故事。
+开课主题谱若不被重新打开，导入只是一场热闹；婚姻讨论又易滑向教师口号、私人自曝或抽象的“要有爱”。
 【唯一功能】
 让每个人以一处原诗形成婚姻观，再由全员轮说和冲突质询生成班级共同生活支点。
 【文学对象】
-O03保存的本班爱情与婚姻文学主题谱照片、学生开课时的一条朴素主题及《氓》反面证据
+[object Object]
 【信息状态】
 首屏不预填好的婚姻结构；教师支点只在学生卡片形成后归纳。
 【学生主动作】
@@ -10281,15 +10281,15 @@
 【可见产物】
 每组一张给未来的共同生活支点卡
 【教师作用】
-准确释词、引用真实回答、追问原词、后置归纳并守住解释边界。
+只谈作品或第三人称；不收集学生恋爱婚姻家庭经历；归纳只到审慎了解、言行一致、劳动与权力平衡、责任承担、理解支持、及时止损等方向，不宣布唯一模板。
 【真实等待】
-逐字稿内有首答等待、限定反馈和本人修订的明确时间。
+时间盒明示：个人准备115秒→全员轮说254秒（所有人说过以前不评价不抢答）→合并一卡173秒→质询162秒→归纳127秒→回投69秒。
 【反馈与本人修订】
-学生依据原词、同伴追问或教师校准，亲自保留、补充、改写或撤回初稿。
+同伴只核文本与行为是否对应，不评私人选择；作者把“要幸福、不要恋爱脑、要有爱”改成承诺是否经得起行动、劳动与决定是否长期失衡、伤害后是否担责等可观察行为。
 【首次后用】
 S08终课引用；真实试教评估
 【正常反例】
-想不起、无新增、已经准确、不同意或暂时沉默均有诚实完成路径，不要求伪造改变。
+原主题经《氓》后仍成立者写“保留”但说明多了哪一层；小组一致时不强制制造分歧；不愿公开者只在组内完成。
 【主视觉职责】
 开放问题；随后由真实学生卡形成平衡木
 【插图资格】
@@ -10297,7 +10297,7 @@
 【第一人称接收】
 我用一处原诗表达了自己的婚姻观，也听见并参与形成了一张给未来的共同生活条件卡。
 【故事回接】
-页面结束前由一句自然复述回到谁做了什么、人物处境怎样变化以及故事推进到哪里。
+从悲剧反推支点：理解、言行、平衡、责任、托举被贴上平衡木；开课主题谱被重新打开，导入的旧主题获得《氓》之后的新层次。
 【删除损失】
 全文讨论停在悲剧诊断，导入主题谱成为孤儿。
 【相邻反证】
@@ -10418,13 +10418,13 @@
 你们的话已经先被听见。现在才把诗中写到的事实与我们由诗想到今天的话分开。
 【V6.6逻辑页】S04｜逻辑页42｜15分钟
 【前页输入】
-学生已经完成前页任务，手中保留与“O03保存的本班爱情与婚姻文学主题谱照片、学生开课时的一条朴素主题及《氓》反面证据”有关的原词或初稿。
+原因结构已完成（S03）；开课主题谱照片仍在教室；每人自选原诗一处与关系条件为空。
 【唯一困难】
-学生容易看见“O03保存的本班爱情与婚姻文学主题谱照片、学生开课时的一条朴素主题及《氓》反面证据”，却不能把它准确接回人物和前后故事。
+开课主题谱若不被重新打开，导入只是一场热闹；婚姻讨论又易滑向教师口号、私人自曝或抽象的“要有爱”。
 【唯一功能】
 让每个人以一处原诗形成婚姻观，再由全员轮说和冲突质询生成班级共同生活支点。
 【文学对象】
-O03保存的本班爱情与婚姻文学主题谱照片、学生开课时的一条朴素主题及《氓》反面证据
+[object Object]
 【信息状态】
 首屏不预填好的婚姻结构；教师支点只在学生卡片形成后归纳。
 【学生主动作】
@@ -10434,15 +10434,15 @@
 【可见产物】
 每组一张给未来的共同生活支点卡
 【教师作用】
-准确释词、引用真实回答、追问原词、后置归纳并守住解释边界。
+只谈作品或第三人称；不收集学生恋爱婚姻家庭经历；归纳只到审慎了解、言行一致、劳动与权力平衡、责任承担、理解支持、及时止损等方向，不宣布唯一模板。
 【真实等待】
-逐字稿内有首答等待、限定反馈和本人修订的明确时间。
+时间盒明示：个人准备115秒→全员轮说254秒（所有人说过以前不评价不抢答）→合并一卡173秒→质询162秒→归纳127秒→回投69秒。
 【反馈与本人修订】
-学生依据原词、同伴追问或教师校准，亲自保留、补充、改写或撤回初稿。
+同伴只核文本与行为是否对应，不评私人选择；作者把“要幸福、不要恋爱脑、要有爱”改成承诺是否经得起行动、劳动与决定是否长期失衡、伤害后是否担责等可观察行为。
 【首次后用】
 S08终课引用；真实试教评估
 【正常反例】
-想不起、无新增、已经准确、不同意或暂时沉默均有诚实完成路径，不要求伪造改变。
+原主题经《氓》后仍成立者写“保留”但说明多了哪一层；小组一致时不强制制造分歧；不愿公开者只在组内完成。
 【主视觉职责】
 开放问题；随后由真实学生卡形成平衡木
 【插图资格】
@@ -10450,7 +10450,7 @@
 【第一人称接收】
 我用一处原诗表达了自己的婚姻观，也听见并参与形成了一张给未来的共同生活条件卡。
 【故事回接】
-页面结束前由一句自然复述回到谁做了什么、人物处境怎样变化以及故事推进到哪里。
+从悲剧反推支点：理解、言行、平衡、责任、托举被贴上平衡木；开课主题谱被重新打开，导入的旧主题获得《氓》之后的新层次。
 【删除损失】
 全文讨论停在悲剧诊断，导入主题谱成为孤儿。
 【相邻反证】
@@ -10570,13 +10570,13 @@
 分层已经清楚。接下来把这些认识带回开头的文学长卷。
 【V6.6逻辑页】S04｜逻辑页42｜15分钟
 【前页输入】
-学生已经完成前页任务，手中保留与“O03保存的本班爱情与婚姻文学主题谱照片、学生开课时的一条朴素主题及《氓》反面证据”有关的原词或初稿。
+原因结构已完成（S03）；开课主题谱照片仍在教室；每人自选原诗一处与关系条件为空。
 【唯一困难】
-学生容易看见“O03保存的本班爱情与婚姻文学主题谱照片、学生开课时的一条朴素主题及《氓》反面证据”，却不能把它准确接回人物和前后故事。
+开课主题谱若不被重新打开，导入只是一场热闹；婚姻讨论又易滑向教师口号、私人自曝或抽象的“要有爱”。
 【唯一功能】
 让每个人以一处原诗形成婚姻观，再由全员轮说和冲突质询生成班级共同生活支点。
 【文学对象】
-O03保存的本班爱情与婚姻文学主题谱照片、学生开课时的一条朴素主题及《氓》反面证据
+[object Object]
 【信息状态】
 首屏不预填好的婚姻结构；教师支点只在学生卡片形成后归纳。
 【学生主动作】
@@ -10586,15 +10586,15 @@
 【可见产物】
 每组一张给未来的共同生活支点卡
 【教师作用】
-准确释词、引用真实回答、追问原词、后置归纳并守住解释边界。
+只谈作品或第三人称；不收集学生恋爱婚姻家庭经历；归纳只到审慎了解、言行一致、劳动与权力平衡、责任承担、理解支持、及时止损等方向，不宣布唯一模板。
 【真实等待】
-逐字稿内有首答等待、限定反馈和本人修订的明确时间。
+时间盒明示：个人准备115秒→全员轮说254秒（所有人说过以前不评价不抢答）→合并一卡173秒→质询162秒→归纳127秒→回投69秒。
 【反馈与本人修订】
-学生依据原词、同伴追问或教师校准，亲自保留、补充、改写或撤回初稿。
+同伴只核文本与行为是否对应，不评私人选择；作者把“要幸福、不要恋爱脑、要有爱”改成承诺是否经得起行动、劳动与决定是否长期失衡、伤害后是否担责等可观察行为。
 【首次后用】
 S08终课引用；真实试教评估
 【正常反例】
-想不起、无新增、已经准确、不同意或暂时沉默均有诚实完成路径，不要求伪造改变。
+原主题经《氓》后仍成立者写“保留”但说明多了哪一层；小组一致时不强制制造分歧；不愿公开者只在组内完成。
 【主视觉职责】
 开放问题；随后由真实学生卡形成平衡木
 【插图资格】
@@ -10602,7 +10602,7 @@
 【第一人称接收】
 我用一处原诗表达了自己的婚姻观，也听见并参与形成了一张给未来的共同生活条件卡。
 【故事回接】
-页面结束前由一句自然复述回到谁做了什么、人物处境怎样变化以及故事推进到哪里。
+从悲剧反推支点：理解、言行、平衡、责任、托举被贴上平衡木；开课主题谱被重新打开，导入的旧主题获得《氓》之后的新层次。
 【删除损失】
 全文讨论停在悲剧诊断，导入主题谱成为孤儿。
 【相邻反证】
@@ -10728,7 +10728,7 @@
 【唯一功能】
 不中断地接收第一至三章，让初见、等待、迁嫁和劝告先作为声音发生。
 【文学对象】
-《氓》第一至第三章的完整声音
+氓之蚩蚩，抱布贸丝,匪来贸丝，来即我谋,送子涉淇，至于顿丘,匪我愆期，子无良媒,将子无怒，秋以为期,乘彼垝垣，以望复关,不见复关，泣涕涟涟,既见复关，载笑载言,尔卜尔筮，体无咎言,以尔车来，以我贿迁,桑之未落，其叶沃若,于嗟鸠兮，无食桑葚,于嗟女兮，无与士耽,士之耽兮，犹可说也,女之耽兮，不可说也
 【信息状态】
 只暴露原诗声音；主题、章意和知识解释保持未知。
 【学生主动作】
@@ -10874,13 +10874,13 @@
 文学长卷已经多了一篇《氓》。下面把文化、字词和诗法收好。
 【V6.6逻辑页】S04｜逻辑页42｜15分钟
 【前页输入】
-学生已经完成前页任务，手中保留与“O03保存的本班爱情与婚姻文学主题谱照片、学生开课时的一条朴素主题及《氓》反面证据”有关的原词或初稿。
+原因结构已完成（S03）；开课主题谱照片仍在教室；每人自选原诗一处与关系条件为空。
 【唯一困难】
-学生容易看见“O03保存的本班爱情与婚姻文学主题谱照片、学生开课时的一条朴素主题及《氓》反面证据”，却不能把它准确接回人物和前后故事。
+开课主题谱若不被重新打开，导入只是一场热闹；婚姻讨论又易滑向教师口号、私人自曝或抽象的“要有爱”。
 【唯一功能】
 让每个人以一处原诗形成婚姻观，再由全员轮说和冲突质询生成班级共同生活支点。
 【文学对象】
-O03保存的本班爱情与婚姻文学主题谱照片、学生开课时的一条朴素主题及《氓》反面证据
+[object Object]
 【信息状态】
 首屏不预填好的婚姻结构；教师支点只在学生卡片形成后归纳。
 【学生主动作】
@@ -10890,15 +10890,15 @@
 【可见产物】
 每组一张给未来的共同生活支点卡
 【教师作用】
-准确释词、引用真实回答、追问原词、后置归纳并守住解释边界。
+只谈作品或第三人称；不收集学生恋爱婚姻家庭经历；归纳只到审慎了解、言行一致、劳动与权力平衡、责任承担、理解支持、及时止损等方向，不宣布唯一模板。
 【真实等待】
-逐字稿内有首答等待、限定反馈和本人修订的明确时间。
+时间盒明示：个人准备115秒→全员轮说254秒（所有人说过以前不评价不抢答）→合并一卡173秒→质询162秒→归纳127秒→回投69秒。
 【反馈与本人修订】
-学生依据原词、同伴追问或教师校准，亲自保留、补充、改写或撤回初稿。
+同伴只核文本与行为是否对应，不评私人选择；作者把“要幸福、不要恋爱脑、要有爱”改成承诺是否经得起行动、劳动与决定是否长期失衡、伤害后是否担责等可观察行为。
 【首次后用】
 S08终课引用；真实试教评估
 【正常反例】
-想不起、无新增、已经准确、不同意或暂时沉默均有诚实完成路径，不要求伪造改变。
+原主题经《氓》后仍成立者写“保留”但说明多了哪一层；小组一致时不强制制造分歧；不愿公开者只在组内完成。
 【主视觉职责】
 开放问题；随后由真实学生卡形成平衡木
 【插图资格】
@@ -10906,7 +10906,7 @@
 【第一人称接收】
 我用一处原诗表达了自己的婚姻观，也听见并参与形成了一张给未来的共同生活条件卡。
 【故事回接】
-页面结束前由一句自然复述回到谁做了什么、人物处境怎样变化以及故事推进到哪里。
+从悲剧反推支点：理解、言行、平衡、责任、托举被贴上平衡木；开课主题谱被重新打开，导入的旧主题获得《氓》之后的新层次。
 【删除损失】
 全文讨论停在悲剧诊断，导入主题谱成为孤儿。
 【相邻反证】
@@ -11026,45 +11026,45 @@
 首答已经封存，现在打开开篇批注，只修错空。
 【V6.6逻辑页】S05A｜逻辑页43｜6分钟
 【前页输入】
-学生已经完成前页任务，手中保留与“《诗经》，我们真正记住了什么？”有关的原词或初稿。
+O04文化坐标已在开课给出并留在批注；五项修复稿为空；教材可翻回。
 【唯一困难】
-学生容易看见“《诗经》，我们真正记住了什么？”，却不能把它准确接回人物和前后故事。
+学生把“看过”当“记住”：开篇文化入口若无合书检索，第一部诗歌总集、305篇、年代、风雅颂与篇目归属五项可能一项也写不出。
 【唯一功能】
 检验开篇文化入口是否真正留下，并修复第一部诗歌总集、305篇、大致年代、风雅颂和篇目归属。
 【文学对象】
-《诗经》，我们真正记住了什么？
+[object Object]
 【信息状态】
 首答不显示第一部诗歌总集、305篇、年代、风雅颂和卫风答案；校准在等待以后。
 【学生主动作】
 合书完成五项文化检索；开书或看课堂批注核对，再合书串说
 【参与路径】
-个人先形成；需要交流时并行同桌或四人轮说；全班只公开少量有差异材料。
+合书五项首答125秒（封存）→开书与批注核对、本人只修错空项115秒→教师准确收束真实错项55秒→再合书同桌串说65秒。
 【可见产物】
 《诗经》五项文化修复稿
 【教师作用】
-准确释词、引用真实回答、追问原词、后置归纳并守住解释边界。
+核对段只给准确五项（首部诗歌总集、305篇、西周初年至春秋中叶、风雅颂、《卫风》）；收束只针对真实错项；不扩展新文化点。
 【真实等待】
-逐字稿内有首答等待、限定反馈和本人修订的明确时间。
+时间盒明示：合书首答125秒（不偷看）→开书修复115秒→收束55秒→合书串说65秒；首答与串说两次合书。
 【反馈与本人修订】
-学生依据原词、同伴追问或教师校准，亲自保留、补充、改写或撤回初稿。
+开书后由本人只修自己错空处；同桌串说只核五项是否说全；全对者写“五项准确，无需改”。
 【首次后用】
 S06艺术收纳和S08终读
 【正常反例】
-想不起、无新增、已经准确、不同意或暂时沉默均有诚实完成路径，不要求伪造改变。
+不确定可以留空不偷看；只记得两三项者先修这两三项；串说不全者听同桌后自己再说一遍。
 【主视觉职责】
 四个开放检索问题
 【插图资格】
 无
 【第一人称接收】
-我刚才面对“《诗经》，我们真正记住了什么？”，留下了《诗经》五项文化修复稿；我能用原词说清自己新增或修正的理解。
+我合书写出了五项中的若干项，开书只修错空处；再合书时我能用两句话把五项连着说给同桌听。
 【故事回接】
-页面结束前由一句自然复述回到谁做了什么、人物处境怎样变化以及故事推进到哪里。
+《诗经》坐标被真正收进口袋：她的声音属于《卫风》、来自三千年前的采诗传统；知识面兜底完成，切页句转向字词回句。
 【删除损失】
 开篇文化输入未经检索，学生可能把看过冒充记住。
 【相邻反证】
-相邻页不同时处理“学生容易看见“《诗经》，我们真正记住了什么？”，却不能把它准确接回人物和前后故事。”；合并会挤掉必要首答、校准或故事回接。
+不并入S05B：文化五项是检索修复，字词是音义原句通关；同屏会使两种检索互相打断、都无法合书完成。
 【失败信号】
-学生只能复述活动手续，不能复述诗意；首答前已经看见完成关系或答案；产物在后页没有真实消费者
+首答偷看批注或同桌；教师替学生逐项报答案；串说段仍开着书
 【声明边界】V5无插图桌面候选；不声称真实课堂或学生掌握已经通过。</a:t>
             </a:r>
             <a:endParaRPr lang="en-US" dirty="0"/>
@@ -11178,45 +11178,45 @@
 答案只看这一遍。下一页再次合书，用自己的话取回。
 【V6.6逻辑页】S05A｜逻辑页43｜6分钟
 【前页输入】
-学生已经完成前页任务，手中保留与“《诗经》，我们真正记住了什么？”有关的原词或初稿。
+O04文化坐标已在开课给出并留在批注；五项修复稿为空；教材可翻回。
 【唯一困难】
-学生容易看见“《诗经》，我们真正记住了什么？”，却不能把它准确接回人物和前后故事。
+学生把“看过”当“记住”：开篇文化入口若无合书检索，第一部诗歌总集、305篇、年代、风雅颂与篇目归属五项可能一项也写不出。
 【唯一功能】
 检验开篇文化入口是否真正留下，并修复第一部诗歌总集、305篇、大致年代、风雅颂和篇目归属。
 【文学对象】
-《诗经》，我们真正记住了什么？
+[object Object]
 【信息状态】
 首答不显示第一部诗歌总集、305篇、年代、风雅颂和卫风答案；校准在等待以后。
 【学生主动作】
 合书完成五项文化检索；开书或看课堂批注核对，再合书串说
 【参与路径】
-个人先形成；需要交流时并行同桌或四人轮说；全班只公开少量有差异材料。
+合书五项首答125秒（封存）→开书与批注核对、本人只修错空项115秒→教师准确收束真实错项55秒→再合书同桌串说65秒。
 【可见产物】
 《诗经》五项文化修复稿
 【教师作用】
-准确释词、引用真实回答、追问原词、后置归纳并守住解释边界。
+核对段只给准确五项（首部诗歌总集、305篇、西周初年至春秋中叶、风雅颂、《卫风》）；收束只针对真实错项；不扩展新文化点。
 【真实等待】
-逐字稿内有首答等待、限定反馈和本人修订的明确时间。
+时间盒明示：合书首答125秒（不偷看）→开书修复115秒→收束55秒→合书串说65秒；首答与串说两次合书。
 【反馈与本人修订】
-学生依据原词、同伴追问或教师校准，亲自保留、补充、改写或撤回初稿。
+开书后由本人只修自己错空处；同桌串说只核五项是否说全；全对者写“五项准确，无需改”。
 【首次后用】
 S06艺术收纳和S08终读
 【正常反例】
-想不起、无新增、已经准确、不同意或暂时沉默均有诚实完成路径，不要求伪造改变。
+不确定可以留空不偷看；只记得两三项者先修这两三项；串说不全者听同桌后自己再说一遍。
 【主视觉职责】
 四个开放检索问题
 【插图资格】
 无
 【第一人称接收】
-我刚才面对“《诗经》，我们真正记住了什么？”，留下了《诗经》五项文化修复稿；我能用原词说清自己新增或修正的理解。
+我合书写出了五项中的若干项，开书只修错空处；再合书时我能用两句话把五项连着说给同桌听。
 【故事回接】
-页面结束前由一句自然复述回到谁做了什么、人物处境怎样变化以及故事推进到哪里。
+《诗经》坐标被真正收进口袋：她的声音属于《卫风》、来自三千年前的采诗传统；知识面兜底完成，切页句转向字词回句。
 【删除损失】
 开篇文化输入未经检索，学生可能把看过冒充记住。
 【相邻反证】
-相邻页不同时处理“学生容易看见“《诗经》，我们真正记住了什么？”，却不能把它准确接回人物和前后故事。”；合并会挤掉必要首答、校准或故事回接。
+不并入S05B：文化五项是检索修复，字词是音义原句通关；同屏会使两种检索互相打断、都无法合书完成。
 【失败信号】
-学生只能复述活动手续，不能复述诗意；首答前已经看见完成关系或答案；产物在后页没有真实消费者
+首答偷看批注或同桌；教师替学生逐项报答案；串说段仍开着书
 【声明边界】V5无插图桌面候选；不声称真实课堂或学生掌握已经通过。</a:t>
             </a:r>
             <a:endParaRPr lang="en-US" dirty="0"/>
@@ -11330,45 +11330,45 @@
 文化坐标已经真正取回，接着检查六章关键字词。
 【V6.6逻辑页】S05A｜逻辑页43｜6分钟
 【前页输入】
-学生已经完成前页任务，手中保留与“《诗经》，我们真正记住了什么？”有关的原词或初稿。
+O04文化坐标已在开课给出并留在批注；五项修复稿为空；教材可翻回。
 【唯一困难】
-学生容易看见“《诗经》，我们真正记住了什么？”，却不能把它准确接回人物和前后故事。
+学生把“看过”当“记住”：开篇文化入口若无合书检索，第一部诗歌总集、305篇、年代、风雅颂与篇目归属五项可能一项也写不出。
 【唯一功能】
 检验开篇文化入口是否真正留下，并修复第一部诗歌总集、305篇、大致年代、风雅颂和篇目归属。
 【文学对象】
-《诗经》，我们真正记住了什么？
+[object Object]
 【信息状态】
 首答不显示第一部诗歌总集、305篇、年代、风雅颂和卫风答案；校准在等待以后。
 【学生主动作】
 合书完成五项文化检索；开书或看课堂批注核对，再合书串说
 【参与路径】
-个人先形成；需要交流时并行同桌或四人轮说；全班只公开少量有差异材料。
+合书五项首答125秒（封存）→开书与批注核对、本人只修错空项115秒→教师准确收束真实错项55秒→再合书同桌串说65秒。
 【可见产物】
 《诗经》五项文化修复稿
 【教师作用】
-准确释词、引用真实回答、追问原词、后置归纳并守住解释边界。
+核对段只给准确五项（首部诗歌总集、305篇、西周初年至春秋中叶、风雅颂、《卫风》）；收束只针对真实错项；不扩展新文化点。
 【真实等待】
-逐字稿内有首答等待、限定反馈和本人修订的明确时间。
+时间盒明示：合书首答125秒（不偷看）→开书修复115秒→收束55秒→合书串说65秒；首答与串说两次合书。
 【反馈与本人修订】
-学生依据原词、同伴追问或教师校准，亲自保留、补充、改写或撤回初稿。
+开书后由本人只修自己错空处；同桌串说只核五项是否说全；全对者写“五项准确，无需改”。
 【首次后用】
 S06艺术收纳和S08终读
 【正常反例】
-想不起、无新增、已经准确、不同意或暂时沉默均有诚实完成路径，不要求伪造改变。
+不确定可以留空不偷看；只记得两三项者先修这两三项；串说不全者听同桌后自己再说一遍。
 【主视觉职责】
 四个开放检索问题
 【插图资格】
 无
 【第一人称接收】
-我刚才面对“《诗经》，我们真正记住了什么？”，留下了《诗经》五项文化修复稿；我能用原词说清自己新增或修正的理解。
+我合书写出了五项中的若干项，开书只修错空处；再合书时我能用两句话把五项连着说给同桌听。
 【故事回接】
-页面结束前由一句自然复述回到谁做了什么、人物处境怎样变化以及故事推进到哪里。
+《诗经》坐标被真正收进口袋：她的声音属于《卫风》、来自三千年前的采诗传统；知识面兜底完成，切页句转向字词回句。
 【删除损失】
 开篇文化输入未经检索，学生可能把看过冒充记住。
 【相邻反证】
-相邻页不同时处理“学生容易看见“《诗经》，我们真正记住了什么？”，却不能把它准确接回人物和前后故事。”；合并会挤掉必要首答、校准或故事回接。
+不并入S05B：文化五项是检索修复，字词是音义原句通关；同屏会使两种检索互相打断、都无法合书完成。
 【失败信号】
-学生只能复述活动手续，不能复述诗意；首答前已经看见完成关系或答案；产物在后页没有真实消费者
+首答偷看批注或同桌；教师替学生逐项报答案；串说段仍开着书
 【声明边界】V5无插图桌面候选；不声称真实课堂或学生掌握已经通过。</a:t>
             </a:r>
             <a:endParaRPr lang="en-US" dirty="0"/>
@@ -11482,13 +11482,13 @@
 错空已经留下，现在打开教材逐项修。
 【V6.6逻辑页】S05B｜逻辑页44｜12分钟
 【前页输入】
-学生已经完成前页任务，手中保留与“把核心字词送回原句”有关的原词或初稿。
+六章各词已在句中学过（愆、筮、说、爽、咥、泮）；通关卡为空；教材可翻回对应句。
 【唯一困难】
-学生容易看见“把核心字词送回原句”，却不能把它准确接回人物和前后故事。
+逐句学过的字词离开原句就不认识；抽样词表会让多数人漏掉自己那一章的盲点，“全诗读通”被冒充。
 【唯一功能】
 用六章各一项全员最低门槛发现个人基础盲点，再以自选两词作加深，不让抽样词表冒充全诗读通。
 【文学对象】
-把核心字词送回原句
+匪我愆期，子无良媒,尔卜尔筮，体无咎言,士之耽兮，犹可说也,女之耽兮，不可说也,女也不爽，士贰其行,兄弟不知，咥其笑矣,淇则有岸，隰则有泮
 【信息状态】
 首答只给六个目标词和原句任务，不给读音与义；校准后再显示答案。
 【学生主动作】
@@ -11498,15 +11498,15 @@
 【可见产物】
 六章字词通关卡和两词加深稿
 【教师作用】
-准确释词、引用真实回答、追问原词、后置归纳并守住解释边界。
+微讲只针对固定样本共错项（愆拖延、筮占问、说同脱、爽差错、咥笑貌、泮同畔）；不逐项重讲；终读提醒由学生在教材对应句旁圈出。
 【真实等待】
-逐字稿内有首答等待、限定反馈和本人修订的明确时间。
+时间盒明示：合书首答210秒（不能先挑会的）→开书修复245秒→共错微讲105秒→自选加深125秒→终读提醒35秒。
 【反馈与本人修订】
-学生依据原词、同伴追问或教师校准，亲自保留、补充、改写或撤回初稿。
+开书后本人只修自己错空处并在教材句旁圈终读提醒；同桌不互批；加深稿由自选两词各自完成。
 【首次后用】
 S08终读提醒
 【正常反例】
-想不起、无新增、已经准确、不同意或暂时沉默均有诚实完成路径，不要求伪造改变。
+不会的项留空不猜；只修复错空处后直接进加深；六项全对者直接进自选两词。
 【主视觉职责】
 六章关键原句与六个最低通关空位
 【插图资格】
@@ -11514,7 +11514,7 @@
 【第一人称接收】
 我知道自己在哪一章的哪个词断过，也已经把读音和句中义修回原句。
 【故事回接】
-页面结束前由一句自然复述回到谁做了什么、人物处境怎样变化以及故事推进到哪里。
+六个字词带着读音和句中义回到原句：愆期、卜筮、脱身、差错、咥笑、水岸各归其位；终读提醒圈定，切页句转向“写法怎样改变故事”。
 【删除损失】
 个人未选词盲点无法发现，逐句讲解没有基础语义兜底。
 【相邻反证】
@@ -11634,13 +11634,13 @@
 六项已经由本人核对，下一页把准确答案完整看一遍。
 【V6.6逻辑页】S05B｜逻辑页44｜12分钟
 【前页输入】
-学生已经完成前页任务，手中保留与“把核心字词送回原句”有关的原词或初稿。
+六章各词已在句中学过（愆、筮、说、爽、咥、泮）；通关卡为空；教材可翻回对应句。
 【唯一困难】
-学生容易看见“把核心字词送回原句”，却不能把它准确接回人物和前后故事。
+逐句学过的字词离开原句就不认识；抽样词表会让多数人漏掉自己那一章的盲点，“全诗读通”被冒充。
 【唯一功能】
 用六章各一项全员最低门槛发现个人基础盲点，再以自选两词作加深，不让抽样词表冒充全诗读通。
 【文学对象】
-把核心字词送回原句
+匪我愆期，子无良媒,尔卜尔筮，体无咎言,士之耽兮，犹可说也,女之耽兮，不可说也,女也不爽，士贰其行,兄弟不知，咥其笑矣,淇则有岸，隰则有泮
 【信息状态】
 首答只给六个目标词和原句任务，不给读音与义；校准后再显示答案。
 【学生主动作】
@@ -11650,15 +11650,15 @@
 【可见产物】
 六章字词通关卡和两词加深稿
 【教师作用】
-准确释词、引用真实回答、追问原词、后置归纳并守住解释边界。
+微讲只针对固定样本共错项（愆拖延、筮占问、说同脱、爽差错、咥笑貌、泮同畔）；不逐项重讲；终读提醒由学生在教材对应句旁圈出。
 【真实等待】
-逐字稿内有首答等待、限定反馈和本人修订的明确时间。
+时间盒明示：合书首答210秒（不能先挑会的）→开书修复245秒→共错微讲105秒→自选加深125秒→终读提醒35秒。
 【反馈与本人修订】
-学生依据原词、同伴追问或教师校准，亲自保留、补充、改写或撤回初稿。
+开书后本人只修自己错空处并在教材句旁圈终读提醒；同桌不互批；加深稿由自选两词各自完成。
 【首次后用】
 S08终读提醒
 【正常反例】
-想不起、无新增、已经准确、不同意或暂时沉默均有诚实完成路径，不要求伪造改变。
+不会的项留空不猜；只修复错空处后直接进加深；六项全对者直接进自选两词。
 【主视觉职责】
 六章关键原句与六个最低通关空位
 【插图资格】
@@ -11666,7 +11666,7 @@
 【第一人称接收】
 我知道自己在哪一章的哪个词断过，也已经把读音和句中义修回原句。
 【故事回接】
-页面结束前由一句自然复述回到谁做了什么、人物处境怎样变化以及故事推进到哪里。
+六个字词带着读音和句中义回到原句：愆期、卜筮、脱身、差错、咥笑、水岸各归其位；终读提醒圈定，切页句转向“写法怎样改变故事”。
 【删除损失】
 个人未选词盲点无法发现，逐句讲解没有基础语义兜底。
 【相邻反证】
@@ -11786,13 +11786,13 @@
 字词已经回到六章，最后看这些句子怎样共同写成一首诗。
 【V6.6逻辑页】S05B｜逻辑页44｜12分钟
 【前页输入】
-学生已经完成前页任务，手中保留与“把核心字词送回原句”有关的原词或初稿。
+六章各词已在句中学过（愆、筮、说、爽、咥、泮）；通关卡为空；教材可翻回对应句。
 【唯一困难】
-学生容易看见“把核心字词送回原句”，却不能把它准确接回人物和前后故事。
+逐句学过的字词离开原句就不认识；抽样词表会让多数人漏掉自己那一章的盲点，“全诗读通”被冒充。
 【唯一功能】
 用六章各一项全员最低门槛发现个人基础盲点，再以自选两词作加深，不让抽样词表冒充全诗读通。
 【文学对象】
-把核心字词送回原句
+匪我愆期，子无良媒,尔卜尔筮，体无咎言,士之耽兮，犹可说也,女之耽兮，不可说也,女也不爽，士贰其行,兄弟不知，咥其笑矣,淇则有岸，隰则有泮
 【信息状态】
 首答只给六个目标词和原句任务，不给读音与义；校准后再显示答案。
 【学生主动作】
@@ -11802,15 +11802,15 @@
 【可见产物】
 六章字词通关卡和两词加深稿
 【教师作用】
-准确释词、引用真实回答、追问原词、后置归纳并守住解释边界。
+微讲只针对固定样本共错项（愆拖延、筮占问、说同脱、爽差错、咥笑貌、泮同畔）；不逐项重讲；终读提醒由学生在教材对应句旁圈出。
 【真实等待】
-逐字稿内有首答等待、限定反馈和本人修订的明确时间。
+时间盒明示：合书首答210秒（不能先挑会的）→开书修复245秒→共错微讲105秒→自选加深125秒→终读提醒35秒。
 【反馈与本人修订】
-学生依据原词、同伴追问或教师校准，亲自保留、补充、改写或撤回初稿。
+开书后本人只修自己错空处并在教材句旁圈终读提醒；同桌不互批；加深稿由自选两词各自完成。
 【首次后用】
 S08终读提醒
 【正常反例】
-想不起、无新增、已经准确、不同意或暂时沉默均有诚实完成路径，不要求伪造改变。
+不会的项留空不猜；只修复错空处后直接进加深；六项全对者直接进自选两词。
 【主视觉职责】
 六章关键原句与六个最低通关空位
 【插图资格】
@@ -11818,7 +11818,7 @@
 【第一人称接收】
 我知道自己在哪一章的哪个词断过，也已经把读音和句中义修回原句。
 【故事回接】
-页面结束前由一句自然复述回到谁做了什么、人物处境怎样变化以及故事推进到哪里。
+六个字词带着读音和句中义回到原句：愆期、卜筮、脱身、差错、咥笑、水岸各归其位；终读提醒圈定，切页句转向“写法怎样改变故事”。
 【删除损失】
 个人未选词盲点无法发现，逐句讲解没有基础语义兜底。
 【相邻反证】
@@ -11938,45 +11938,45 @@
 分法已经各不相同，下一页只比较真实出现的分组。
 【V6.6逻辑页】S06｜逻辑页45｜15分钟
 【前页输入】
-学生已经完成前页任务，手中保留与“桑叶沃若/黄而陨、两声于嗟由斑鸠到女子、信誓/反/不思在末章回来的三组原句”有关的原词或初稿。
+四类材料都已读过（六章事件、桑叶与鸠女句、两个老与两个反及淇水复现、涟涟汤汤晏晏旦旦）；随机散卡未分组；术语未命名。
 【唯一困难】
-学生容易看见“桑叶沃若/黄而陨、两声于嗟由斑鸠到女子、信誓/反/不思在末章回来的三组原句”，却不能把它准确接回人物和前后故事。
+学生会报比兴、对照、反复、回环等术语，却不能说明原词关系怎样改变声音、时间与人物处境；“生动形象、表达感情”成为终点。
 【唯一功能】
 把逐句体验收成叙事推进、桑叶比兴与对照、词句复现反折、四言叠词与声音四类知识，并说明写法怎样改变人物故事。
 【文学对象】
-桑叶沃若/黄而陨、两声于嗟由斑鸠到女子、信誓/反/不思在末章回来的三组原句
+[object Object]
 【信息状态】
 只给知识检索类别，不给代表原句和作用答案；教师术语提升在小组补例以后。
 【学生主动作】
 面对随机散卡自行分组；比较黑板分法后由教师命名；每人完成四类识别并自选两类深做
 【参与路径】
-个人先形成；需要交流时并行同桌或四人轮说；全班只公开少量有差异材料。
+无术语例句观察与个人分组238秒→四组各写一种分法上黑板187秒→全班比较学生分法125秒→教师后置命名与准确提升144秒→个人两类说明与返诗修订206秒。
 【可见产物】
 个人随机分组、教师后置知识图、四类最低识别和个人两类深做
 【教师作用】
-准确释词、引用真实回答、追问原词、后置归纳并守住解释边界。
+后置命名四类（叙事推进／桑叶比兴与对照／复现回环反折／四言叠词与声音）；不接受空泛作用；提升只加准确不加术语堆叠。
 【真实等待】
-逐字稿内有首答等待、限定反馈和本人修订的明确时间。
+时间盒明示：个人分组238秒（零术语）→黑板分法187秒→全班比较125秒→后置命名144秒→个人说明返诗206秒。
 【反馈与本人修订】
-学生依据原词、同伴追问或教师校准，亲自保留、补充、改写或撤回初稿。
+同桌只指出哪两个原词没有形成所说关系、作用是否回到人物；作者把空泛作用改为桑叶荣枯把关系盛衰置于时间、两声于嗟让劝告由物抵达人、反与不思回环让旧誓在结尾受核验。
 【首次后用】
 S08带走一处语言发现
 【正常反例】
-想不起、无新增、已经准确、不同意或暂时沉默均有诚实完成路径，不要求伪造改变。
+术语一时想不起者先准确写原词关系与人物变化；短卡已经准确者写“迁移成立，保留”不强制修改。
 【主视觉职责】
 关系线与原词
 【插图资格】
 无
 【第一人称接收】
-我刚才面对“桑叶沃若/黄而陨、两声于嗟由斑鸠到女子、信誓/反/不思在末章回来的三组原句”，留下了个人随机分组、教师后置知识图、四类最低识别和个人两类深做；我能用原词说清自己新增或修正的理解。
+我在无术语状态下把两组材料放在一起并写出它们怎样改变声音或处境；教师命名后我能用其中一类解释一处原词关系。
 【故事回接】
-页面结束前由一句自然复述回到谁做了什么、人物处境怎样变化以及故事推进到哪里。
+写法回到她的故事：六章推进她的时间，桑叶照见盛衰，复现让旧誓受核验，叠词让她的声音可闻；四类知识各归一处原句，切页句指向个人收束。
 【删除损失】
 删除会使知识只散落在活动里
 【相邻反证】
-相邻页不同时处理“学生容易看见“桑叶沃若/黄而陨、两声于嗟由斑鸠到女子、信誓/反/不思在末章回来的三组原句”，却不能把它准确接回人物和前后故事。”；合并会挤掉必要首答、校准或故事回接。
+不并入S07：本页仍在生成与互证形式解释，S07撤去原句群后只做个人收束与自我检索；合并会让命名失去比较底子。
 【失败信号】
-学生只能复述活动手续，不能复述诗意；首答前已经看见完成关系或答案；产物在后页没有真实消费者
+分组直接抄术语标签；作用只写生动形象；命名先于学生分法
 【声明边界】V5无插图桌面候选；不声称真实课堂或学生掌握已经通过。</a:t>
             </a:r>
             <a:endParaRPr lang="en-US" dirty="0"/>
@@ -12090,45 +12090,45 @@
 你们已经从原句中看见关系，下一页再用准确术语命名。
 【V6.6逻辑页】S06｜逻辑页45｜15分钟
 【前页输入】
-学生已经完成前页任务，手中保留与“桑叶沃若/黄而陨、两声于嗟由斑鸠到女子、信誓/反/不思在末章回来的三组原句”有关的原词或初稿。
+四类材料都已读过（六章事件、桑叶与鸠女句、两个老与两个反及淇水复现、涟涟汤汤晏晏旦旦）；随机散卡未分组；术语未命名。
 【唯一困难】
-学生容易看见“桑叶沃若/黄而陨、两声于嗟由斑鸠到女子、信誓/反/不思在末章回来的三组原句”，却不能把它准确接回人物和前后故事。
+学生会报比兴、对照、反复、回环等术语，却不能说明原词关系怎样改变声音、时间与人物处境；“生动形象、表达感情”成为终点。
 【唯一功能】
 把逐句体验收成叙事推进、桑叶比兴与对照、词句复现反折、四言叠词与声音四类知识，并说明写法怎样改变人物故事。
 【文学对象】
-桑叶沃若/黄而陨、两声于嗟由斑鸠到女子、信誓/反/不思在末章回来的三组原句
+[object Object]
 【信息状态】
 只给知识检索类别，不给代表原句和作用答案；教师术语提升在小组补例以后。
 【学生主动作】
 面对随机散卡自行分组；比较黑板分法后由教师命名；每人完成四类识别并自选两类深做
 【参与路径】
-个人先形成；需要交流时并行同桌或四人轮说；全班只公开少量有差异材料。
+无术语例句观察与个人分组238秒→四组各写一种分法上黑板187秒→全班比较学生分法125秒→教师后置命名与准确提升144秒→个人两类说明与返诗修订206秒。
 【可见产物】
 个人随机分组、教师后置知识图、四类最低识别和个人两类深做
 【教师作用】
-准确释词、引用真实回答、追问原词、后置归纳并守住解释边界。
+后置命名四类（叙事推进／桑叶比兴与对照／复现回环反折／四言叠词与声音）；不接受空泛作用；提升只加准确不加术语堆叠。
 【真实等待】
-逐字稿内有首答等待、限定反馈和本人修订的明确时间。
+时间盒明示：个人分组238秒（零术语）→黑板分法187秒→全班比较125秒→后置命名144秒→个人说明返诗206秒。
 【反馈与本人修订】
-学生依据原词、同伴追问或教师校准，亲自保留、补充、改写或撤回初稿。
+同桌只指出哪两个原词没有形成所说关系、作用是否回到人物；作者把空泛作用改为桑叶荣枯把关系盛衰置于时间、两声于嗟让劝告由物抵达人、反与不思回环让旧誓在结尾受核验。
 【首次后用】
 S08带走一处语言发现
 【正常反例】
-想不起、无新增、已经准确、不同意或暂时沉默均有诚实完成路径，不要求伪造改变。
+术语一时想不起者先准确写原词关系与人物变化；短卡已经准确者写“迁移成立，保留”不强制修改。
 【主视觉职责】
 关系线与原词
 【插图资格】
 无
 【第一人称接收】
-我刚才面对“桑叶沃若/黄而陨、两声于嗟由斑鸠到女子、信誓/反/不思在末章回来的三组原句”，留下了个人随机分组、教师后置知识图、四类最低识别和个人两类深做；我能用原词说清自己新增或修正的理解。
+我在无术语状态下把两组材料放在一起并写出它们怎样改变声音或处境；教师命名后我能用其中一类解释一处原词关系。
 【故事回接】
-页面结束前由一句自然复述回到谁做了什么、人物处境怎样变化以及故事推进到哪里。
+写法回到她的故事：六章推进她的时间，桑叶照见盛衰，复现让旧誓受核验，叠词让她的声音可闻；四类知识各归一处原句，切页句指向个人收束。
 【删除损失】
 删除会使知识只散落在活动里
 【相邻反证】
-相邻页不同时处理“学生容易看见“桑叶沃若/黄而陨、两声于嗟由斑鸠到女子、信誓/反/不思在末章回来的三组原句”，却不能把它准确接回人物和前后故事。”；合并会挤掉必要首答、校准或故事回接。
+不并入S07：本页仍在生成与互证形式解释，S07撤去原句群后只做个人收束与自我检索；合并会让命名失去比较底子。
 【失败信号】
-学生只能复述活动手续，不能复述诗意；首答前已经看见完成关系或答案；产物在后页没有真实消费者
+分组直接抄术语标签；作用只写生动形象；命名先于学生分法
 【声明边界】V5无插图桌面候选；不声称真实课堂或学生掌握已经通过。</a:t>
             </a:r>
             <a:endParaRPr lang="en-US" dirty="0"/>
@@ -12242,45 +12242,45 @@
 术语已经看过，下一页撤去教师例子，检验每个人是否真正拥有。
 【V6.6逻辑页】S06｜逻辑页45｜15分钟
 【前页输入】
-学生已经完成前页任务，手中保留与“桑叶沃若/黄而陨、两声于嗟由斑鸠到女子、信誓/反/不思在末章回来的三组原句”有关的原词或初稿。
+四类材料都已读过（六章事件、桑叶与鸠女句、两个老与两个反及淇水复现、涟涟汤汤晏晏旦旦）；随机散卡未分组；术语未命名。
 【唯一困难】
-学生容易看见“桑叶沃若/黄而陨、两声于嗟由斑鸠到女子、信誓/反/不思在末章回来的三组原句”，却不能把它准确接回人物和前后故事。
+学生会报比兴、对照、反复、回环等术语，却不能说明原词关系怎样改变声音、时间与人物处境；“生动形象、表达感情”成为终点。
 【唯一功能】
 把逐句体验收成叙事推进、桑叶比兴与对照、词句复现反折、四言叠词与声音四类知识，并说明写法怎样改变人物故事。
 【文学对象】
-桑叶沃若/黄而陨、两声于嗟由斑鸠到女子、信誓/反/不思在末章回来的三组原句
+[object Object]
 【信息状态】
 只给知识检索类别，不给代表原句和作用答案；教师术语提升在小组补例以后。
 【学生主动作】
 面对随机散卡自行分组；比较黑板分法后由教师命名；每人完成四类识别并自选两类深做
 【参与路径】
-个人先形成；需要交流时并行同桌或四人轮说；全班只公开少量有差异材料。
+无术语例句观察与个人分组238秒→四组各写一种分法上黑板187秒→全班比较学生分法125秒→教师后置命名与准确提升144秒→个人两类说明与返诗修订206秒。
 【可见产物】
 个人随机分组、教师后置知识图、四类最低识别和个人两类深做
 【教师作用】
-准确释词、引用真实回答、追问原词、后置归纳并守住解释边界。
+后置命名四类（叙事推进／桑叶比兴与对照／复现回环反折／四言叠词与声音）；不接受空泛作用；提升只加准确不加术语堆叠。
 【真实等待】
-逐字稿内有首答等待、限定反馈和本人修订的明确时间。
+时间盒明示：个人分组238秒（零术语）→黑板分法187秒→全班比较125秒→后置命名144秒→个人说明返诗206秒。
 【反馈与本人修订】
-学生依据原词、同伴追问或教师校准，亲自保留、补充、改写或撤回初稿。
+同桌只指出哪两个原词没有形成所说关系、作用是否回到人物；作者把空泛作用改为桑叶荣枯把关系盛衰置于时间、两声于嗟让劝告由物抵达人、反与不思回环让旧誓在结尾受核验。
 【首次后用】
 S08带走一处语言发现
 【正常反例】
-想不起、无新增、已经准确、不同意或暂时沉默均有诚实完成路径，不要求伪造改变。
+术语一时想不起者先准确写原词关系与人物变化；短卡已经准确者写“迁移成立，保留”不强制修改。
 【主视觉职责】
 关系线与原词
 【插图资格】
 无
 【第一人称接收】
-我刚才面对“桑叶沃若/黄而陨、两声于嗟由斑鸠到女子、信誓/反/不思在末章回来的三组原句”，留下了个人随机分组、教师后置知识图、四类最低识别和个人两类深做；我能用原词说清自己新增或修正的理解。
+我在无术语状态下把两组材料放在一起并写出它们怎样改变声音或处境；教师命名后我能用其中一类解释一处原词关系。
 【故事回接】
-页面结束前由一句自然复述回到谁做了什么、人物处境怎样变化以及故事推进到哪里。
+写法回到她的故事：六章推进她的时间，桑叶照见盛衰，复现让旧誓受核验，叠词让她的声音可闻；四类知识各归一处原句，切页句指向个人收束。
 【删除损失】
 删除会使知识只散落在活动里
 【相邻反证】
-相邻页不同时处理“学生容易看见“桑叶沃若/黄而陨、两声于嗟由斑鸠到女子、信誓/反/不思在末章回来的三组原句”，却不能把它准确接回人物和前后故事。”；合并会挤掉必要首答、校准或故事回接。
+不并入S07：本页仍在生成与互证形式解释，S07撤去原句群后只做个人收束与自我检索；合并会让命名失去比较底子。
 【失败信号】
-学生只能复述活动手续，不能复述诗意；首答前已经看见完成关系或答案；产物在后页没有真实消费者
+分组直接抄术语标签；作用只写生动形象；命名先于学生分法
 【声明边界】V5无插图桌面候选；不声称真实课堂或学生掌握已经通过。</a:t>
             </a:r>
             <a:endParaRPr lang="en-US" dirty="0"/>
@@ -12400,7 +12400,7 @@
 【唯一功能】
 无缝接收第四至六章并让末句落下。
 【文学对象】
-《氓》第四至第六章的完整声音及全诗结尾
+桑之落矣，其黄而陨,自我徂尔，三岁食贫,淇水汤汤，渐车帷裳,女也不爽，士贰其行,士也罔极，二三其德,三岁为妇，靡室劳矣,夙兴夜寐，靡有朝矣,言既遂矣，至于暴矣,兄弟不知，咥其笑矣,静言思之，躬自悼矣,及尔偕老，老使我怨,淇则有岸，隰则有泮,总角之宴，言笑晏晏,信誓旦旦，不思其反,反是不思，亦已焉哉
 【信息状态】
 只继续暴露原诗，末句后保持十五秒无解释静默。
 【学生主动作】
@@ -12546,45 +12546,45 @@
 文化、字词和诗法都已收回原诗。最后让《氓》完整响起。
 【V6.6逻辑页】S06｜逻辑页45｜15分钟
 【前页输入】
-学生已经完成前页任务，手中保留与“桑叶沃若/黄而陨、两声于嗟由斑鸠到女子、信誓/反/不思在末章回来的三组原句”有关的原词或初稿。
+四类材料都已读过（六章事件、桑叶与鸠女句、两个老与两个反及淇水复现、涟涟汤汤晏晏旦旦）；随机散卡未分组；术语未命名。
 【唯一困难】
-学生容易看见“桑叶沃若/黄而陨、两声于嗟由斑鸠到女子、信誓/反/不思在末章回来的三组原句”，却不能把它准确接回人物和前后故事。
+学生会报比兴、对照、反复、回环等术语，却不能说明原词关系怎样改变声音、时间与人物处境；“生动形象、表达感情”成为终点。
 【唯一功能】
 把逐句体验收成叙事推进、桑叶比兴与对照、词句复现反折、四言叠词与声音四类知识，并说明写法怎样改变人物故事。
 【文学对象】
-桑叶沃若/黄而陨、两声于嗟由斑鸠到女子、信誓/反/不思在末章回来的三组原句
+[object Object]
 【信息状态】
 只给知识检索类别，不给代表原句和作用答案；教师术语提升在小组补例以后。
 【学生主动作】
 面对随机散卡自行分组；比较黑板分法后由教师命名；每人完成四类识别并自选两类深做
 【参与路径】
-个人先形成；需要交流时并行同桌或四人轮说；全班只公开少量有差异材料。
+无术语例句观察与个人分组238秒→四组各写一种分法上黑板187秒→全班比较学生分法125秒→教师后置命名与准确提升144秒→个人两类说明与返诗修订206秒。
 【可见产物】
 个人随机分组、教师后置知识图、四类最低识别和个人两类深做
 【教师作用】
-准确释词、引用真实回答、追问原词、后置归纳并守住解释边界。
+后置命名四类（叙事推进／桑叶比兴与对照／复现回环反折／四言叠词与声音）；不接受空泛作用；提升只加准确不加术语堆叠。
 【真实等待】
-逐字稿内有首答等待、限定反馈和本人修订的明确时间。
+时间盒明示：个人分组238秒（零术语）→黑板分法187秒→全班比较125秒→后置命名144秒→个人说明返诗206秒。
 【反馈与本人修订】
-学生依据原词、同伴追问或教师校准，亲自保留、补充、改写或撤回初稿。
+同桌只指出哪两个原词没有形成所说关系、作用是否回到人物；作者把空泛作用改为桑叶荣枯把关系盛衰置于时间、两声于嗟让劝告由物抵达人、反与不思回环让旧誓在结尾受核验。
 【首次后用】
 S08带走一处语言发现
 【正常反例】
-想不起、无新增、已经准确、不同意或暂时沉默均有诚实完成路径，不要求伪造改变。
+术语一时想不起者先准确写原词关系与人物变化；短卡已经准确者写“迁移成立，保留”不强制修改。
 【主视觉职责】
 关系线与原词
 【插图资格】
 无
 【第一人称接收】
-我刚才面对“桑叶沃若/黄而陨、两声于嗟由斑鸠到女子、信誓/反/不思在末章回来的三组原句”，留下了个人随机分组、教师后置知识图、四类最低识别和个人两类深做；我能用原词说清自己新增或修正的理解。
+我在无术语状态下把两组材料放在一起并写出它们怎样改变声音或处境；教师命名后我能用其中一类解释一处原词关系。
 【故事回接】
-页面结束前由一句自然复述回到谁做了什么、人物处境怎样变化以及故事推进到哪里。
+写法回到她的故事：六章推进她的时间，桑叶照见盛衰，复现让旧誓受核验，叠词让她的声音可闻；四类知识各归一处原句，切页句指向个人收束。
 【删除损失】
 删除会使知识只散落在活动里
 【相邻反证】
-相邻页不同时处理“学生容易看见“桑叶沃若/黄而陨、两声于嗟由斑鸠到女子、信誓/反/不思在末章回来的三组原句”，却不能把它准确接回人物和前后故事。”；合并会挤掉必要首答、校准或故事回接。
+不并入S07：本页仍在生成与互证形式解释，S07撤去原句群后只做个人收束与自我检索；合并会让命名失去比较底子。
 【失败信号】
-学生只能复述活动手续，不能复述诗意；首答前已经看见完成关系或答案；产物在后页没有真实消费者
+分组直接抄术语标签；作用只写生动形象；命名先于学生分法
 【声明边界】V5无插图桌面候选；不声称真实课堂或学生掌握已经通过。</a:t>
             </a:r>
             <a:endParaRPr lang="en-US" dirty="0"/>
@@ -12700,27 +12700,27 @@
 （末句后保持安静，不再切入新的结论页。）
 【V6.6逻辑页】S08｜逻辑页46｜7分钟
 【前页输入】
-学生已经完成前页任务，手中保留与“S01—S04的个人答案、S07知识清单、《氓》全文及学生仍愿保留的真实问题”有关的原词或初稿。
+批注、六章长卷、关系卡与字词终读提醒都在手边；个人终课句为空；全诗自O06后未再完整朗读。
 【唯一困难】
-学生容易看见“S01—S04的个人答案、S07知识清单、《氓》全文及学生仍愿保留的真实问题”，却不能把它准确接回人物和前后故事。
+全课产物丰富但须由每名学生亲自浓缩；终页若塞进知识测验或教师口号，人物、关系理解与完整声音都会被压扁。
 【唯一功能】
 每人只留下一个改变或问题，再让全诗完整响起并安静结束。
 【文学对象】
-S01—S04的个人答案、S07知识清单、《氓》全文及学生仍愿保留的真实问题
+[object Object]
 【信息状态】
-首答前只给原诗、必要字面和一个自然问题；解释、分类、关系与代表答案在学生首稿后出现。
+三选一出口（改变最大的理解／最想带走的语言发现／仍愿追问的问题）只写一句真话；屏幕降暗后只剩全文与六个提醒；末句后真实静默。
 【学生主动作】
 三选一留下真实终课句；至少180秒完整朗读
 【参与路径】
-个人先形成；需要交流时并行同桌或四人轮说；全班只公开少量有差异材料。
+三选一个人终课句105秒→少量真实分享75秒→从“氓之蚩蚩”到“亦已焉哉”完整终读210秒→末句静默15秒→自然收束15秒。
 【可见产物】
 个人终课句和完整终读
 【教师作用】
-准确释词、引用真实回答、追问原词、后置归纳并守住解释边界。
+只引用三种不同收束并确认事实边界（伤害责任与停止困难分开、实际离开降回停止判断）；不再增加新结论，解释权交回朗读。
 【真实等待】
-逐字稿内有首答等待、限定反馈和本人修订的明确时间。
+时间盒明示：终课句105秒（三选一不必填满）→分享75秒→完整终读210秒（不停顿分析）→静默15秒→收束15秒。
 【反馈与本人修订】
-学生依据原词、同伴追问或教师校准，亲自保留、补充、改写或撤回初稿。
+同桌只核一个事实边界，不统一婚姻观与最爱诗句；作者补原句、分开责任与困难、把“她已离开”降回“停止判断”；真实问题允许保留。
 【首次后用】
 真实试教评估
 【正常反例】
@@ -12730,15 +12730,15 @@
 【插图资格】
 无
 【第一人称接收】
-我刚才面对“S01—S04的个人答案、S07知识清单、《氓》全文及学生仍愿保留的真实问题”，留下了个人终课句和完整终读；我能用原词说清自己新增或修正的理解。
+我从三选一写下一句真实的终课句；终读经过我圈的提醒处时我把音义读稳，最想带走的那处我的声音自然慢了一点。
 【故事回接】
-页面结束前由一句自然复述回到谁做了什么、人物处境怎样变化以及故事推进到哪里。
+全诗完整响起并安静结束：她从抱布贸丝走到亦已焉哉；三问、支点与带走的那句话一起留在学生手里，课堂账待真实试教填写。
 【删除损失】
 删除会失去个人出口和整体声音
 【相邻反证】
-相邻页不同时处理“学生容易看见“S01—S04的个人答案、S07知识清单、《氓》全文及学生仍愿保留的真实问题”，却不能把它准确接回人物和前后故事。”；合并会挤掉必要首答、校准或故事回接。
+不并入S07：S07收束字词、写法与边界，S08回到人物三问与关系理解并完成整诗朗读；合并将终页再次过载。
 【失败信号】
-学生只能复述活动手续，不能复述诗意；首答前已经看见完成关系或答案；产物在后页没有真实消费者
+终页变成知识测验；教师以口号收尾；末句后立即布置作业无静默
 【声明边界】V5无插图桌面候选；不声称真实课堂或学生掌握已经通过。</a:t>
             </a:r>
             <a:endParaRPr lang="en-US" dirty="0"/>
@@ -12858,7 +12858,7 @@
 【唯一功能】
 无缝接收第四至六章并让末句落下。
 【文学对象】
-《氓》第四至第六章的完整声音及全诗结尾
+桑之落矣，其黄而陨,自我徂尔，三岁食贫,淇水汤汤，渐车帷裳,女也不爽，士贰其行,士也罔极，二三其德,三岁为妇，靡室劳矣,夙兴夜寐，靡有朝矣,言既遂矣，至于暴矣,兄弟不知，咥其笑矣,静言思之，躬自悼矣,及尔偕老，老使我怨,淇则有岸，隰则有泮,总角之宴，言笑晏晏,信誓旦旦，不思其反,反是不思，亦已焉哉
 【信息状态】
 只继续暴露原诗，末句后保持十五秒无解释静默。
 【学生主动作】

</xml_diff>